<commit_message>
OSG Smart Guide deck: knowledge-graph cover, aligned slide titles, footnotes to OSG AI Assistant Banking, exec-summary 326 products & promos tile; repo now holds only the pptx
</commit_message>
<xml_diff>
--- a/OSG-Smart-Guide.pptx
+++ b/OSG-Smart-Guide.pptx
@@ -3198,16 +3198,2354 @@
           </a:p>
         </p:txBody>
       </p:sp>
-      <p:sp>
-        <p:nvSpPr>
-          <p:cNvPr id="4" name="TextBox 3"/>
+      <p:cxnSp>
+        <p:nvCxnSpPr>
+          <p:cNvPr id="4" name="Connector 3"/>
+          <p:cNvCxnSpPr/>
+          <p:nvPr/>
+        </p:nvCxnSpPr>
+        <p:spPr>
+          <a:xfrm flipH="1" flipV="1">
+            <a:off x="6720840" y="1188720"/>
+            <a:ext cx="2011680" cy="822960"/>
+          </a:xfrm>
+          <a:prstGeom prst="line">
+            <a:avLst/>
+          </a:prstGeom>
+          <a:ln w="9525">
+            <a:solidFill>
+              <a:srgbClr val="4A9384"/>
+            </a:solidFill>
+          </a:ln>
+          <a:effectLst/>
+        </p:spPr>
+        <p:style>
+          <a:lnRef idx="2">
+            <a:schemeClr val="accent1"/>
+          </a:lnRef>
+          <a:fillRef idx="0">
+            <a:schemeClr val="accent1"/>
+          </a:fillRef>
+          <a:effectRef idx="1">
+            <a:schemeClr val="accent1"/>
+          </a:effectRef>
+          <a:fontRef idx="minor">
+            <a:schemeClr val="tx1"/>
+          </a:fontRef>
+        </p:style>
+      </p:cxnSp>
+      <p:cxnSp>
+        <p:nvCxnSpPr>
+          <p:cNvPr id="5" name="Connector 4"/>
+          <p:cNvCxnSpPr/>
+          <p:nvPr/>
+        </p:nvCxnSpPr>
+        <p:spPr>
+          <a:xfrm flipH="1" flipV="1">
+            <a:off x="7955279" y="841248"/>
+            <a:ext cx="777241" cy="1170432"/>
+          </a:xfrm>
+          <a:prstGeom prst="line">
+            <a:avLst/>
+          </a:prstGeom>
+          <a:ln w="9525">
+            <a:solidFill>
+              <a:srgbClr val="4A9384"/>
+            </a:solidFill>
+          </a:ln>
+          <a:effectLst/>
+        </p:spPr>
+        <p:style>
+          <a:lnRef idx="2">
+            <a:schemeClr val="accent1"/>
+          </a:lnRef>
+          <a:fillRef idx="0">
+            <a:schemeClr val="accent1"/>
+          </a:fillRef>
+          <a:effectRef idx="1">
+            <a:schemeClr val="accent1"/>
+          </a:effectRef>
+          <a:fontRef idx="minor">
+            <a:schemeClr val="tx1"/>
+          </a:fontRef>
+        </p:style>
+      </p:cxnSp>
+      <p:cxnSp>
+        <p:nvCxnSpPr>
+          <p:cNvPr id="6" name="Connector 5"/>
+          <p:cNvCxnSpPr/>
+          <p:nvPr/>
+        </p:nvCxnSpPr>
+        <p:spPr>
+          <a:xfrm flipV="1">
+            <a:off x="8732520" y="1234440"/>
+            <a:ext cx="1188720" cy="777240"/>
+          </a:xfrm>
+          <a:prstGeom prst="line">
+            <a:avLst/>
+          </a:prstGeom>
+          <a:ln w="9525">
+            <a:solidFill>
+              <a:srgbClr val="4A9384"/>
+            </a:solidFill>
+          </a:ln>
+          <a:effectLst/>
+        </p:spPr>
+        <p:style>
+          <a:lnRef idx="2">
+            <a:schemeClr val="accent1"/>
+          </a:lnRef>
+          <a:fillRef idx="0">
+            <a:schemeClr val="accent1"/>
+          </a:fillRef>
+          <a:effectRef idx="1">
+            <a:schemeClr val="accent1"/>
+          </a:effectRef>
+          <a:fontRef idx="minor">
+            <a:schemeClr val="tx1"/>
+          </a:fontRef>
+        </p:style>
+      </p:cxnSp>
+      <p:cxnSp>
+        <p:nvCxnSpPr>
+          <p:cNvPr id="7" name="Connector 6"/>
+          <p:cNvCxnSpPr/>
+          <p:nvPr/>
+        </p:nvCxnSpPr>
+        <p:spPr>
+          <a:xfrm flipH="1">
+            <a:off x="7726679" y="2011680"/>
+            <a:ext cx="1005841" cy="914400"/>
+          </a:xfrm>
+          <a:prstGeom prst="line">
+            <a:avLst/>
+          </a:prstGeom>
+          <a:ln w="9525">
+            <a:solidFill>
+              <a:srgbClr val="4A9384"/>
+            </a:solidFill>
+          </a:ln>
+          <a:effectLst/>
+        </p:spPr>
+        <p:style>
+          <a:lnRef idx="2">
+            <a:schemeClr val="accent1"/>
+          </a:lnRef>
+          <a:fillRef idx="0">
+            <a:schemeClr val="accent1"/>
+          </a:fillRef>
+          <a:effectRef idx="1">
+            <a:schemeClr val="accent1"/>
+          </a:effectRef>
+          <a:fontRef idx="minor">
+            <a:schemeClr val="tx1"/>
+          </a:fontRef>
+        </p:style>
+      </p:cxnSp>
+      <p:cxnSp>
+        <p:nvCxnSpPr>
+          <p:cNvPr id="8" name="Connector 7"/>
+          <p:cNvCxnSpPr/>
+          <p:nvPr/>
+        </p:nvCxnSpPr>
+        <p:spPr>
+          <a:xfrm>
+            <a:off x="8732520" y="2011680"/>
+            <a:ext cx="822960" cy="685800"/>
+          </a:xfrm>
+          <a:prstGeom prst="line">
+            <a:avLst/>
+          </a:prstGeom>
+          <a:ln w="9525">
+            <a:solidFill>
+              <a:srgbClr val="4A9384"/>
+            </a:solidFill>
+          </a:ln>
+          <a:effectLst/>
+        </p:spPr>
+        <p:style>
+          <a:lnRef idx="2">
+            <a:schemeClr val="accent1"/>
+          </a:lnRef>
+          <a:fillRef idx="0">
+            <a:schemeClr val="accent1"/>
+          </a:fillRef>
+          <a:effectRef idx="1">
+            <a:schemeClr val="accent1"/>
+          </a:effectRef>
+          <a:fontRef idx="minor">
+            <a:schemeClr val="tx1"/>
+          </a:fontRef>
+        </p:style>
+      </p:cxnSp>
+      <p:cxnSp>
+        <p:nvCxnSpPr>
+          <p:cNvPr id="9" name="Connector 8"/>
+          <p:cNvCxnSpPr/>
+          <p:nvPr/>
+        </p:nvCxnSpPr>
+        <p:spPr>
+          <a:xfrm flipH="1" flipV="1">
+            <a:off x="7452360" y="1920240"/>
+            <a:ext cx="1280160" cy="91440"/>
+          </a:xfrm>
+          <a:prstGeom prst="line">
+            <a:avLst/>
+          </a:prstGeom>
+          <a:ln w="9525">
+            <a:solidFill>
+              <a:srgbClr val="4A9384"/>
+            </a:solidFill>
+          </a:ln>
+          <a:effectLst/>
+        </p:spPr>
+        <p:style>
+          <a:lnRef idx="2">
+            <a:schemeClr val="accent1"/>
+          </a:lnRef>
+          <a:fillRef idx="0">
+            <a:schemeClr val="accent1"/>
+          </a:fillRef>
+          <a:effectRef idx="1">
+            <a:schemeClr val="accent1"/>
+          </a:effectRef>
+          <a:fontRef idx="minor">
+            <a:schemeClr val="tx1"/>
+          </a:fontRef>
+        </p:style>
+      </p:cxnSp>
+      <p:cxnSp>
+        <p:nvCxnSpPr>
+          <p:cNvPr id="10" name="Connector 9"/>
+          <p:cNvCxnSpPr/>
+          <p:nvPr/>
+        </p:nvCxnSpPr>
+        <p:spPr>
+          <a:xfrm flipH="1">
+            <a:off x="7040880" y="2011680"/>
+            <a:ext cx="1691640" cy="1920240"/>
+          </a:xfrm>
+          <a:prstGeom prst="line">
+            <a:avLst/>
+          </a:prstGeom>
+          <a:ln w="9525">
+            <a:solidFill>
+              <a:srgbClr val="4A9384"/>
+            </a:solidFill>
+          </a:ln>
+          <a:effectLst/>
+        </p:spPr>
+        <p:style>
+          <a:lnRef idx="2">
+            <a:schemeClr val="accent1"/>
+          </a:lnRef>
+          <a:fillRef idx="0">
+            <a:schemeClr val="accent1"/>
+          </a:fillRef>
+          <a:effectRef idx="1">
+            <a:schemeClr val="accent1"/>
+          </a:effectRef>
+          <a:fontRef idx="minor">
+            <a:schemeClr val="tx1"/>
+          </a:fontRef>
+        </p:style>
+      </p:cxnSp>
+      <p:cxnSp>
+        <p:nvCxnSpPr>
+          <p:cNvPr id="11" name="Connector 10"/>
+          <p:cNvCxnSpPr/>
+          <p:nvPr/>
+        </p:nvCxnSpPr>
+        <p:spPr>
+          <a:xfrm flipH="1" flipV="1">
+            <a:off x="9921240" y="1234440"/>
+            <a:ext cx="822960" cy="2377440"/>
+          </a:xfrm>
+          <a:prstGeom prst="line">
+            <a:avLst/>
+          </a:prstGeom>
+          <a:ln w="9525">
+            <a:solidFill>
+              <a:srgbClr val="4A9384"/>
+            </a:solidFill>
+          </a:ln>
+          <a:effectLst/>
+        </p:spPr>
+        <p:style>
+          <a:lnRef idx="2">
+            <a:schemeClr val="accent1"/>
+          </a:lnRef>
+          <a:fillRef idx="0">
+            <a:schemeClr val="accent1"/>
+          </a:fillRef>
+          <a:effectRef idx="1">
+            <a:schemeClr val="accent1"/>
+          </a:effectRef>
+          <a:fontRef idx="minor">
+            <a:schemeClr val="tx1"/>
+          </a:fontRef>
+        </p:style>
+      </p:cxnSp>
+      <p:cxnSp>
+        <p:nvCxnSpPr>
+          <p:cNvPr id="12" name="Connector 11"/>
+          <p:cNvCxnSpPr/>
+          <p:nvPr/>
+        </p:nvCxnSpPr>
+        <p:spPr>
+          <a:xfrm flipV="1">
+            <a:off x="10744200" y="1965960"/>
+            <a:ext cx="731520" cy="1645920"/>
+          </a:xfrm>
+          <a:prstGeom prst="line">
+            <a:avLst/>
+          </a:prstGeom>
+          <a:ln w="9525">
+            <a:solidFill>
+              <a:srgbClr val="4A9384"/>
+            </a:solidFill>
+          </a:ln>
+          <a:effectLst/>
+        </p:spPr>
+        <p:style>
+          <a:lnRef idx="2">
+            <a:schemeClr val="accent1"/>
+          </a:lnRef>
+          <a:fillRef idx="0">
+            <a:schemeClr val="accent1"/>
+          </a:fillRef>
+          <a:effectRef idx="1">
+            <a:schemeClr val="accent1"/>
+          </a:effectRef>
+          <a:fontRef idx="minor">
+            <a:schemeClr val="tx1"/>
+          </a:fontRef>
+        </p:style>
+      </p:cxnSp>
+      <p:cxnSp>
+        <p:nvCxnSpPr>
+          <p:cNvPr id="13" name="Connector 12"/>
+          <p:cNvCxnSpPr/>
+          <p:nvPr/>
+        </p:nvCxnSpPr>
+        <p:spPr>
+          <a:xfrm flipH="1" flipV="1">
+            <a:off x="9555480" y="2697480"/>
+            <a:ext cx="1188720" cy="914400"/>
+          </a:xfrm>
+          <a:prstGeom prst="line">
+            <a:avLst/>
+          </a:prstGeom>
+          <a:ln w="9525">
+            <a:solidFill>
+              <a:srgbClr val="4A9384"/>
+            </a:solidFill>
+          </a:ln>
+          <a:effectLst/>
+        </p:spPr>
+        <p:style>
+          <a:lnRef idx="2">
+            <a:schemeClr val="accent1"/>
+          </a:lnRef>
+          <a:fillRef idx="0">
+            <a:schemeClr val="accent1"/>
+          </a:fillRef>
+          <a:effectRef idx="1">
+            <a:schemeClr val="accent1"/>
+          </a:effectRef>
+          <a:fontRef idx="minor">
+            <a:schemeClr val="tx1"/>
+          </a:fontRef>
+        </p:style>
+      </p:cxnSp>
+      <p:cxnSp>
+        <p:nvCxnSpPr>
+          <p:cNvPr id="14" name="Connector 13"/>
+          <p:cNvCxnSpPr/>
+          <p:nvPr/>
+        </p:nvCxnSpPr>
+        <p:spPr>
+          <a:xfrm>
+            <a:off x="10744200" y="3611880"/>
+            <a:ext cx="548640" cy="1005840"/>
+          </a:xfrm>
+          <a:prstGeom prst="line">
+            <a:avLst/>
+          </a:prstGeom>
+          <a:ln w="9525">
+            <a:solidFill>
+              <a:srgbClr val="4A9384"/>
+            </a:solidFill>
+          </a:ln>
+          <a:effectLst/>
+        </p:spPr>
+        <p:style>
+          <a:lnRef idx="2">
+            <a:schemeClr val="accent1"/>
+          </a:lnRef>
+          <a:fillRef idx="0">
+            <a:schemeClr val="accent1"/>
+          </a:fillRef>
+          <a:effectRef idx="1">
+            <a:schemeClr val="accent1"/>
+          </a:effectRef>
+          <a:fontRef idx="minor">
+            <a:schemeClr val="tx1"/>
+          </a:fontRef>
+        </p:style>
+      </p:cxnSp>
+      <p:cxnSp>
+        <p:nvCxnSpPr>
+          <p:cNvPr id="15" name="Connector 14"/>
+          <p:cNvCxnSpPr/>
+          <p:nvPr/>
+        </p:nvCxnSpPr>
+        <p:spPr>
+          <a:xfrm flipH="1">
+            <a:off x="10104120" y="3611880"/>
+            <a:ext cx="640080" cy="548640"/>
+          </a:xfrm>
+          <a:prstGeom prst="line">
+            <a:avLst/>
+          </a:prstGeom>
+          <a:ln w="9525">
+            <a:solidFill>
+              <a:srgbClr val="4A9384"/>
+            </a:solidFill>
+          </a:ln>
+          <a:effectLst/>
+        </p:spPr>
+        <p:style>
+          <a:lnRef idx="2">
+            <a:schemeClr val="accent1"/>
+          </a:lnRef>
+          <a:fillRef idx="0">
+            <a:schemeClr val="accent1"/>
+          </a:fillRef>
+          <a:effectRef idx="1">
+            <a:schemeClr val="accent1"/>
+          </a:effectRef>
+          <a:fontRef idx="minor">
+            <a:schemeClr val="tx1"/>
+          </a:fontRef>
+        </p:style>
+      </p:cxnSp>
+      <p:cxnSp>
+        <p:nvCxnSpPr>
+          <p:cNvPr id="16" name="Connector 15"/>
+          <p:cNvCxnSpPr/>
+          <p:nvPr/>
+        </p:nvCxnSpPr>
+        <p:spPr>
+          <a:xfrm flipV="1">
+            <a:off x="10744200" y="3063240"/>
+            <a:ext cx="1161288" cy="548640"/>
+          </a:xfrm>
+          <a:prstGeom prst="line">
+            <a:avLst/>
+          </a:prstGeom>
+          <a:ln w="9525">
+            <a:solidFill>
+              <a:srgbClr val="4A9384"/>
+            </a:solidFill>
+          </a:ln>
+          <a:effectLst/>
+        </p:spPr>
+        <p:style>
+          <a:lnRef idx="2">
+            <a:schemeClr val="accent1"/>
+          </a:lnRef>
+          <a:fillRef idx="0">
+            <a:schemeClr val="accent1"/>
+          </a:fillRef>
+          <a:effectRef idx="1">
+            <a:schemeClr val="accent1"/>
+          </a:effectRef>
+          <a:fontRef idx="minor">
+            <a:schemeClr val="tx1"/>
+          </a:fontRef>
+        </p:style>
+      </p:cxnSp>
+      <p:cxnSp>
+        <p:nvCxnSpPr>
+          <p:cNvPr id="17" name="Connector 16"/>
+          <p:cNvCxnSpPr/>
+          <p:nvPr/>
+        </p:nvCxnSpPr>
+        <p:spPr>
+          <a:xfrm flipH="1">
+            <a:off x="9646920" y="3611880"/>
+            <a:ext cx="1097280" cy="1188720"/>
+          </a:xfrm>
+          <a:prstGeom prst="line">
+            <a:avLst/>
+          </a:prstGeom>
+          <a:ln w="9525">
+            <a:solidFill>
+              <a:srgbClr val="4A9384"/>
+            </a:solidFill>
+          </a:ln>
+          <a:effectLst/>
+        </p:spPr>
+        <p:style>
+          <a:lnRef idx="2">
+            <a:schemeClr val="accent1"/>
+          </a:lnRef>
+          <a:fillRef idx="0">
+            <a:schemeClr val="accent1"/>
+          </a:fillRef>
+          <a:effectRef idx="1">
+            <a:schemeClr val="accent1"/>
+          </a:effectRef>
+          <a:fontRef idx="minor">
+            <a:schemeClr val="tx1"/>
+          </a:fontRef>
+        </p:style>
+      </p:cxnSp>
+      <p:cxnSp>
+        <p:nvCxnSpPr>
+          <p:cNvPr id="18" name="Connector 17"/>
+          <p:cNvCxnSpPr/>
+          <p:nvPr/>
+        </p:nvCxnSpPr>
+        <p:spPr>
+          <a:xfrm flipH="1" flipV="1">
+            <a:off x="6053328" y="2331720"/>
+            <a:ext cx="987552" cy="1600200"/>
+          </a:xfrm>
+          <a:prstGeom prst="line">
+            <a:avLst/>
+          </a:prstGeom>
+          <a:ln w="9525">
+            <a:solidFill>
+              <a:srgbClr val="4A9384"/>
+            </a:solidFill>
+          </a:ln>
+          <a:effectLst/>
+        </p:spPr>
+        <p:style>
+          <a:lnRef idx="2">
+            <a:schemeClr val="accent1"/>
+          </a:lnRef>
+          <a:fillRef idx="0">
+            <a:schemeClr val="accent1"/>
+          </a:fillRef>
+          <a:effectRef idx="1">
+            <a:schemeClr val="accent1"/>
+          </a:effectRef>
+          <a:fontRef idx="minor">
+            <a:schemeClr val="tx1"/>
+          </a:fontRef>
+        </p:style>
+      </p:cxnSp>
+      <p:cxnSp>
+        <p:nvCxnSpPr>
+          <p:cNvPr id="19" name="Connector 18"/>
+          <p:cNvCxnSpPr/>
+          <p:nvPr/>
+        </p:nvCxnSpPr>
+        <p:spPr>
+          <a:xfrm flipH="1" flipV="1">
+            <a:off x="5806440" y="3310128"/>
+            <a:ext cx="1234440" cy="621792"/>
+          </a:xfrm>
+          <a:prstGeom prst="line">
+            <a:avLst/>
+          </a:prstGeom>
+          <a:ln w="9525">
+            <a:solidFill>
+              <a:srgbClr val="4A9384"/>
+            </a:solidFill>
+          </a:ln>
+          <a:effectLst/>
+        </p:spPr>
+        <p:style>
+          <a:lnRef idx="2">
+            <a:schemeClr val="accent1"/>
+          </a:lnRef>
+          <a:fillRef idx="0">
+            <a:schemeClr val="accent1"/>
+          </a:fillRef>
+          <a:effectRef idx="1">
+            <a:schemeClr val="accent1"/>
+          </a:effectRef>
+          <a:fontRef idx="minor">
+            <a:schemeClr val="tx1"/>
+          </a:fontRef>
+        </p:style>
+      </p:cxnSp>
+      <p:cxnSp>
+        <p:nvCxnSpPr>
+          <p:cNvPr id="20" name="Connector 19"/>
+          <p:cNvCxnSpPr/>
+          <p:nvPr/>
+        </p:nvCxnSpPr>
+        <p:spPr>
+          <a:xfrm flipV="1">
+            <a:off x="7040880" y="2926080"/>
+            <a:ext cx="685799" cy="1005840"/>
+          </a:xfrm>
+          <a:prstGeom prst="line">
+            <a:avLst/>
+          </a:prstGeom>
+          <a:ln w="9525">
+            <a:solidFill>
+              <a:srgbClr val="4A9384"/>
+            </a:solidFill>
+          </a:ln>
+          <a:effectLst/>
+        </p:spPr>
+        <p:style>
+          <a:lnRef idx="2">
+            <a:schemeClr val="accent1"/>
+          </a:lnRef>
+          <a:fillRef idx="0">
+            <a:schemeClr val="accent1"/>
+          </a:fillRef>
+          <a:effectRef idx="1">
+            <a:schemeClr val="accent1"/>
+          </a:effectRef>
+          <a:fontRef idx="minor">
+            <a:schemeClr val="tx1"/>
+          </a:fontRef>
+        </p:style>
+      </p:cxnSp>
+      <p:cxnSp>
+        <p:nvCxnSpPr>
+          <p:cNvPr id="21" name="Connector 20"/>
+          <p:cNvCxnSpPr/>
+          <p:nvPr/>
+        </p:nvCxnSpPr>
+        <p:spPr>
+          <a:xfrm>
+            <a:off x="7040880" y="3931920"/>
+            <a:ext cx="1234440" cy="640080"/>
+          </a:xfrm>
+          <a:prstGeom prst="line">
+            <a:avLst/>
+          </a:prstGeom>
+          <a:ln w="9525">
+            <a:solidFill>
+              <a:srgbClr val="4A9384"/>
+            </a:solidFill>
+          </a:ln>
+          <a:effectLst/>
+        </p:spPr>
+        <p:style>
+          <a:lnRef idx="2">
+            <a:schemeClr val="accent1"/>
+          </a:lnRef>
+          <a:fillRef idx="0">
+            <a:schemeClr val="accent1"/>
+          </a:fillRef>
+          <a:effectRef idx="1">
+            <a:schemeClr val="accent1"/>
+          </a:effectRef>
+          <a:fontRef idx="minor">
+            <a:schemeClr val="tx1"/>
+          </a:fontRef>
+        </p:style>
+      </p:cxnSp>
+      <p:cxnSp>
+        <p:nvCxnSpPr>
+          <p:cNvPr id="22" name="Connector 21"/>
+          <p:cNvCxnSpPr/>
+          <p:nvPr/>
+        </p:nvCxnSpPr>
+        <p:spPr>
+          <a:xfrm flipH="1">
+            <a:off x="6537960" y="3931920"/>
+            <a:ext cx="502920" cy="960120"/>
+          </a:xfrm>
+          <a:prstGeom prst="line">
+            <a:avLst/>
+          </a:prstGeom>
+          <a:ln w="9525">
+            <a:solidFill>
+              <a:srgbClr val="4A9384"/>
+            </a:solidFill>
+          </a:ln>
+          <a:effectLst/>
+        </p:spPr>
+        <p:style>
+          <a:lnRef idx="2">
+            <a:schemeClr val="accent1"/>
+          </a:lnRef>
+          <a:fillRef idx="0">
+            <a:schemeClr val="accent1"/>
+          </a:fillRef>
+          <a:effectRef idx="1">
+            <a:schemeClr val="accent1"/>
+          </a:effectRef>
+          <a:fontRef idx="minor">
+            <a:schemeClr val="tx1"/>
+          </a:fontRef>
+        </p:style>
+      </p:cxnSp>
+      <p:cxnSp>
+        <p:nvCxnSpPr>
+          <p:cNvPr id="23" name="Connector 22"/>
+          <p:cNvCxnSpPr/>
+          <p:nvPr/>
+        </p:nvCxnSpPr>
+        <p:spPr>
+          <a:xfrm flipV="1">
+            <a:off x="9921240" y="1005840"/>
+            <a:ext cx="1783080" cy="228600"/>
+          </a:xfrm>
+          <a:prstGeom prst="line">
+            <a:avLst/>
+          </a:prstGeom>
+          <a:ln w="9525">
+            <a:solidFill>
+              <a:srgbClr val="4A9384"/>
+            </a:solidFill>
+          </a:ln>
+          <a:effectLst/>
+        </p:spPr>
+        <p:style>
+          <a:lnRef idx="2">
+            <a:schemeClr val="accent1"/>
+          </a:lnRef>
+          <a:fillRef idx="0">
+            <a:schemeClr val="accent1"/>
+          </a:fillRef>
+          <a:effectRef idx="1">
+            <a:schemeClr val="accent1"/>
+          </a:effectRef>
+          <a:fontRef idx="minor">
+            <a:schemeClr val="tx1"/>
+          </a:fontRef>
+        </p:style>
+      </p:cxnSp>
+      <p:cxnSp>
+        <p:nvCxnSpPr>
+          <p:cNvPr id="24" name="Connector 23"/>
+          <p:cNvCxnSpPr/>
+          <p:nvPr/>
+        </p:nvCxnSpPr>
+        <p:spPr>
+          <a:xfrm flipH="1">
+            <a:off x="7726679" y="2697480"/>
+            <a:ext cx="1828801" cy="228600"/>
+          </a:xfrm>
+          <a:prstGeom prst="line">
+            <a:avLst/>
+          </a:prstGeom>
+          <a:ln w="9525">
+            <a:solidFill>
+              <a:srgbClr val="4A9384"/>
+            </a:solidFill>
+          </a:ln>
+          <a:effectLst/>
+        </p:spPr>
+        <p:style>
+          <a:lnRef idx="2">
+            <a:schemeClr val="accent1"/>
+          </a:lnRef>
+          <a:fillRef idx="0">
+            <a:schemeClr val="accent1"/>
+          </a:fillRef>
+          <a:effectRef idx="1">
+            <a:schemeClr val="accent1"/>
+          </a:effectRef>
+          <a:fontRef idx="minor">
+            <a:schemeClr val="tx1"/>
+          </a:fontRef>
+        </p:style>
+      </p:cxnSp>
+      <p:cxnSp>
+        <p:nvCxnSpPr>
+          <p:cNvPr id="25" name="Connector 24"/>
+          <p:cNvCxnSpPr/>
+          <p:nvPr/>
+        </p:nvCxnSpPr>
+        <p:spPr>
+          <a:xfrm>
+            <a:off x="8275320" y="4572000"/>
+            <a:ext cx="1371600" cy="228600"/>
+          </a:xfrm>
+          <a:prstGeom prst="line">
+            <a:avLst/>
+          </a:prstGeom>
+          <a:ln w="9525">
+            <a:solidFill>
+              <a:srgbClr val="4A9384"/>
+            </a:solidFill>
+          </a:ln>
+          <a:effectLst/>
+        </p:spPr>
+        <p:style>
+          <a:lnRef idx="2">
+            <a:schemeClr val="accent1"/>
+          </a:lnRef>
+          <a:fillRef idx="0">
+            <a:schemeClr val="accent1"/>
+          </a:fillRef>
+          <a:effectRef idx="1">
+            <a:schemeClr val="accent1"/>
+          </a:effectRef>
+          <a:fontRef idx="minor">
+            <a:schemeClr val="tx1"/>
+          </a:fontRef>
+        </p:style>
+      </p:cxnSp>
+      <p:cxnSp>
+        <p:nvCxnSpPr>
+          <p:cNvPr id="26" name="Connector 25"/>
+          <p:cNvCxnSpPr/>
+          <p:nvPr/>
+        </p:nvCxnSpPr>
+        <p:spPr>
+          <a:xfrm>
+            <a:off x="11475720" y="1965960"/>
+            <a:ext cx="429768" cy="1097280"/>
+          </a:xfrm>
+          <a:prstGeom prst="line">
+            <a:avLst/>
+          </a:prstGeom>
+          <a:ln w="9525">
+            <a:solidFill>
+              <a:srgbClr val="4A9384"/>
+            </a:solidFill>
+          </a:ln>
+          <a:effectLst/>
+        </p:spPr>
+        <p:style>
+          <a:lnRef idx="2">
+            <a:schemeClr val="accent1"/>
+          </a:lnRef>
+          <a:fillRef idx="0">
+            <a:schemeClr val="accent1"/>
+          </a:fillRef>
+          <a:effectRef idx="1">
+            <a:schemeClr val="accent1"/>
+          </a:effectRef>
+          <a:fontRef idx="minor">
+            <a:schemeClr val="tx1"/>
+          </a:fontRef>
+        </p:style>
+      </p:cxnSp>
+      <p:cxnSp>
+        <p:nvCxnSpPr>
+          <p:cNvPr id="27" name="Connector 26"/>
+          <p:cNvCxnSpPr/>
+          <p:nvPr/>
+        </p:nvCxnSpPr>
+        <p:spPr>
+          <a:xfrm flipH="1" flipV="1">
+            <a:off x="7452360" y="1920240"/>
+            <a:ext cx="274319" cy="1005840"/>
+          </a:xfrm>
+          <a:prstGeom prst="line">
+            <a:avLst/>
+          </a:prstGeom>
+          <a:ln w="9525">
+            <a:solidFill>
+              <a:srgbClr val="4A9384"/>
+            </a:solidFill>
+          </a:ln>
+          <a:effectLst/>
+        </p:spPr>
+        <p:style>
+          <a:lnRef idx="2">
+            <a:schemeClr val="accent1"/>
+          </a:lnRef>
+          <a:fillRef idx="0">
+            <a:schemeClr val="accent1"/>
+          </a:fillRef>
+          <a:effectRef idx="1">
+            <a:schemeClr val="accent1"/>
+          </a:effectRef>
+          <a:fontRef idx="minor">
+            <a:schemeClr val="tx1"/>
+          </a:fontRef>
+        </p:style>
+      </p:cxnSp>
+      <p:cxnSp>
+        <p:nvCxnSpPr>
+          <p:cNvPr id="28" name="Connector 27"/>
+          <p:cNvCxnSpPr/>
+          <p:nvPr/>
+        </p:nvCxnSpPr>
+        <p:spPr>
+          <a:xfrm flipH="1">
+            <a:off x="6053328" y="1188720"/>
+            <a:ext cx="667512" cy="1143000"/>
+          </a:xfrm>
+          <a:prstGeom prst="line">
+            <a:avLst/>
+          </a:prstGeom>
+          <a:ln w="9525">
+            <a:solidFill>
+              <a:srgbClr val="4A9384"/>
+            </a:solidFill>
+          </a:ln>
+          <a:effectLst/>
+        </p:spPr>
+        <p:style>
+          <a:lnRef idx="2">
+            <a:schemeClr val="accent1"/>
+          </a:lnRef>
+          <a:fillRef idx="0">
+            <a:schemeClr val="accent1"/>
+          </a:fillRef>
+          <a:effectRef idx="1">
+            <a:schemeClr val="accent1"/>
+          </a:effectRef>
+          <a:fontRef idx="minor">
+            <a:schemeClr val="tx1"/>
+          </a:fontRef>
+        </p:style>
+      </p:cxnSp>
+      <p:cxnSp>
+        <p:nvCxnSpPr>
+          <p:cNvPr id="29" name="Connector 28"/>
+          <p:cNvCxnSpPr/>
+          <p:nvPr/>
+        </p:nvCxnSpPr>
+        <p:spPr>
+          <a:xfrm flipV="1">
+            <a:off x="9646920" y="4617720"/>
+            <a:ext cx="1645920" cy="182880"/>
+          </a:xfrm>
+          <a:prstGeom prst="line">
+            <a:avLst/>
+          </a:prstGeom>
+          <a:ln w="9525">
+            <a:solidFill>
+              <a:srgbClr val="4A9384"/>
+            </a:solidFill>
+          </a:ln>
+          <a:effectLst/>
+        </p:spPr>
+        <p:style>
+          <a:lnRef idx="2">
+            <a:schemeClr val="accent1"/>
+          </a:lnRef>
+          <a:fillRef idx="0">
+            <a:schemeClr val="accent1"/>
+          </a:fillRef>
+          <a:effectRef idx="1">
+            <a:schemeClr val="accent1"/>
+          </a:effectRef>
+          <a:fontRef idx="minor">
+            <a:schemeClr val="tx1"/>
+          </a:fontRef>
+        </p:style>
+      </p:cxnSp>
+      <p:sp>
+        <p:nvSpPr>
+          <p:cNvPr id="30" name="Oval 29"/>
+          <p:cNvSpPr/>
+          <p:nvPr/>
+        </p:nvSpPr>
+        <p:spPr>
+          <a:xfrm>
+            <a:off x="6601968" y="1069848"/>
+            <a:ext cx="237744" cy="237744"/>
+          </a:xfrm>
+          <a:prstGeom prst="ellipse">
+            <a:avLst/>
+          </a:prstGeom>
+          <a:solidFill>
+            <a:srgbClr val="F2F7F5"/>
+          </a:solidFill>
+          <a:ln w="9525">
+            <a:solidFill>
+              <a:srgbClr val="0C332C"/>
+            </a:solidFill>
+          </a:ln>
+          <a:effectLst/>
+        </p:spPr>
+        <p:style>
+          <a:lnRef idx="1">
+            <a:schemeClr val="accent1"/>
+          </a:lnRef>
+          <a:fillRef idx="3">
+            <a:schemeClr val="accent1"/>
+          </a:fillRef>
+          <a:effectRef idx="2">
+            <a:schemeClr val="accent1"/>
+          </a:effectRef>
+          <a:fontRef idx="minor">
+            <a:schemeClr val="lt1"/>
+          </a:fontRef>
+        </p:style>
+        <p:txBody>
+          <a:bodyPr rtlCol="0" anchor="ctr"/>
+          <a:lstStyle/>
+          <a:p>
+            <a:pPr algn="ctr"/>
+          </a:p>
+        </p:txBody>
+      </p:sp>
+      <p:sp>
+        <p:nvSpPr>
+          <p:cNvPr id="31" name="Oval 30"/>
+          <p:cNvSpPr/>
+          <p:nvPr/>
+        </p:nvSpPr>
+        <p:spPr>
+          <a:xfrm>
+            <a:off x="7863840" y="749808"/>
+            <a:ext cx="182880" cy="182880"/>
+          </a:xfrm>
+          <a:prstGeom prst="ellipse">
+            <a:avLst/>
+          </a:prstGeom>
+          <a:solidFill>
+            <a:srgbClr val="DAB462"/>
+          </a:solidFill>
+          <a:ln w="9525">
+            <a:solidFill>
+              <a:srgbClr val="0C332C"/>
+            </a:solidFill>
+          </a:ln>
+          <a:effectLst/>
+        </p:spPr>
+        <p:style>
+          <a:lnRef idx="1">
+            <a:schemeClr val="accent1"/>
+          </a:lnRef>
+          <a:fillRef idx="3">
+            <a:schemeClr val="accent1"/>
+          </a:fillRef>
+          <a:effectRef idx="2">
+            <a:schemeClr val="accent1"/>
+          </a:effectRef>
+          <a:fontRef idx="minor">
+            <a:schemeClr val="lt1"/>
+          </a:fontRef>
+        </p:style>
+        <p:txBody>
+          <a:bodyPr rtlCol="0" anchor="ctr"/>
+          <a:lstStyle/>
+          <a:p>
+            <a:pPr algn="ctr"/>
+          </a:p>
+        </p:txBody>
+      </p:sp>
+      <p:sp>
+        <p:nvSpPr>
+          <p:cNvPr id="32" name="Oval 31"/>
+          <p:cNvSpPr/>
+          <p:nvPr/>
+        </p:nvSpPr>
+        <p:spPr>
+          <a:xfrm>
+            <a:off x="9784080" y="1097280"/>
+            <a:ext cx="274320" cy="274320"/>
+          </a:xfrm>
+          <a:prstGeom prst="ellipse">
+            <a:avLst/>
+          </a:prstGeom>
+          <a:solidFill>
+            <a:srgbClr val="F2F7F5"/>
+          </a:solidFill>
+          <a:ln w="9525">
+            <a:solidFill>
+              <a:srgbClr val="0C332C"/>
+            </a:solidFill>
+          </a:ln>
+          <a:effectLst/>
+        </p:spPr>
+        <p:style>
+          <a:lnRef idx="1">
+            <a:schemeClr val="accent1"/>
+          </a:lnRef>
+          <a:fillRef idx="3">
+            <a:schemeClr val="accent1"/>
+          </a:fillRef>
+          <a:effectRef idx="2">
+            <a:schemeClr val="accent1"/>
+          </a:effectRef>
+          <a:fontRef idx="minor">
+            <a:schemeClr val="lt1"/>
+          </a:fontRef>
+        </p:style>
+        <p:txBody>
+          <a:bodyPr rtlCol="0" anchor="ctr"/>
+          <a:lstStyle/>
+          <a:p>
+            <a:pPr algn="ctr"/>
+          </a:p>
+        </p:txBody>
+      </p:sp>
+      <p:sp>
+        <p:nvSpPr>
+          <p:cNvPr id="33" name="Oval 32"/>
+          <p:cNvSpPr/>
+          <p:nvPr/>
+        </p:nvSpPr>
+        <p:spPr>
+          <a:xfrm>
+            <a:off x="11365992" y="1856231"/>
+            <a:ext cx="219456" cy="219456"/>
+          </a:xfrm>
+          <a:prstGeom prst="ellipse">
+            <a:avLst/>
+          </a:prstGeom>
+          <a:solidFill>
+            <a:srgbClr val="5FC9B4"/>
+          </a:solidFill>
+          <a:ln w="9525">
+            <a:solidFill>
+              <a:srgbClr val="0C332C"/>
+            </a:solidFill>
+          </a:ln>
+          <a:effectLst/>
+        </p:spPr>
+        <p:style>
+          <a:lnRef idx="1">
+            <a:schemeClr val="accent1"/>
+          </a:lnRef>
+          <a:fillRef idx="3">
+            <a:schemeClr val="accent1"/>
+          </a:fillRef>
+          <a:effectRef idx="2">
+            <a:schemeClr val="accent1"/>
+          </a:effectRef>
+          <a:fontRef idx="minor">
+            <a:schemeClr val="lt1"/>
+          </a:fontRef>
+        </p:style>
+        <p:txBody>
+          <a:bodyPr rtlCol="0" anchor="ctr"/>
+          <a:lstStyle/>
+          <a:p>
+            <a:pPr algn="ctr"/>
+          </a:p>
+        </p:txBody>
+      </p:sp>
+      <p:sp>
+        <p:nvSpPr>
+          <p:cNvPr id="34" name="Oval 33"/>
+          <p:cNvSpPr/>
+          <p:nvPr/>
+        </p:nvSpPr>
+        <p:spPr>
+          <a:xfrm>
+            <a:off x="11622024" y="923544"/>
+            <a:ext cx="164592" cy="164592"/>
+          </a:xfrm>
+          <a:prstGeom prst="ellipse">
+            <a:avLst/>
+          </a:prstGeom>
+          <a:solidFill>
+            <a:srgbClr val="F2F7F5"/>
+          </a:solidFill>
+          <a:ln w="9525">
+            <a:solidFill>
+              <a:srgbClr val="0C332C"/>
+            </a:solidFill>
+          </a:ln>
+          <a:effectLst/>
+        </p:spPr>
+        <p:style>
+          <a:lnRef idx="1">
+            <a:schemeClr val="accent1"/>
+          </a:lnRef>
+          <a:fillRef idx="3">
+            <a:schemeClr val="accent1"/>
+          </a:fillRef>
+          <a:effectRef idx="2">
+            <a:schemeClr val="accent1"/>
+          </a:effectRef>
+          <a:fontRef idx="minor">
+            <a:schemeClr val="lt1"/>
+          </a:fontRef>
+        </p:style>
+        <p:txBody>
+          <a:bodyPr rtlCol="0" anchor="ctr"/>
+          <a:lstStyle/>
+          <a:p>
+            <a:pPr algn="ctr"/>
+          </a:p>
+        </p:txBody>
+      </p:sp>
+      <p:sp>
+        <p:nvSpPr>
+          <p:cNvPr id="35" name="Oval 34"/>
+          <p:cNvSpPr/>
+          <p:nvPr/>
+        </p:nvSpPr>
+        <p:spPr>
+          <a:xfrm>
+            <a:off x="5943600" y="2221991"/>
+            <a:ext cx="219456" cy="219456"/>
+          </a:xfrm>
+          <a:prstGeom prst="ellipse">
+            <a:avLst/>
+          </a:prstGeom>
+          <a:solidFill>
+            <a:srgbClr val="DAB462"/>
+          </a:solidFill>
+          <a:ln w="9525">
+            <a:solidFill>
+              <a:srgbClr val="0C332C"/>
+            </a:solidFill>
+          </a:ln>
+          <a:effectLst/>
+        </p:spPr>
+        <p:style>
+          <a:lnRef idx="1">
+            <a:schemeClr val="accent1"/>
+          </a:lnRef>
+          <a:fillRef idx="3">
+            <a:schemeClr val="accent1"/>
+          </a:fillRef>
+          <a:effectRef idx="2">
+            <a:schemeClr val="accent1"/>
+          </a:effectRef>
+          <a:fontRef idx="minor">
+            <a:schemeClr val="lt1"/>
+          </a:fontRef>
+        </p:style>
+        <p:txBody>
+          <a:bodyPr rtlCol="0" anchor="ctr"/>
+          <a:lstStyle/>
+          <a:p>
+            <a:pPr algn="ctr"/>
+          </a:p>
+        </p:txBody>
+      </p:sp>
+      <p:sp>
+        <p:nvSpPr>
+          <p:cNvPr id="36" name="Oval 35"/>
+          <p:cNvSpPr/>
+          <p:nvPr/>
+        </p:nvSpPr>
+        <p:spPr>
+          <a:xfrm>
+            <a:off x="5715000" y="3218688"/>
+            <a:ext cx="182880" cy="182880"/>
+          </a:xfrm>
+          <a:prstGeom prst="ellipse">
+            <a:avLst/>
+          </a:prstGeom>
+          <a:solidFill>
+            <a:srgbClr val="F2F7F5"/>
+          </a:solidFill>
+          <a:ln w="9525">
+            <a:solidFill>
+              <a:srgbClr val="0C332C"/>
+            </a:solidFill>
+          </a:ln>
+          <a:effectLst/>
+        </p:spPr>
+        <p:style>
+          <a:lnRef idx="1">
+            <a:schemeClr val="accent1"/>
+          </a:lnRef>
+          <a:fillRef idx="3">
+            <a:schemeClr val="accent1"/>
+          </a:fillRef>
+          <a:effectRef idx="2">
+            <a:schemeClr val="accent1"/>
+          </a:effectRef>
+          <a:fontRef idx="minor">
+            <a:schemeClr val="lt1"/>
+          </a:fontRef>
+        </p:style>
+        <p:txBody>
+          <a:bodyPr rtlCol="0" anchor="ctr"/>
+          <a:lstStyle/>
+          <a:p>
+            <a:pPr algn="ctr"/>
+          </a:p>
+        </p:txBody>
+      </p:sp>
+      <p:sp>
+        <p:nvSpPr>
+          <p:cNvPr id="37" name="Oval 36"/>
+          <p:cNvSpPr/>
+          <p:nvPr/>
+        </p:nvSpPr>
+        <p:spPr>
+          <a:xfrm>
+            <a:off x="7598663" y="2798064"/>
+            <a:ext cx="256032" cy="256032"/>
+          </a:xfrm>
+          <a:prstGeom prst="ellipse">
+            <a:avLst/>
+          </a:prstGeom>
+          <a:solidFill>
+            <a:srgbClr val="5FC9B4"/>
+          </a:solidFill>
+          <a:ln w="9525">
+            <a:solidFill>
+              <a:srgbClr val="0C332C"/>
+            </a:solidFill>
+          </a:ln>
+          <a:effectLst/>
+        </p:spPr>
+        <p:style>
+          <a:lnRef idx="1">
+            <a:schemeClr val="accent1"/>
+          </a:lnRef>
+          <a:fillRef idx="3">
+            <a:schemeClr val="accent1"/>
+          </a:fillRef>
+          <a:effectRef idx="2">
+            <a:schemeClr val="accent1"/>
+          </a:effectRef>
+          <a:fontRef idx="minor">
+            <a:schemeClr val="lt1"/>
+          </a:fontRef>
+        </p:style>
+        <p:txBody>
+          <a:bodyPr rtlCol="0" anchor="ctr"/>
+          <a:lstStyle/>
+          <a:p>
+            <a:pPr algn="ctr"/>
+          </a:p>
+        </p:txBody>
+      </p:sp>
+      <p:sp>
+        <p:nvSpPr>
+          <p:cNvPr id="38" name="Oval 37"/>
+          <p:cNvSpPr/>
+          <p:nvPr/>
+        </p:nvSpPr>
+        <p:spPr>
+          <a:xfrm>
+            <a:off x="9454896" y="2596896"/>
+            <a:ext cx="201168" cy="201168"/>
+          </a:xfrm>
+          <a:prstGeom prst="ellipse">
+            <a:avLst/>
+          </a:prstGeom>
+          <a:solidFill>
+            <a:srgbClr val="DAB462"/>
+          </a:solidFill>
+          <a:ln w="9525">
+            <a:solidFill>
+              <a:srgbClr val="0C332C"/>
+            </a:solidFill>
+          </a:ln>
+          <a:effectLst/>
+        </p:spPr>
+        <p:style>
+          <a:lnRef idx="1">
+            <a:schemeClr val="accent1"/>
+          </a:lnRef>
+          <a:fillRef idx="3">
+            <a:schemeClr val="accent1"/>
+          </a:fillRef>
+          <a:effectRef idx="2">
+            <a:schemeClr val="accent1"/>
+          </a:effectRef>
+          <a:fontRef idx="minor">
+            <a:schemeClr val="lt1"/>
+          </a:fontRef>
+        </p:style>
+        <p:txBody>
+          <a:bodyPr rtlCol="0" anchor="ctr"/>
+          <a:lstStyle/>
+          <a:p>
+            <a:pPr algn="ctr"/>
+          </a:p>
+        </p:txBody>
+      </p:sp>
+      <p:sp>
+        <p:nvSpPr>
+          <p:cNvPr id="39" name="Oval 38"/>
+          <p:cNvSpPr/>
+          <p:nvPr/>
+        </p:nvSpPr>
+        <p:spPr>
+          <a:xfrm>
+            <a:off x="11183112" y="4507992"/>
+            <a:ext cx="219456" cy="219456"/>
+          </a:xfrm>
+          <a:prstGeom prst="ellipse">
+            <a:avLst/>
+          </a:prstGeom>
+          <a:solidFill>
+            <a:srgbClr val="5FC9B4"/>
+          </a:solidFill>
+          <a:ln w="9525">
+            <a:solidFill>
+              <a:srgbClr val="0C332C"/>
+            </a:solidFill>
+          </a:ln>
+          <a:effectLst/>
+        </p:spPr>
+        <p:style>
+          <a:lnRef idx="1">
+            <a:schemeClr val="accent1"/>
+          </a:lnRef>
+          <a:fillRef idx="3">
+            <a:schemeClr val="accent1"/>
+          </a:fillRef>
+          <a:effectRef idx="2">
+            <a:schemeClr val="accent1"/>
+          </a:effectRef>
+          <a:fontRef idx="minor">
+            <a:schemeClr val="lt1"/>
+          </a:fontRef>
+        </p:style>
+        <p:txBody>
+          <a:bodyPr rtlCol="0" anchor="ctr"/>
+          <a:lstStyle/>
+          <a:p>
+            <a:pPr algn="ctr"/>
+          </a:p>
+        </p:txBody>
+      </p:sp>
+      <p:sp>
+        <p:nvSpPr>
+          <p:cNvPr id="40" name="Oval 39"/>
+          <p:cNvSpPr/>
+          <p:nvPr/>
+        </p:nvSpPr>
+        <p:spPr>
+          <a:xfrm>
+            <a:off x="9546336" y="4700016"/>
+            <a:ext cx="201168" cy="201168"/>
+          </a:xfrm>
+          <a:prstGeom prst="ellipse">
+            <a:avLst/>
+          </a:prstGeom>
+          <a:solidFill>
+            <a:srgbClr val="F2F7F5"/>
+          </a:solidFill>
+          <a:ln w="9525">
+            <a:solidFill>
+              <a:srgbClr val="0C332C"/>
+            </a:solidFill>
+          </a:ln>
+          <a:effectLst/>
+        </p:spPr>
+        <p:style>
+          <a:lnRef idx="1">
+            <a:schemeClr val="accent1"/>
+          </a:lnRef>
+          <a:fillRef idx="3">
+            <a:schemeClr val="accent1"/>
+          </a:fillRef>
+          <a:effectRef idx="2">
+            <a:schemeClr val="accent1"/>
+          </a:effectRef>
+          <a:fontRef idx="minor">
+            <a:schemeClr val="lt1"/>
+          </a:fontRef>
+        </p:style>
+        <p:txBody>
+          <a:bodyPr rtlCol="0" anchor="ctr"/>
+          <a:lstStyle/>
+          <a:p>
+            <a:pPr algn="ctr"/>
+          </a:p>
+        </p:txBody>
+      </p:sp>
+      <p:sp>
+        <p:nvSpPr>
+          <p:cNvPr id="41" name="Oval 40"/>
+          <p:cNvSpPr/>
+          <p:nvPr/>
+        </p:nvSpPr>
+        <p:spPr>
+          <a:xfrm>
+            <a:off x="8147304" y="4443984"/>
+            <a:ext cx="256032" cy="256032"/>
+          </a:xfrm>
+          <a:prstGeom prst="ellipse">
+            <a:avLst/>
+          </a:prstGeom>
+          <a:solidFill>
+            <a:srgbClr val="DAB462"/>
+          </a:solidFill>
+          <a:ln w="9525">
+            <a:solidFill>
+              <a:srgbClr val="0C332C"/>
+            </a:solidFill>
+          </a:ln>
+          <a:effectLst/>
+        </p:spPr>
+        <p:style>
+          <a:lnRef idx="1">
+            <a:schemeClr val="accent1"/>
+          </a:lnRef>
+          <a:fillRef idx="3">
+            <a:schemeClr val="accent1"/>
+          </a:fillRef>
+          <a:effectRef idx="2">
+            <a:schemeClr val="accent1"/>
+          </a:effectRef>
+          <a:fontRef idx="minor">
+            <a:schemeClr val="lt1"/>
+          </a:fontRef>
+        </p:style>
+        <p:txBody>
+          <a:bodyPr rtlCol="0" anchor="ctr"/>
+          <a:lstStyle/>
+          <a:p>
+            <a:pPr algn="ctr"/>
+          </a:p>
+        </p:txBody>
+      </p:sp>
+      <p:sp>
+        <p:nvSpPr>
+          <p:cNvPr id="42" name="Oval 41"/>
+          <p:cNvSpPr/>
+          <p:nvPr/>
+        </p:nvSpPr>
+        <p:spPr>
+          <a:xfrm>
+            <a:off x="6446520" y="4800600"/>
+            <a:ext cx="182880" cy="182880"/>
+          </a:xfrm>
+          <a:prstGeom prst="ellipse">
+            <a:avLst/>
+          </a:prstGeom>
+          <a:solidFill>
+            <a:srgbClr val="5FC9B4"/>
+          </a:solidFill>
+          <a:ln w="9525">
+            <a:solidFill>
+              <a:srgbClr val="0C332C"/>
+            </a:solidFill>
+          </a:ln>
+          <a:effectLst/>
+        </p:spPr>
+        <p:style>
+          <a:lnRef idx="1">
+            <a:schemeClr val="accent1"/>
+          </a:lnRef>
+          <a:fillRef idx="3">
+            <a:schemeClr val="accent1"/>
+          </a:fillRef>
+          <a:effectRef idx="2">
+            <a:schemeClr val="accent1"/>
+          </a:effectRef>
+          <a:fontRef idx="minor">
+            <a:schemeClr val="lt1"/>
+          </a:fontRef>
+        </p:style>
+        <p:txBody>
+          <a:bodyPr rtlCol="0" anchor="ctr"/>
+          <a:lstStyle/>
+          <a:p>
+            <a:pPr algn="ctr"/>
+          </a:p>
+        </p:txBody>
+      </p:sp>
+      <p:sp>
+        <p:nvSpPr>
+          <p:cNvPr id="43" name="Oval 42"/>
+          <p:cNvSpPr/>
+          <p:nvPr/>
+        </p:nvSpPr>
+        <p:spPr>
+          <a:xfrm>
+            <a:off x="10021824" y="4078224"/>
+            <a:ext cx="164592" cy="164592"/>
+          </a:xfrm>
+          <a:prstGeom prst="ellipse">
+            <a:avLst/>
+          </a:prstGeom>
+          <a:solidFill>
+            <a:srgbClr val="F2F7F5"/>
+          </a:solidFill>
+          <a:ln w="9525">
+            <a:solidFill>
+              <a:srgbClr val="0C332C"/>
+            </a:solidFill>
+          </a:ln>
+          <a:effectLst/>
+        </p:spPr>
+        <p:style>
+          <a:lnRef idx="1">
+            <a:schemeClr val="accent1"/>
+          </a:lnRef>
+          <a:fillRef idx="3">
+            <a:schemeClr val="accent1"/>
+          </a:fillRef>
+          <a:effectRef idx="2">
+            <a:schemeClr val="accent1"/>
+          </a:effectRef>
+          <a:fontRef idx="minor">
+            <a:schemeClr val="lt1"/>
+          </a:fontRef>
+        </p:style>
+        <p:txBody>
+          <a:bodyPr rtlCol="0" anchor="ctr"/>
+          <a:lstStyle/>
+          <a:p>
+            <a:pPr algn="ctr"/>
+          </a:p>
+        </p:txBody>
+      </p:sp>
+      <p:sp>
+        <p:nvSpPr>
+          <p:cNvPr id="44" name="Oval 43"/>
+          <p:cNvSpPr/>
+          <p:nvPr/>
+        </p:nvSpPr>
+        <p:spPr>
+          <a:xfrm>
+            <a:off x="11814048" y="2971800"/>
+            <a:ext cx="182880" cy="182880"/>
+          </a:xfrm>
+          <a:prstGeom prst="ellipse">
+            <a:avLst/>
+          </a:prstGeom>
+          <a:solidFill>
+            <a:srgbClr val="DAB462"/>
+          </a:solidFill>
+          <a:ln w="9525">
+            <a:solidFill>
+              <a:srgbClr val="0C332C"/>
+            </a:solidFill>
+          </a:ln>
+          <a:effectLst/>
+        </p:spPr>
+        <p:style>
+          <a:lnRef idx="1">
+            <a:schemeClr val="accent1"/>
+          </a:lnRef>
+          <a:fillRef idx="3">
+            <a:schemeClr val="accent1"/>
+          </a:fillRef>
+          <a:effectRef idx="2">
+            <a:schemeClr val="accent1"/>
+          </a:effectRef>
+          <a:fontRef idx="minor">
+            <a:schemeClr val="lt1"/>
+          </a:fontRef>
+        </p:style>
+        <p:txBody>
+          <a:bodyPr rtlCol="0" anchor="ctr"/>
+          <a:lstStyle/>
+          <a:p>
+            <a:pPr algn="ctr"/>
+          </a:p>
+        </p:txBody>
+      </p:sp>
+      <p:sp>
+        <p:nvSpPr>
+          <p:cNvPr id="45" name="Oval 44"/>
+          <p:cNvSpPr/>
+          <p:nvPr/>
+        </p:nvSpPr>
+        <p:spPr>
+          <a:xfrm>
+            <a:off x="7370064" y="1837944"/>
+            <a:ext cx="164592" cy="164592"/>
+          </a:xfrm>
+          <a:prstGeom prst="ellipse">
+            <a:avLst/>
+          </a:prstGeom>
+          <a:solidFill>
+            <a:srgbClr val="F2F7F5"/>
+          </a:solidFill>
+          <a:ln w="9525">
+            <a:solidFill>
+              <a:srgbClr val="0C332C"/>
+            </a:solidFill>
+          </a:ln>
+          <a:effectLst/>
+        </p:spPr>
+        <p:style>
+          <a:lnRef idx="1">
+            <a:schemeClr val="accent1"/>
+          </a:lnRef>
+          <a:fillRef idx="3">
+            <a:schemeClr val="accent1"/>
+          </a:fillRef>
+          <a:effectRef idx="2">
+            <a:schemeClr val="accent1"/>
+          </a:effectRef>
+          <a:fontRef idx="minor">
+            <a:schemeClr val="lt1"/>
+          </a:fontRef>
+        </p:style>
+        <p:txBody>
+          <a:bodyPr rtlCol="0" anchor="ctr"/>
+          <a:lstStyle/>
+          <a:p>
+            <a:pPr algn="ctr"/>
+          </a:p>
+        </p:txBody>
+      </p:sp>
+      <p:sp>
+        <p:nvSpPr>
+          <p:cNvPr id="46" name="Oval 45"/>
+          <p:cNvSpPr/>
+          <p:nvPr/>
+        </p:nvSpPr>
+        <p:spPr>
+          <a:xfrm>
+            <a:off x="6272784" y="3163824"/>
+            <a:ext cx="1536192" cy="1536192"/>
+          </a:xfrm>
+          <a:prstGeom prst="ellipse">
+            <a:avLst/>
+          </a:prstGeom>
+          <a:solidFill>
+            <a:srgbClr val="1C554C"/>
+          </a:solidFill>
+          <a:ln>
+            <a:noFill/>
+          </a:ln>
+          <a:effectLst/>
+        </p:spPr>
+        <p:style>
+          <a:lnRef idx="1">
+            <a:schemeClr val="accent1"/>
+          </a:lnRef>
+          <a:fillRef idx="3">
+            <a:schemeClr val="accent1"/>
+          </a:fillRef>
+          <a:effectRef idx="2">
+            <a:schemeClr val="accent1"/>
+          </a:effectRef>
+          <a:fontRef idx="minor">
+            <a:schemeClr val="lt1"/>
+          </a:fontRef>
+        </p:style>
+        <p:txBody>
+          <a:bodyPr rtlCol="0" anchor="ctr"/>
+          <a:lstStyle/>
+          <a:p>
+            <a:pPr algn="ctr"/>
+          </a:p>
+        </p:txBody>
+      </p:sp>
+      <p:sp>
+        <p:nvSpPr>
+          <p:cNvPr id="47" name="Oval 46"/>
+          <p:cNvSpPr/>
+          <p:nvPr/>
+        </p:nvSpPr>
+        <p:spPr>
+          <a:xfrm>
+            <a:off x="6503212" y="3394252"/>
+            <a:ext cx="1075334" cy="1075334"/>
+          </a:xfrm>
+          <a:prstGeom prst="ellipse">
+            <a:avLst/>
+          </a:prstGeom>
+          <a:solidFill>
+            <a:srgbClr val="2C7769"/>
+          </a:solidFill>
+          <a:ln>
+            <a:noFill/>
+          </a:ln>
+          <a:effectLst/>
+        </p:spPr>
+        <p:style>
+          <a:lnRef idx="1">
+            <a:schemeClr val="accent1"/>
+          </a:lnRef>
+          <a:fillRef idx="3">
+            <a:schemeClr val="accent1"/>
+          </a:fillRef>
+          <a:effectRef idx="2">
+            <a:schemeClr val="accent1"/>
+          </a:effectRef>
+          <a:fontRef idx="minor">
+            <a:schemeClr val="lt1"/>
+          </a:fontRef>
+        </p:style>
+        <p:txBody>
+          <a:bodyPr rtlCol="0" anchor="ctr"/>
+          <a:lstStyle/>
+          <a:p>
+            <a:pPr algn="ctr"/>
+          </a:p>
+        </p:txBody>
+      </p:sp>
+      <p:sp>
+        <p:nvSpPr>
+          <p:cNvPr id="48" name="Oval 47"/>
+          <p:cNvSpPr/>
+          <p:nvPr/>
+        </p:nvSpPr>
+        <p:spPr>
+          <a:xfrm>
+            <a:off x="6656832" y="3547872"/>
+            <a:ext cx="768096" cy="768096"/>
+          </a:xfrm>
+          <a:prstGeom prst="ellipse">
+            <a:avLst/>
+          </a:prstGeom>
+          <a:solidFill>
+            <a:srgbClr val="45A08E"/>
+          </a:solidFill>
+          <a:ln>
+            <a:noFill/>
+          </a:ln>
+          <a:effectLst/>
+        </p:spPr>
+        <p:style>
+          <a:lnRef idx="1">
+            <a:schemeClr val="accent1"/>
+          </a:lnRef>
+          <a:fillRef idx="3">
+            <a:schemeClr val="accent1"/>
+          </a:fillRef>
+          <a:effectRef idx="2">
+            <a:schemeClr val="accent1"/>
+          </a:effectRef>
+          <a:fontRef idx="minor">
+            <a:schemeClr val="lt1"/>
+          </a:fontRef>
+        </p:style>
+        <p:txBody>
+          <a:bodyPr rtlCol="0" anchor="ctr"/>
+          <a:lstStyle/>
+          <a:p>
+            <a:pPr algn="ctr"/>
+          </a:p>
+        </p:txBody>
+      </p:sp>
+      <p:sp>
+        <p:nvSpPr>
+          <p:cNvPr id="49" name="Oval 48"/>
+          <p:cNvSpPr/>
+          <p:nvPr/>
+        </p:nvSpPr>
+        <p:spPr>
+          <a:xfrm>
+            <a:off x="6784848" y="3675887"/>
+            <a:ext cx="512064" cy="512064"/>
+          </a:xfrm>
+          <a:prstGeom prst="ellipse">
+            <a:avLst/>
+          </a:prstGeom>
+          <a:solidFill>
+            <a:srgbClr val="5FC9B4"/>
+          </a:solidFill>
+          <a:ln w="9525">
+            <a:solidFill>
+              <a:srgbClr val="0C332C"/>
+            </a:solidFill>
+          </a:ln>
+          <a:effectLst/>
+        </p:spPr>
+        <p:style>
+          <a:lnRef idx="1">
+            <a:schemeClr val="accent1"/>
+          </a:lnRef>
+          <a:fillRef idx="3">
+            <a:schemeClr val="accent1"/>
+          </a:fillRef>
+          <a:effectRef idx="2">
+            <a:schemeClr val="accent1"/>
+          </a:effectRef>
+          <a:fontRef idx="minor">
+            <a:schemeClr val="lt1"/>
+          </a:fontRef>
+        </p:style>
+        <p:txBody>
+          <a:bodyPr rtlCol="0" anchor="ctr"/>
+          <a:lstStyle/>
+          <a:p>
+            <a:pPr algn="ctr"/>
+          </a:p>
+        </p:txBody>
+      </p:sp>
+      <p:sp>
+        <p:nvSpPr>
+          <p:cNvPr id="50" name="Oval 49"/>
+          <p:cNvSpPr/>
+          <p:nvPr/>
+        </p:nvSpPr>
+        <p:spPr>
+          <a:xfrm>
+            <a:off x="6933346" y="3824386"/>
+            <a:ext cx="215066" cy="215066"/>
+          </a:xfrm>
+          <a:prstGeom prst="ellipse">
+            <a:avLst/>
+          </a:prstGeom>
+          <a:solidFill>
+            <a:srgbClr val="F2F7F5"/>
+          </a:solidFill>
+          <a:ln>
+            <a:noFill/>
+          </a:ln>
+          <a:effectLst/>
+        </p:spPr>
+        <p:style>
+          <a:lnRef idx="1">
+            <a:schemeClr val="accent1"/>
+          </a:lnRef>
+          <a:fillRef idx="3">
+            <a:schemeClr val="accent1"/>
+          </a:fillRef>
+          <a:effectRef idx="2">
+            <a:schemeClr val="accent1"/>
+          </a:effectRef>
+          <a:fontRef idx="minor">
+            <a:schemeClr val="lt1"/>
+          </a:fontRef>
+        </p:style>
+        <p:txBody>
+          <a:bodyPr rtlCol="0" anchor="ctr"/>
+          <a:lstStyle/>
+          <a:p>
+            <a:pPr algn="ctr"/>
+          </a:p>
+        </p:txBody>
+      </p:sp>
+      <p:sp>
+        <p:nvSpPr>
+          <p:cNvPr id="51" name="Oval 50"/>
+          <p:cNvSpPr/>
+          <p:nvPr/>
+        </p:nvSpPr>
+        <p:spPr>
+          <a:xfrm>
+            <a:off x="9838944" y="2706624"/>
+            <a:ext cx="1810512" cy="1810512"/>
+          </a:xfrm>
+          <a:prstGeom prst="ellipse">
+            <a:avLst/>
+          </a:prstGeom>
+          <a:solidFill>
+            <a:srgbClr val="4A4A30"/>
+          </a:solidFill>
+          <a:ln>
+            <a:noFill/>
+          </a:ln>
+          <a:effectLst/>
+        </p:spPr>
+        <p:style>
+          <a:lnRef idx="1">
+            <a:schemeClr val="accent1"/>
+          </a:lnRef>
+          <a:fillRef idx="3">
+            <a:schemeClr val="accent1"/>
+          </a:fillRef>
+          <a:effectRef idx="2">
+            <a:schemeClr val="accent1"/>
+          </a:effectRef>
+          <a:fontRef idx="minor">
+            <a:schemeClr val="lt1"/>
+          </a:fontRef>
+        </p:style>
+        <p:txBody>
+          <a:bodyPr rtlCol="0" anchor="ctr"/>
+          <a:lstStyle/>
+          <a:p>
+            <a:pPr algn="ctr"/>
+          </a:p>
+        </p:txBody>
+      </p:sp>
+      <p:sp>
+        <p:nvSpPr>
+          <p:cNvPr id="52" name="Oval 51"/>
+          <p:cNvSpPr/>
+          <p:nvPr/>
+        </p:nvSpPr>
+        <p:spPr>
+          <a:xfrm>
+            <a:off x="10110520" y="2978200"/>
+            <a:ext cx="1267358" cy="1267358"/>
+          </a:xfrm>
+          <a:prstGeom prst="ellipse">
+            <a:avLst/>
+          </a:prstGeom>
+          <a:solidFill>
+            <a:srgbClr val="7A6A38"/>
+          </a:solidFill>
+          <a:ln>
+            <a:noFill/>
+          </a:ln>
+          <a:effectLst/>
+        </p:spPr>
+        <p:style>
+          <a:lnRef idx="1">
+            <a:schemeClr val="accent1"/>
+          </a:lnRef>
+          <a:fillRef idx="3">
+            <a:schemeClr val="accent1"/>
+          </a:fillRef>
+          <a:effectRef idx="2">
+            <a:schemeClr val="accent1"/>
+          </a:effectRef>
+          <a:fontRef idx="minor">
+            <a:schemeClr val="lt1"/>
+          </a:fontRef>
+        </p:style>
+        <p:txBody>
+          <a:bodyPr rtlCol="0" anchor="ctr"/>
+          <a:lstStyle/>
+          <a:p>
+            <a:pPr algn="ctr"/>
+          </a:p>
+        </p:txBody>
+      </p:sp>
+      <p:sp>
+        <p:nvSpPr>
+          <p:cNvPr id="53" name="Oval 52"/>
+          <p:cNvSpPr/>
+          <p:nvPr/>
+        </p:nvSpPr>
+        <p:spPr>
+          <a:xfrm>
+            <a:off x="10291572" y="3159252"/>
+            <a:ext cx="905256" cy="905256"/>
+          </a:xfrm>
+          <a:prstGeom prst="ellipse">
+            <a:avLst/>
+          </a:prstGeom>
+          <a:solidFill>
+            <a:srgbClr val="B09244"/>
+          </a:solidFill>
+          <a:ln>
+            <a:noFill/>
+          </a:ln>
+          <a:effectLst/>
+        </p:spPr>
+        <p:style>
+          <a:lnRef idx="1">
+            <a:schemeClr val="accent1"/>
+          </a:lnRef>
+          <a:fillRef idx="3">
+            <a:schemeClr val="accent1"/>
+          </a:fillRef>
+          <a:effectRef idx="2">
+            <a:schemeClr val="accent1"/>
+          </a:effectRef>
+          <a:fontRef idx="minor">
+            <a:schemeClr val="lt1"/>
+          </a:fontRef>
+        </p:style>
+        <p:txBody>
+          <a:bodyPr rtlCol="0" anchor="ctr"/>
+          <a:lstStyle/>
+          <a:p>
+            <a:pPr algn="ctr"/>
+          </a:p>
+        </p:txBody>
+      </p:sp>
+      <p:sp>
+        <p:nvSpPr>
+          <p:cNvPr id="54" name="Oval 53"/>
+          <p:cNvSpPr/>
+          <p:nvPr/>
+        </p:nvSpPr>
+        <p:spPr>
+          <a:xfrm>
+            <a:off x="10442448" y="3310128"/>
+            <a:ext cx="603504" cy="603504"/>
+          </a:xfrm>
+          <a:prstGeom prst="ellipse">
+            <a:avLst/>
+          </a:prstGeom>
+          <a:solidFill>
+            <a:srgbClr val="DAB462"/>
+          </a:solidFill>
+          <a:ln w="9525">
+            <a:solidFill>
+              <a:srgbClr val="0C332C"/>
+            </a:solidFill>
+          </a:ln>
+          <a:effectLst/>
+        </p:spPr>
+        <p:style>
+          <a:lnRef idx="1">
+            <a:schemeClr val="accent1"/>
+          </a:lnRef>
+          <a:fillRef idx="3">
+            <a:schemeClr val="accent1"/>
+          </a:fillRef>
+          <a:effectRef idx="2">
+            <a:schemeClr val="accent1"/>
+          </a:effectRef>
+          <a:fontRef idx="minor">
+            <a:schemeClr val="lt1"/>
+          </a:fontRef>
+        </p:style>
+        <p:txBody>
+          <a:bodyPr rtlCol="0" anchor="ctr"/>
+          <a:lstStyle/>
+          <a:p>
+            <a:pPr algn="ctr"/>
+          </a:p>
+        </p:txBody>
+      </p:sp>
+      <p:sp>
+        <p:nvSpPr>
+          <p:cNvPr id="55" name="Oval 54"/>
+          <p:cNvSpPr/>
+          <p:nvPr/>
+        </p:nvSpPr>
+        <p:spPr>
+          <a:xfrm>
+            <a:off x="10617464" y="3485144"/>
+            <a:ext cx="253471" cy="253471"/>
+          </a:xfrm>
+          <a:prstGeom prst="ellipse">
+            <a:avLst/>
+          </a:prstGeom>
+          <a:solidFill>
+            <a:srgbClr val="F2F7F5"/>
+          </a:solidFill>
+          <a:ln>
+            <a:noFill/>
+          </a:ln>
+          <a:effectLst/>
+        </p:spPr>
+        <p:style>
+          <a:lnRef idx="1">
+            <a:schemeClr val="accent1"/>
+          </a:lnRef>
+          <a:fillRef idx="3">
+            <a:schemeClr val="accent1"/>
+          </a:fillRef>
+          <a:effectRef idx="2">
+            <a:schemeClr val="accent1"/>
+          </a:effectRef>
+          <a:fontRef idx="minor">
+            <a:schemeClr val="lt1"/>
+          </a:fontRef>
+        </p:style>
+        <p:txBody>
+          <a:bodyPr rtlCol="0" anchor="ctr"/>
+          <a:lstStyle/>
+          <a:p>
+            <a:pPr algn="ctr"/>
+          </a:p>
+        </p:txBody>
+      </p:sp>
+      <p:sp>
+        <p:nvSpPr>
+          <p:cNvPr id="56" name="Oval 55"/>
+          <p:cNvSpPr/>
+          <p:nvPr/>
+        </p:nvSpPr>
+        <p:spPr>
+          <a:xfrm>
+            <a:off x="7635240" y="914400"/>
+            <a:ext cx="2194560" cy="2194560"/>
+          </a:xfrm>
+          <a:prstGeom prst="ellipse">
+            <a:avLst/>
+          </a:prstGeom>
+          <a:solidFill>
+            <a:srgbClr val="1C554C"/>
+          </a:solidFill>
+          <a:ln>
+            <a:noFill/>
+          </a:ln>
+          <a:effectLst/>
+        </p:spPr>
+        <p:style>
+          <a:lnRef idx="1">
+            <a:schemeClr val="accent1"/>
+          </a:lnRef>
+          <a:fillRef idx="3">
+            <a:schemeClr val="accent1"/>
+          </a:fillRef>
+          <a:effectRef idx="2">
+            <a:schemeClr val="accent1"/>
+          </a:effectRef>
+          <a:fontRef idx="minor">
+            <a:schemeClr val="lt1"/>
+          </a:fontRef>
+        </p:style>
+        <p:txBody>
+          <a:bodyPr rtlCol="0" anchor="ctr"/>
+          <a:lstStyle/>
+          <a:p>
+            <a:pPr algn="ctr"/>
+          </a:p>
+        </p:txBody>
+      </p:sp>
+      <p:sp>
+        <p:nvSpPr>
+          <p:cNvPr id="57" name="Oval 56"/>
+          <p:cNvSpPr/>
+          <p:nvPr/>
+        </p:nvSpPr>
+        <p:spPr>
+          <a:xfrm>
+            <a:off x="7964424" y="1243584"/>
+            <a:ext cx="1536192" cy="1536192"/>
+          </a:xfrm>
+          <a:prstGeom prst="ellipse">
+            <a:avLst/>
+          </a:prstGeom>
+          <a:solidFill>
+            <a:srgbClr val="2C7769"/>
+          </a:solidFill>
+          <a:ln>
+            <a:noFill/>
+          </a:ln>
+          <a:effectLst/>
+        </p:spPr>
+        <p:style>
+          <a:lnRef idx="1">
+            <a:schemeClr val="accent1"/>
+          </a:lnRef>
+          <a:fillRef idx="3">
+            <a:schemeClr val="accent1"/>
+          </a:fillRef>
+          <a:effectRef idx="2">
+            <a:schemeClr val="accent1"/>
+          </a:effectRef>
+          <a:fontRef idx="minor">
+            <a:schemeClr val="lt1"/>
+          </a:fontRef>
+        </p:style>
+        <p:txBody>
+          <a:bodyPr rtlCol="0" anchor="ctr"/>
+          <a:lstStyle/>
+          <a:p>
+            <a:pPr algn="ctr"/>
+          </a:p>
+        </p:txBody>
+      </p:sp>
+      <p:sp>
+        <p:nvSpPr>
+          <p:cNvPr id="58" name="Oval 57"/>
+          <p:cNvSpPr/>
+          <p:nvPr/>
+        </p:nvSpPr>
+        <p:spPr>
+          <a:xfrm>
+            <a:off x="8183880" y="1463040"/>
+            <a:ext cx="1097280" cy="1097280"/>
+          </a:xfrm>
+          <a:prstGeom prst="ellipse">
+            <a:avLst/>
+          </a:prstGeom>
+          <a:solidFill>
+            <a:srgbClr val="45A08E"/>
+          </a:solidFill>
+          <a:ln>
+            <a:noFill/>
+          </a:ln>
+          <a:effectLst/>
+        </p:spPr>
+        <p:style>
+          <a:lnRef idx="1">
+            <a:schemeClr val="accent1"/>
+          </a:lnRef>
+          <a:fillRef idx="3">
+            <a:schemeClr val="accent1"/>
+          </a:fillRef>
+          <a:effectRef idx="2">
+            <a:schemeClr val="accent1"/>
+          </a:effectRef>
+          <a:fontRef idx="minor">
+            <a:schemeClr val="lt1"/>
+          </a:fontRef>
+        </p:style>
+        <p:txBody>
+          <a:bodyPr rtlCol="0" anchor="ctr"/>
+          <a:lstStyle/>
+          <a:p>
+            <a:pPr algn="ctr"/>
+          </a:p>
+        </p:txBody>
+      </p:sp>
+      <p:sp>
+        <p:nvSpPr>
+          <p:cNvPr id="59" name="Oval 58"/>
+          <p:cNvSpPr/>
+          <p:nvPr/>
+        </p:nvSpPr>
+        <p:spPr>
+          <a:xfrm>
+            <a:off x="8366760" y="1645920"/>
+            <a:ext cx="731520" cy="731520"/>
+          </a:xfrm>
+          <a:prstGeom prst="ellipse">
+            <a:avLst/>
+          </a:prstGeom>
+          <a:solidFill>
+            <a:srgbClr val="5FC9B4"/>
+          </a:solidFill>
+          <a:ln w="9525">
+            <a:solidFill>
+              <a:srgbClr val="0C332C"/>
+            </a:solidFill>
+          </a:ln>
+          <a:effectLst/>
+        </p:spPr>
+        <p:style>
+          <a:lnRef idx="1">
+            <a:schemeClr val="accent1"/>
+          </a:lnRef>
+          <a:fillRef idx="3">
+            <a:schemeClr val="accent1"/>
+          </a:fillRef>
+          <a:effectRef idx="2">
+            <a:schemeClr val="accent1"/>
+          </a:effectRef>
+          <a:fontRef idx="minor">
+            <a:schemeClr val="lt1"/>
+          </a:fontRef>
+        </p:style>
+        <p:txBody>
+          <a:bodyPr rtlCol="0" anchor="ctr"/>
+          <a:lstStyle/>
+          <a:p>
+            <a:pPr algn="ctr"/>
+          </a:p>
+        </p:txBody>
+      </p:sp>
+      <p:sp>
+        <p:nvSpPr>
+          <p:cNvPr id="60" name="Oval 59"/>
+          <p:cNvSpPr/>
+          <p:nvPr/>
+        </p:nvSpPr>
+        <p:spPr>
+          <a:xfrm>
+            <a:off x="8578900" y="1858060"/>
+            <a:ext cx="307238" cy="307238"/>
+          </a:xfrm>
+          <a:prstGeom prst="ellipse">
+            <a:avLst/>
+          </a:prstGeom>
+          <a:solidFill>
+            <a:srgbClr val="F2F7F5"/>
+          </a:solidFill>
+          <a:ln>
+            <a:noFill/>
+          </a:ln>
+          <a:effectLst/>
+        </p:spPr>
+        <p:style>
+          <a:lnRef idx="1">
+            <a:schemeClr val="accent1"/>
+          </a:lnRef>
+          <a:fillRef idx="3">
+            <a:schemeClr val="accent1"/>
+          </a:fillRef>
+          <a:effectRef idx="2">
+            <a:schemeClr val="accent1"/>
+          </a:effectRef>
+          <a:fontRef idx="minor">
+            <a:schemeClr val="lt1"/>
+          </a:fontRef>
+        </p:style>
+        <p:txBody>
+          <a:bodyPr rtlCol="0" anchor="ctr"/>
+          <a:lstStyle/>
+          <a:p>
+            <a:pPr algn="ctr"/>
+          </a:p>
+        </p:txBody>
+      </p:sp>
+      <p:sp>
+        <p:nvSpPr>
+          <p:cNvPr id="61" name="TextBox 60"/>
           <p:cNvSpPr txBox="1"/>
           <p:nvPr/>
         </p:nvSpPr>
         <p:spPr>
           <a:xfrm>
             <a:off x="841248" y="603504"/>
-            <a:ext cx="5486400" cy="274320"/>
+            <a:ext cx="5852160" cy="274320"/>
           </a:xfrm>
           <a:prstGeom prst="rect">
             <a:avLst/>
@@ -3254,7 +5592,7 @@
       </p:sp>
       <p:sp>
         <p:nvSpPr>
-          <p:cNvPr id="5" name="TextBox 4"/>
+          <p:cNvPr id="62" name="TextBox 61"/>
           <p:cNvSpPr txBox="1"/>
           <p:nvPr/>
         </p:nvSpPr>
@@ -3299,7 +5637,7 @@
       </p:sp>
       <p:sp>
         <p:nvSpPr>
-          <p:cNvPr id="6" name="Rounded Rectangle 5"/>
+          <p:cNvPr id="63" name="Rounded Rectangle 62"/>
           <p:cNvSpPr/>
           <p:nvPr/>
         </p:nvSpPr>
@@ -3343,14 +5681,14 @@
       </p:sp>
       <p:sp>
         <p:nvSpPr>
-          <p:cNvPr id="7" name="TextBox 6"/>
+          <p:cNvPr id="64" name="TextBox 63"/>
           <p:cNvSpPr txBox="1"/>
           <p:nvPr/>
         </p:nvSpPr>
         <p:spPr>
           <a:xfrm>
             <a:off x="841248" y="2212848"/>
-            <a:ext cx="4892040" cy="1051560"/>
+            <a:ext cx="4754880" cy="1051560"/>
           </a:xfrm>
           <a:prstGeom prst="rect">
             <a:avLst/>
@@ -3388,13 +5726,13 @@
       </p:sp>
       <p:sp>
         <p:nvSpPr>
-          <p:cNvPr id="8" name="TextBox 7"/>
+          <p:cNvPr id="65" name="TextBox 64"/>
           <p:cNvSpPr txBox="1"/>
           <p:nvPr/>
         </p:nvSpPr>
         <p:spPr>
           <a:xfrm>
-            <a:off x="841248" y="3456432"/>
+            <a:off x="841248" y="3529584"/>
             <a:ext cx="4572000" cy="237744"/>
           </a:xfrm>
           <a:prstGeom prst="rect">
@@ -3433,13 +5771,13 @@
       </p:sp>
       <p:sp>
         <p:nvSpPr>
-          <p:cNvPr id="9" name="Oval 8"/>
+          <p:cNvPr id="66" name="Oval 65"/>
           <p:cNvSpPr/>
           <p:nvPr/>
         </p:nvSpPr>
         <p:spPr>
           <a:xfrm>
-            <a:off x="841248" y="3849623"/>
+            <a:off x="841248" y="3922776"/>
             <a:ext cx="137160" cy="137160"/>
           </a:xfrm>
           <a:prstGeom prst="ellipse">
@@ -3477,13 +5815,13 @@
       </p:sp>
       <p:sp>
         <p:nvSpPr>
-          <p:cNvPr id="10" name="TextBox 9"/>
+          <p:cNvPr id="67" name="TextBox 66"/>
           <p:cNvSpPr txBox="1"/>
           <p:nvPr/>
         </p:nvSpPr>
         <p:spPr>
           <a:xfrm>
-            <a:off x="1133856" y="3785615"/>
+            <a:off x="1133856" y="3858768"/>
             <a:ext cx="4480560" cy="310896"/>
           </a:xfrm>
           <a:prstGeom prst="rect">
@@ -3531,13 +5869,13 @@
       </p:sp>
       <p:sp>
         <p:nvSpPr>
-          <p:cNvPr id="11" name="Oval 10"/>
+          <p:cNvPr id="68" name="Oval 67"/>
           <p:cNvSpPr/>
           <p:nvPr/>
         </p:nvSpPr>
         <p:spPr>
           <a:xfrm>
-            <a:off x="841248" y="4325112"/>
+            <a:off x="841248" y="4398264"/>
             <a:ext cx="137160" cy="137160"/>
           </a:xfrm>
           <a:prstGeom prst="ellipse">
@@ -3575,13 +5913,13 @@
       </p:sp>
       <p:sp>
         <p:nvSpPr>
-          <p:cNvPr id="12" name="TextBox 11"/>
+          <p:cNvPr id="69" name="TextBox 68"/>
           <p:cNvSpPr txBox="1"/>
           <p:nvPr/>
         </p:nvSpPr>
         <p:spPr>
           <a:xfrm>
-            <a:off x="1133856" y="4261104"/>
+            <a:off x="1133856" y="4334256"/>
             <a:ext cx="4480560" cy="310896"/>
           </a:xfrm>
           <a:prstGeom prst="rect">
@@ -3629,13 +5967,13 @@
       </p:sp>
       <p:sp>
         <p:nvSpPr>
-          <p:cNvPr id="13" name="Oval 12"/>
+          <p:cNvPr id="70" name="Oval 69"/>
           <p:cNvSpPr/>
           <p:nvPr/>
         </p:nvSpPr>
         <p:spPr>
           <a:xfrm>
-            <a:off x="841248" y="4800600"/>
+            <a:off x="841248" y="4873752"/>
             <a:ext cx="137160" cy="137160"/>
           </a:xfrm>
           <a:prstGeom prst="ellipse">
@@ -3673,13 +6011,13 @@
       </p:sp>
       <p:sp>
         <p:nvSpPr>
-          <p:cNvPr id="14" name="TextBox 13"/>
+          <p:cNvPr id="71" name="TextBox 70"/>
           <p:cNvSpPr txBox="1"/>
           <p:nvPr/>
         </p:nvSpPr>
         <p:spPr>
           <a:xfrm>
-            <a:off x="1133856" y="4736592"/>
+            <a:off x="1133856" y="4809744"/>
             <a:ext cx="4480560" cy="310896"/>
           </a:xfrm>
           <a:prstGeom prst="rect">
@@ -3727,130 +6065,13 @@
       </p:sp>
       <p:sp>
         <p:nvSpPr>
-          <p:cNvPr id="15" name="Rounded Rectangle 14"/>
+          <p:cNvPr id="72" name="Rectangle 71"/>
           <p:cNvSpPr/>
           <p:nvPr/>
         </p:nvSpPr>
         <p:spPr>
           <a:xfrm>
-            <a:off x="6071616" y="1271016"/>
-            <a:ext cx="5504688" cy="3319272"/>
-          </a:xfrm>
-          <a:prstGeom prst="roundRect">
-            <a:avLst/>
-          </a:prstGeom>
-          <a:solidFill>
-            <a:srgbClr val="051E19"/>
-          </a:solidFill>
-          <a:ln>
-            <a:noFill/>
-          </a:ln>
-          <a:effectLst/>
-        </p:spPr>
-        <p:style>
-          <a:lnRef idx="1">
-            <a:schemeClr val="accent1"/>
-          </a:lnRef>
-          <a:fillRef idx="3">
-            <a:schemeClr val="accent1"/>
-          </a:fillRef>
-          <a:effectRef idx="2">
-            <a:schemeClr val="accent1"/>
-          </a:effectRef>
-          <a:fontRef idx="minor">
-            <a:schemeClr val="lt1"/>
-          </a:fontRef>
-        </p:style>
-        <p:txBody>
-          <a:bodyPr rtlCol="0" anchor="ctr"/>
-          <a:lstStyle/>
-          <a:p>
-            <a:pPr algn="ctr"/>
-          </a:p>
-        </p:txBody>
-      </p:sp>
-      <p:sp>
-        <p:nvSpPr>
-          <p:cNvPr id="16" name="Rounded Rectangle 15"/>
-          <p:cNvSpPr/>
-          <p:nvPr/>
-        </p:nvSpPr>
-        <p:spPr>
-          <a:xfrm>
-            <a:off x="5961888" y="1115568"/>
-            <a:ext cx="5614416" cy="3429000"/>
-          </a:xfrm>
-          <a:prstGeom prst="roundRect">
-            <a:avLst/>
-          </a:prstGeom>
-          <a:solidFill>
-            <a:srgbClr val="EAF1EF"/>
-          </a:solidFill>
-          <a:ln>
-            <a:noFill/>
-          </a:ln>
-          <a:effectLst/>
-        </p:spPr>
-        <p:style>
-          <a:lnRef idx="1">
-            <a:schemeClr val="accent1"/>
-          </a:lnRef>
-          <a:fillRef idx="3">
-            <a:schemeClr val="accent1"/>
-          </a:fillRef>
-          <a:effectRef idx="2">
-            <a:schemeClr val="accent1"/>
-          </a:effectRef>
-          <a:fontRef idx="minor">
-            <a:schemeClr val="lt1"/>
-          </a:fontRef>
-        </p:style>
-        <p:txBody>
-          <a:bodyPr rtlCol="0" anchor="ctr"/>
-          <a:lstStyle/>
-          <a:p>
-            <a:pPr algn="ctr"/>
-          </a:p>
-        </p:txBody>
-      </p:sp>
-      <p:pic>
-        <p:nvPicPr>
-          <p:cNvPr id="17" name="Picture 16" descr="osg_login_card.png"/>
-          <p:cNvPicPr>
-            <a:picLocks noChangeAspect="1"/>
-          </p:cNvPicPr>
-          <p:nvPr/>
-        </p:nvPicPr>
-        <p:blipFill>
-          <a:blip r:embed="rId2"/>
-          <a:stretch>
-            <a:fillRect/>
-          </a:stretch>
-        </p:blipFill>
-        <p:spPr>
-          <a:xfrm>
-            <a:off x="6016752" y="1170432"/>
-            <a:ext cx="5504688" cy="3319272"/>
-          </a:xfrm>
-          <a:prstGeom prst="rect">
-            <a:avLst/>
-          </a:prstGeom>
-          <a:ln w="9525">
-            <a:solidFill>
-              <a:srgbClr val="EAF1EF"/>
-            </a:solidFill>
-          </a:ln>
-        </p:spPr>
-      </p:pic>
-      <p:sp>
-        <p:nvSpPr>
-          <p:cNvPr id="18" name="Rectangle 17"/>
-          <p:cNvSpPr/>
-          <p:nvPr/>
-        </p:nvSpPr>
-        <p:spPr>
-          <a:xfrm>
-            <a:off x="841248" y="5504688"/>
+            <a:off x="841248" y="5577840"/>
             <a:ext cx="10509199" cy="12700"/>
           </a:xfrm>
           <a:prstGeom prst="rect">
@@ -3888,13 +6109,13 @@
       </p:sp>
       <p:sp>
         <p:nvSpPr>
-          <p:cNvPr id="19" name="TextBox 18"/>
+          <p:cNvPr id="73" name="TextBox 72"/>
           <p:cNvSpPr txBox="1"/>
           <p:nvPr/>
         </p:nvSpPr>
         <p:spPr>
           <a:xfrm>
-            <a:off x="0" y="5632704"/>
+            <a:off x="0" y="5705856"/>
             <a:ext cx="12191695" cy="256032"/>
           </a:xfrm>
           <a:prstGeom prst="rect">
@@ -3933,13 +6154,13 @@
       </p:sp>
       <p:sp>
         <p:nvSpPr>
-          <p:cNvPr id="20" name="Oval 19"/>
+          <p:cNvPr id="74" name="Oval 73"/>
           <p:cNvSpPr/>
           <p:nvPr/>
         </p:nvSpPr>
         <p:spPr>
           <a:xfrm>
-            <a:off x="2066544" y="6007608"/>
+            <a:off x="2066544" y="6062472"/>
             <a:ext cx="530352" cy="530352"/>
           </a:xfrm>
           <a:prstGeom prst="ellipse">
@@ -3979,13 +6200,13 @@
       </p:sp>
       <p:sp>
         <p:nvSpPr>
-          <p:cNvPr id="21" name="Oval 20"/>
+          <p:cNvPr id="75" name="Oval 74"/>
           <p:cNvSpPr/>
           <p:nvPr/>
         </p:nvSpPr>
         <p:spPr>
           <a:xfrm>
-            <a:off x="2252168" y="6092464"/>
+            <a:off x="2252168" y="6147328"/>
             <a:ext cx="159105" cy="159105"/>
           </a:xfrm>
           <a:prstGeom prst="ellipse">
@@ -4023,13 +6244,13 @@
       </p:sp>
       <p:sp>
         <p:nvSpPr>
-          <p:cNvPr id="22" name="Oval 21"/>
+          <p:cNvPr id="76" name="Oval 75"/>
           <p:cNvSpPr/>
           <p:nvPr/>
         </p:nvSpPr>
         <p:spPr>
           <a:xfrm>
-            <a:off x="2172615" y="6293998"/>
+            <a:off x="2172615" y="6348862"/>
             <a:ext cx="318211" cy="243961"/>
           </a:xfrm>
           <a:prstGeom prst="ellipse">
@@ -4067,13 +6288,13 @@
       </p:sp>
       <p:sp>
         <p:nvSpPr>
-          <p:cNvPr id="23" name="TextBox 22"/>
+          <p:cNvPr id="77" name="TextBox 76"/>
           <p:cNvSpPr txBox="1"/>
           <p:nvPr/>
         </p:nvSpPr>
         <p:spPr>
           <a:xfrm>
-            <a:off x="1691640" y="6601968"/>
+            <a:off x="1691640" y="6656832"/>
             <a:ext cx="1280160" cy="219456"/>
           </a:xfrm>
           <a:prstGeom prst="rect">
@@ -4112,13 +6333,13 @@
       </p:sp>
       <p:sp>
         <p:nvSpPr>
-          <p:cNvPr id="24" name="Oval 23"/>
+          <p:cNvPr id="78" name="Oval 77"/>
           <p:cNvSpPr/>
           <p:nvPr/>
         </p:nvSpPr>
         <p:spPr>
           <a:xfrm>
-            <a:off x="4078224" y="6007608"/>
+            <a:off x="4078224" y="6062472"/>
             <a:ext cx="530352" cy="530352"/>
           </a:xfrm>
           <a:prstGeom prst="ellipse">
@@ -4158,13 +6379,13 @@
       </p:sp>
       <p:sp>
         <p:nvSpPr>
-          <p:cNvPr id="25" name="Oval 24"/>
+          <p:cNvPr id="79" name="Oval 78"/>
           <p:cNvSpPr/>
           <p:nvPr/>
         </p:nvSpPr>
         <p:spPr>
           <a:xfrm>
-            <a:off x="4263848" y="6092464"/>
+            <a:off x="4263848" y="6147328"/>
             <a:ext cx="159105" cy="159105"/>
           </a:xfrm>
           <a:prstGeom prst="ellipse">
@@ -4202,13 +6423,13 @@
       </p:sp>
       <p:sp>
         <p:nvSpPr>
-          <p:cNvPr id="26" name="Oval 25"/>
+          <p:cNvPr id="80" name="Oval 79"/>
           <p:cNvSpPr/>
           <p:nvPr/>
         </p:nvSpPr>
         <p:spPr>
           <a:xfrm>
-            <a:off x="4184295" y="6293998"/>
+            <a:off x="4184295" y="6348862"/>
             <a:ext cx="318211" cy="243961"/>
           </a:xfrm>
           <a:prstGeom prst="ellipse">
@@ -4246,13 +6467,13 @@
       </p:sp>
       <p:sp>
         <p:nvSpPr>
-          <p:cNvPr id="27" name="TextBox 26"/>
+          <p:cNvPr id="81" name="TextBox 80"/>
           <p:cNvSpPr txBox="1"/>
           <p:nvPr/>
         </p:nvSpPr>
         <p:spPr>
           <a:xfrm>
-            <a:off x="3703320" y="6601968"/>
+            <a:off x="3703320" y="6656832"/>
             <a:ext cx="1280160" cy="219456"/>
           </a:xfrm>
           <a:prstGeom prst="rect">
@@ -4291,13 +6512,13 @@
       </p:sp>
       <p:sp>
         <p:nvSpPr>
-          <p:cNvPr id="28" name="Oval 27"/>
+          <p:cNvPr id="82" name="Oval 81"/>
           <p:cNvSpPr/>
           <p:nvPr/>
         </p:nvSpPr>
         <p:spPr>
           <a:xfrm>
-            <a:off x="6089904" y="6007608"/>
+            <a:off x="6089904" y="6062472"/>
             <a:ext cx="530352" cy="530352"/>
           </a:xfrm>
           <a:prstGeom prst="ellipse">
@@ -4337,13 +6558,13 @@
       </p:sp>
       <p:sp>
         <p:nvSpPr>
-          <p:cNvPr id="29" name="Oval 28"/>
+          <p:cNvPr id="83" name="Oval 82"/>
           <p:cNvSpPr/>
           <p:nvPr/>
         </p:nvSpPr>
         <p:spPr>
           <a:xfrm>
-            <a:off x="6275528" y="6092464"/>
+            <a:off x="6275528" y="6147328"/>
             <a:ext cx="159105" cy="159105"/>
           </a:xfrm>
           <a:prstGeom prst="ellipse">
@@ -4381,13 +6602,13 @@
       </p:sp>
       <p:sp>
         <p:nvSpPr>
-          <p:cNvPr id="30" name="Oval 29"/>
+          <p:cNvPr id="84" name="Oval 83"/>
           <p:cNvSpPr/>
           <p:nvPr/>
         </p:nvSpPr>
         <p:spPr>
           <a:xfrm>
-            <a:off x="6195975" y="6293998"/>
+            <a:off x="6195975" y="6348862"/>
             <a:ext cx="318211" cy="243961"/>
           </a:xfrm>
           <a:prstGeom prst="ellipse">
@@ -4425,13 +6646,13 @@
       </p:sp>
       <p:sp>
         <p:nvSpPr>
-          <p:cNvPr id="31" name="TextBox 30"/>
+          <p:cNvPr id="85" name="TextBox 84"/>
           <p:cNvSpPr txBox="1"/>
           <p:nvPr/>
         </p:nvSpPr>
         <p:spPr>
           <a:xfrm>
-            <a:off x="5715000" y="6601968"/>
+            <a:off x="5715000" y="6656832"/>
             <a:ext cx="1280160" cy="219456"/>
           </a:xfrm>
           <a:prstGeom prst="rect">
@@ -4470,13 +6691,13 @@
       </p:sp>
       <p:sp>
         <p:nvSpPr>
-          <p:cNvPr id="32" name="Oval 31"/>
+          <p:cNvPr id="86" name="Oval 85"/>
           <p:cNvSpPr/>
           <p:nvPr/>
         </p:nvSpPr>
         <p:spPr>
           <a:xfrm>
-            <a:off x="8101584" y="6007608"/>
+            <a:off x="8101584" y="6062472"/>
             <a:ext cx="530352" cy="530352"/>
           </a:xfrm>
           <a:prstGeom prst="ellipse">
@@ -4516,13 +6737,13 @@
       </p:sp>
       <p:sp>
         <p:nvSpPr>
-          <p:cNvPr id="33" name="Oval 32"/>
+          <p:cNvPr id="87" name="Oval 86"/>
           <p:cNvSpPr/>
           <p:nvPr/>
         </p:nvSpPr>
         <p:spPr>
           <a:xfrm>
-            <a:off x="8287208" y="6092464"/>
+            <a:off x="8287208" y="6147328"/>
             <a:ext cx="159105" cy="159105"/>
           </a:xfrm>
           <a:prstGeom prst="ellipse">
@@ -4560,13 +6781,13 @@
       </p:sp>
       <p:sp>
         <p:nvSpPr>
-          <p:cNvPr id="34" name="Oval 33"/>
+          <p:cNvPr id="88" name="Oval 87"/>
           <p:cNvSpPr/>
           <p:nvPr/>
         </p:nvSpPr>
         <p:spPr>
           <a:xfrm>
-            <a:off x="8207655" y="6293998"/>
+            <a:off x="8207655" y="6348862"/>
             <a:ext cx="318211" cy="243961"/>
           </a:xfrm>
           <a:prstGeom prst="ellipse">
@@ -4604,13 +6825,13 @@
       </p:sp>
       <p:sp>
         <p:nvSpPr>
-          <p:cNvPr id="35" name="TextBox 34"/>
+          <p:cNvPr id="89" name="TextBox 88"/>
           <p:cNvSpPr txBox="1"/>
           <p:nvPr/>
         </p:nvSpPr>
         <p:spPr>
           <a:xfrm>
-            <a:off x="7726680" y="6601968"/>
+            <a:off x="7726680" y="6656832"/>
             <a:ext cx="1280160" cy="219456"/>
           </a:xfrm>
           <a:prstGeom prst="rect">
@@ -4649,13 +6870,13 @@
       </p:sp>
       <p:sp>
         <p:nvSpPr>
-          <p:cNvPr id="36" name="Oval 35"/>
+          <p:cNvPr id="90" name="Oval 89"/>
           <p:cNvSpPr/>
           <p:nvPr/>
         </p:nvSpPr>
         <p:spPr>
           <a:xfrm>
-            <a:off x="10113264" y="6007608"/>
+            <a:off x="10113264" y="6062472"/>
             <a:ext cx="530352" cy="530352"/>
           </a:xfrm>
           <a:prstGeom prst="ellipse">
@@ -4695,13 +6916,13 @@
       </p:sp>
       <p:sp>
         <p:nvSpPr>
-          <p:cNvPr id="37" name="Oval 36"/>
+          <p:cNvPr id="91" name="Oval 90"/>
           <p:cNvSpPr/>
           <p:nvPr/>
         </p:nvSpPr>
         <p:spPr>
           <a:xfrm>
-            <a:off x="10298888" y="6092464"/>
+            <a:off x="10298888" y="6147328"/>
             <a:ext cx="159105" cy="159105"/>
           </a:xfrm>
           <a:prstGeom prst="ellipse">
@@ -4739,13 +6960,13 @@
       </p:sp>
       <p:sp>
         <p:nvSpPr>
-          <p:cNvPr id="38" name="Oval 37"/>
+          <p:cNvPr id="92" name="Oval 91"/>
           <p:cNvSpPr/>
           <p:nvPr/>
         </p:nvSpPr>
         <p:spPr>
           <a:xfrm>
-            <a:off x="10219335" y="6293998"/>
+            <a:off x="10219335" y="6348862"/>
             <a:ext cx="318211" cy="243961"/>
           </a:xfrm>
           <a:prstGeom prst="ellipse">
@@ -4783,13 +7004,13 @@
       </p:sp>
       <p:sp>
         <p:nvSpPr>
-          <p:cNvPr id="39" name="TextBox 38"/>
+          <p:cNvPr id="93" name="TextBox 92"/>
           <p:cNvSpPr txBox="1"/>
           <p:nvPr/>
         </p:nvSpPr>
         <p:spPr>
           <a:xfrm>
-            <a:off x="9738360" y="6601968"/>
+            <a:off x="9738360" y="6656832"/>
             <a:ext cx="1280160" cy="219456"/>
           </a:xfrm>
           <a:prstGeom prst="rect">
@@ -4967,7 +7188,7 @@
               </a:spcAft>
             </a:pPr>
             <a:r>
-              <a:rPr sz="2400" b="1" i="0">
+              <a:rPr sz="1900" b="1" i="0">
                 <a:solidFill>
                   <a:srgbClr val="24282C"/>
                 </a:solidFill>
@@ -5150,7 +7371,7 @@
                 </a:solidFill>
                 <a:latin typeface="Calibri"/>
               </a:rPr>
-              <a:t>Source: OSG Smart Guide · internal analysis</a:t>
+              <a:t>OSG AI Assistant Banking</a:t>
             </a:r>
           </a:p>
         </p:txBody>
@@ -6218,7 +8439,7 @@
               </a:spcAft>
             </a:pPr>
             <a:r>
-              <a:rPr sz="2400" b="1" i="0">
+              <a:rPr sz="1900" b="1" i="0">
                 <a:solidFill>
                   <a:srgbClr val="24282C"/>
                 </a:solidFill>
@@ -6401,7 +8622,7 @@
                 </a:solidFill>
                 <a:latin typeface="Calibri"/>
               </a:rPr>
-              <a:t>Source: OSG Smart Guide · internal analysis</a:t>
+              <a:t>OSG AI Assistant Banking</a:t>
             </a:r>
           </a:p>
         </p:txBody>
@@ -7861,7 +10082,7 @@
               </a:spcAft>
             </a:pPr>
             <a:r>
-              <a:rPr sz="2400" b="1" i="0">
+              <a:rPr sz="1900" b="1" i="0">
                 <a:solidFill>
                   <a:srgbClr val="24282C"/>
                 </a:solidFill>
@@ -8044,7 +10265,7 @@
                 </a:solidFill>
                 <a:latin typeface="Calibri"/>
               </a:rPr>
-              <a:t>Source: OSG Smart Guide · internal analysis</a:t>
+              <a:t>OSG AI Assistant Banking</a:t>
             </a:r>
           </a:p>
         </p:txBody>
@@ -9504,7 +11725,7 @@
               </a:spcAft>
             </a:pPr>
             <a:r>
-              <a:rPr sz="2400" b="1" i="0">
+              <a:rPr sz="1900" b="1" i="0">
                 <a:solidFill>
                   <a:srgbClr val="24282C"/>
                 </a:solidFill>
@@ -9687,7 +11908,7 @@
                 </a:solidFill>
                 <a:latin typeface="Calibri"/>
               </a:rPr>
-              <a:t>Source: OSG Smart Guide · internal analysis</a:t>
+              <a:t>OSG AI Assistant Banking</a:t>
             </a:r>
           </a:p>
         </p:txBody>
@@ -10949,7 +13170,7 @@
               </a:spcAft>
             </a:pPr>
             <a:r>
-              <a:rPr sz="2400" b="1" i="0">
+              <a:rPr sz="1900" b="1" i="0">
                 <a:solidFill>
                   <a:srgbClr val="24282C"/>
                 </a:solidFill>
@@ -11132,7 +13353,7 @@
                 </a:solidFill>
                 <a:latin typeface="Calibri"/>
               </a:rPr>
-              <a:t>Source: OSG Smart Guide · internal analysis</a:t>
+              <a:t>OSG AI Assistant Banking</a:t>
             </a:r>
           </a:p>
         </p:txBody>
@@ -11774,7 +13995,7 @@
                 </a:solidFill>
                 <a:latin typeface="Calibri"/>
               </a:rPr>
-              <a:t>2,758 documents in 51 categories, filtered by product or promo.</a:t>
+              <a:t>751 documents across 51 categories, filtered by product or promo.</a:t>
             </a:r>
           </a:p>
         </p:txBody>
@@ -12687,7 +14908,7 @@
               </a:spcAft>
             </a:pPr>
             <a:r>
-              <a:rPr sz="2400" b="1" i="0">
+              <a:rPr sz="1900" b="1" i="0">
                 <a:solidFill>
                   <a:srgbClr val="24282C"/>
                 </a:solidFill>
@@ -12870,7 +15091,7 @@
                 </a:solidFill>
                 <a:latin typeface="Calibri"/>
               </a:rPr>
-              <a:t>Source: OSG Smart Guide · internal analysis</a:t>
+              <a:t>OSG AI Assistant Banking</a:t>
             </a:r>
           </a:p>
         </p:txBody>
@@ -13841,7 +16062,7 @@
               </a:spcAft>
             </a:pPr>
             <a:r>
-              <a:rPr sz="2400" b="1" i="0">
+              <a:rPr sz="1900" b="1" i="0">
                 <a:solidFill>
                   <a:srgbClr val="24282C"/>
                 </a:solidFill>
@@ -14024,7 +16245,7 @@
                 </a:solidFill>
                 <a:latin typeface="Calibri"/>
               </a:rPr>
-              <a:t>Source: OSG Smart Guide · internal analysis</a:t>
+              <a:t>OSG AI Assistant Banking</a:t>
             </a:r>
           </a:p>
         </p:txBody>
@@ -15033,7 +17254,7 @@
                 </a:solidFill>
                 <a:latin typeface="Calibri"/>
               </a:rPr>
-              <a:t>2,758</a:t>
+              <a:t>326</a:t>
             </a:r>
           </a:p>
         </p:txBody>
@@ -15078,7 +17299,7 @@
                 </a:solidFill>
                 <a:latin typeface="Calibri"/>
               </a:rPr>
-              <a:t>documents already live · 51 categories</a:t>
+              <a:t>products &amp; promos live · 51 categories</a:t>
             </a:r>
           </a:p>
         </p:txBody>
@@ -15224,7 +17445,7 @@
               </a:spcAft>
             </a:pPr>
             <a:r>
-              <a:rPr sz="2000" b="1" i="0">
+              <a:rPr sz="1900" b="1" i="0">
                 <a:solidFill>
                   <a:srgbClr val="24282C"/>
                 </a:solidFill>
@@ -15407,7 +17628,7 @@
                 </a:solidFill>
                 <a:latin typeface="Calibri"/>
               </a:rPr>
-              <a:t>Source: OSG Smart Guide · internal analysis</a:t>
+              <a:t>OSG AI Assistant Banking</a:t>
             </a:r>
           </a:p>
         </p:txBody>
@@ -18248,7 +20469,7 @@
                 </a:solidFill>
                 <a:latin typeface="Calibri"/>
               </a:rPr>
-              <a:t>Source: internal analysis · EES 2025, NPS H1 2025</a:t>
+              <a:t>OSG AI Assistant Banking</a:t>
             </a:r>
           </a:p>
         </p:txBody>
@@ -21228,7 +23449,7 @@
               </a:spcAft>
             </a:pPr>
             <a:r>
-              <a:rPr sz="2400" b="1" i="0">
+              <a:rPr sz="1900" b="1" i="0">
                 <a:solidFill>
                   <a:srgbClr val="24282C"/>
                 </a:solidFill>
@@ -21411,7 +23632,7 @@
                 </a:solidFill>
                 <a:latin typeface="Calibri"/>
               </a:rPr>
-              <a:t>Source: OSG live-pilot usage, 6 Apr to 6 Jul 2026</a:t>
+              <a:t>OSG AI Assistant Banking</a:t>
             </a:r>
           </a:p>
         </p:txBody>
@@ -23532,7 +25753,7 @@
                 </a:solidFill>
                 <a:latin typeface="Calibri"/>
               </a:rPr>
-              <a:t>Source: OSG Smart Guide · internal analysis</a:t>
+              <a:t>OSG AI Assistant Banking</a:t>
             </a:r>
           </a:p>
         </p:txBody>
@@ -25439,7 +27660,7 @@
                 </a:solidFill>
                 <a:latin typeface="Calibri"/>
               </a:rPr>
-              <a:t>Source: OSG Smart Guide · internal analysis</a:t>
+              <a:t>OSG AI Assistant Banking</a:t>
             </a:r>
           </a:p>
         </p:txBody>
@@ -27598,7 +29819,7 @@
                 </a:solidFill>
                 <a:latin typeface="Calibri"/>
               </a:rPr>
-              <a:t>Source: OSG Smart Guide · internal analysis</a:t>
+              <a:t>OSG AI Assistant Banking</a:t>
             </a:r>
           </a:p>
         </p:txBody>

</xml_diff>

<commit_message>
cover: white-dominant knowledge-graph, red + green accents, enlarged team photos, stats block removed; exec summary reworded
</commit_message>
<xml_diff>
--- a/OSG-Smart-Guide.pptx
+++ b/OSG-Smart-Guide.pptx
@@ -3116,17 +3116,9 @@
           <a:prstGeom prst="rect">
             <a:avLst/>
           </a:prstGeom>
-          <a:gradFill rotWithShape="1">
-            <a:gsLst>
-              <a:gs pos="0">
-                <a:srgbClr val="2A7464"/>
-              </a:gs>
-              <a:gs pos="100000">
-                <a:srgbClr val="082C27"/>
-              </a:gs>
-            </a:gsLst>
-            <a:lin scaled="0" ang="18000000"/>
-          </a:gradFill>
+          <a:solidFill>
+            <a:srgbClr val="FFFFFF"/>
+          </a:solidFill>
           <a:ln>
             <a:noFill/>
           </a:ln>
@@ -3169,7 +3161,7 @@
             <a:avLst/>
           </a:prstGeom>
           <a:solidFill>
-            <a:srgbClr val="4E6B84"/>
+            <a:srgbClr val="E4002B"/>
           </a:solidFill>
           <a:ln>
             <a:noFill/>
@@ -3206,15 +3198,15 @@
         </p:nvCxnSpPr>
         <p:spPr>
           <a:xfrm flipH="1" flipV="1">
-            <a:off x="6720840" y="1188720"/>
-            <a:ext cx="2011680" cy="822960"/>
+            <a:off x="7178040" y="1234440"/>
+            <a:ext cx="1737360" cy="777240"/>
           </a:xfrm>
           <a:prstGeom prst="line">
             <a:avLst/>
           </a:prstGeom>
           <a:ln w="9525">
             <a:solidFill>
-              <a:srgbClr val="4A9384"/>
+              <a:srgbClr val="D7DCE1"/>
             </a:solidFill>
           </a:ln>
           <a:effectLst/>
@@ -3242,15 +3234,15 @@
         </p:nvCxnSpPr>
         <p:spPr>
           <a:xfrm flipH="1" flipV="1">
-            <a:off x="7955279" y="841248"/>
-            <a:ext cx="777241" cy="1170432"/>
+            <a:off x="8275320" y="868680"/>
+            <a:ext cx="640080" cy="1143000"/>
           </a:xfrm>
           <a:prstGeom prst="line">
             <a:avLst/>
           </a:prstGeom>
           <a:ln w="9525">
             <a:solidFill>
-              <a:srgbClr val="4A9384"/>
+              <a:srgbClr val="D7DCE1"/>
             </a:solidFill>
           </a:ln>
           <a:effectLst/>
@@ -3278,15 +3270,15 @@
         </p:nvCxnSpPr>
         <p:spPr>
           <a:xfrm flipV="1">
-            <a:off x="8732520" y="1234440"/>
-            <a:ext cx="1188720" cy="777240"/>
+            <a:off x="8915400" y="1234440"/>
+            <a:ext cx="1143000" cy="777240"/>
           </a:xfrm>
           <a:prstGeom prst="line">
             <a:avLst/>
           </a:prstGeom>
           <a:ln w="9525">
             <a:solidFill>
-              <a:srgbClr val="4A9384"/>
+              <a:srgbClr val="D7DCE1"/>
             </a:solidFill>
           </a:ln>
           <a:effectLst/>
@@ -3314,15 +3306,15 @@
         </p:nvCxnSpPr>
         <p:spPr>
           <a:xfrm flipH="1">
-            <a:off x="7726679" y="2011680"/>
-            <a:ext cx="1005841" cy="914400"/>
+            <a:off x="8046720" y="2011680"/>
+            <a:ext cx="868680" cy="914400"/>
           </a:xfrm>
           <a:prstGeom prst="line">
             <a:avLst/>
           </a:prstGeom>
           <a:ln w="9525">
             <a:solidFill>
-              <a:srgbClr val="4A9384"/>
+              <a:srgbClr val="D7DCE1"/>
             </a:solidFill>
           </a:ln>
           <a:effectLst/>
@@ -3350,15 +3342,15 @@
         </p:nvCxnSpPr>
         <p:spPr>
           <a:xfrm>
-            <a:off x="8732520" y="2011680"/>
-            <a:ext cx="822960" cy="685800"/>
+            <a:off x="8915400" y="2011680"/>
+            <a:ext cx="777240" cy="685800"/>
           </a:xfrm>
           <a:prstGeom prst="line">
             <a:avLst/>
           </a:prstGeom>
           <a:ln w="9525">
             <a:solidFill>
-              <a:srgbClr val="4A9384"/>
+              <a:srgbClr val="D7DCE1"/>
             </a:solidFill>
           </a:ln>
           <a:effectLst/>
@@ -3386,15 +3378,15 @@
         </p:nvCxnSpPr>
         <p:spPr>
           <a:xfrm flipH="1" flipV="1">
-            <a:off x="7452360" y="1920240"/>
-            <a:ext cx="1280160" cy="91440"/>
+            <a:off x="7726679" y="1965960"/>
+            <a:ext cx="1188721" cy="45720"/>
           </a:xfrm>
           <a:prstGeom prst="line">
             <a:avLst/>
           </a:prstGeom>
           <a:ln w="9525">
             <a:solidFill>
-              <a:srgbClr val="4A9384"/>
+              <a:srgbClr val="D7DCE1"/>
             </a:solidFill>
           </a:ln>
           <a:effectLst/>
@@ -3422,15 +3414,15 @@
         </p:nvCxnSpPr>
         <p:spPr>
           <a:xfrm flipH="1">
-            <a:off x="7040880" y="2011680"/>
-            <a:ext cx="1691640" cy="1920240"/>
+            <a:off x="7360920" y="2011680"/>
+            <a:ext cx="1554480" cy="1920240"/>
           </a:xfrm>
           <a:prstGeom prst="line">
             <a:avLst/>
           </a:prstGeom>
           <a:ln w="9525">
             <a:solidFill>
-              <a:srgbClr val="4A9384"/>
+              <a:srgbClr val="D7DCE1"/>
             </a:solidFill>
           </a:ln>
           <a:effectLst/>
@@ -3458,15 +3450,15 @@
         </p:nvCxnSpPr>
         <p:spPr>
           <a:xfrm flipH="1" flipV="1">
-            <a:off x="9921240" y="1234440"/>
-            <a:ext cx="822960" cy="2377440"/>
+            <a:off x="10058400" y="1234440"/>
+            <a:ext cx="777240" cy="2377440"/>
           </a:xfrm>
           <a:prstGeom prst="line">
             <a:avLst/>
           </a:prstGeom>
           <a:ln w="9525">
             <a:solidFill>
-              <a:srgbClr val="4A9384"/>
+              <a:srgbClr val="D7DCE1"/>
             </a:solidFill>
           </a:ln>
           <a:effectLst/>
@@ -3494,15 +3486,15 @@
         </p:nvCxnSpPr>
         <p:spPr>
           <a:xfrm flipV="1">
-            <a:off x="10744200" y="1965960"/>
-            <a:ext cx="731520" cy="1645920"/>
+            <a:off x="10835640" y="2011680"/>
+            <a:ext cx="704088" cy="1600200"/>
           </a:xfrm>
           <a:prstGeom prst="line">
             <a:avLst/>
           </a:prstGeom>
           <a:ln w="9525">
             <a:solidFill>
-              <a:srgbClr val="4A9384"/>
+              <a:srgbClr val="D7DCE1"/>
             </a:solidFill>
           </a:ln>
           <a:effectLst/>
@@ -3530,15 +3522,15 @@
         </p:nvCxnSpPr>
         <p:spPr>
           <a:xfrm flipH="1" flipV="1">
-            <a:off x="9555480" y="2697480"/>
-            <a:ext cx="1188720" cy="914400"/>
+            <a:off x="9692640" y="2697480"/>
+            <a:ext cx="1143000" cy="914400"/>
           </a:xfrm>
           <a:prstGeom prst="line">
             <a:avLst/>
           </a:prstGeom>
           <a:ln w="9525">
             <a:solidFill>
-              <a:srgbClr val="4A9384"/>
+              <a:srgbClr val="D7DCE1"/>
             </a:solidFill>
           </a:ln>
           <a:effectLst/>
@@ -3566,7 +3558,7 @@
         </p:nvCxnSpPr>
         <p:spPr>
           <a:xfrm>
-            <a:off x="10744200" y="3611880"/>
+            <a:off x="10835640" y="3611880"/>
             <a:ext cx="548640" cy="1005840"/>
           </a:xfrm>
           <a:prstGeom prst="line">
@@ -3574,7 +3566,7 @@
           </a:prstGeom>
           <a:ln w="9525">
             <a:solidFill>
-              <a:srgbClr val="4A9384"/>
+              <a:srgbClr val="D7DCE1"/>
             </a:solidFill>
           </a:ln>
           <a:effectLst/>
@@ -3602,7 +3594,7 @@
         </p:nvCxnSpPr>
         <p:spPr>
           <a:xfrm flipH="1">
-            <a:off x="10104120" y="3611880"/>
+            <a:off x="10195560" y="3611880"/>
             <a:ext cx="640080" cy="548640"/>
           </a:xfrm>
           <a:prstGeom prst="line">
@@ -3610,7 +3602,7 @@
           </a:prstGeom>
           <a:ln w="9525">
             <a:solidFill>
-              <a:srgbClr val="4A9384"/>
+              <a:srgbClr val="D7DCE1"/>
             </a:solidFill>
           </a:ln>
           <a:effectLst/>
@@ -3638,15 +3630,15 @@
         </p:nvCxnSpPr>
         <p:spPr>
           <a:xfrm flipV="1">
-            <a:off x="10744200" y="3063240"/>
-            <a:ext cx="1161288" cy="548640"/>
+            <a:off x="10835640" y="3063240"/>
+            <a:ext cx="1097280" cy="548640"/>
           </a:xfrm>
           <a:prstGeom prst="line">
             <a:avLst/>
           </a:prstGeom>
           <a:ln w="9525">
             <a:solidFill>
-              <a:srgbClr val="4A9384"/>
+              <a:srgbClr val="D7DCE1"/>
             </a:solidFill>
           </a:ln>
           <a:effectLst/>
@@ -3674,15 +3666,15 @@
         </p:nvCxnSpPr>
         <p:spPr>
           <a:xfrm flipH="1">
-            <a:off x="9646920" y="3611880"/>
-            <a:ext cx="1097280" cy="1188720"/>
+            <a:off x="9784080" y="3611880"/>
+            <a:ext cx="1051560" cy="1188720"/>
           </a:xfrm>
           <a:prstGeom prst="line">
             <a:avLst/>
           </a:prstGeom>
           <a:ln w="9525">
             <a:solidFill>
-              <a:srgbClr val="4A9384"/>
+              <a:srgbClr val="D7DCE1"/>
             </a:solidFill>
           </a:ln>
           <a:effectLst/>
@@ -3710,15 +3702,15 @@
         </p:nvCxnSpPr>
         <p:spPr>
           <a:xfrm flipH="1" flipV="1">
-            <a:off x="6053328" y="2331720"/>
-            <a:ext cx="987552" cy="1600200"/>
+            <a:off x="6812280" y="2468880"/>
+            <a:ext cx="548640" cy="1463040"/>
           </a:xfrm>
           <a:prstGeom prst="line">
             <a:avLst/>
           </a:prstGeom>
           <a:ln w="9525">
             <a:solidFill>
-              <a:srgbClr val="4A9384"/>
+              <a:srgbClr val="D7DCE1"/>
             </a:solidFill>
           </a:ln>
           <a:effectLst/>
@@ -3746,15 +3738,15 @@
         </p:nvCxnSpPr>
         <p:spPr>
           <a:xfrm flipH="1" flipV="1">
-            <a:off x="5806440" y="3310128"/>
-            <a:ext cx="1234440" cy="621792"/>
+            <a:off x="6675120" y="3401568"/>
+            <a:ext cx="685800" cy="530352"/>
           </a:xfrm>
           <a:prstGeom prst="line">
             <a:avLst/>
           </a:prstGeom>
           <a:ln w="9525">
             <a:solidFill>
-              <a:srgbClr val="4A9384"/>
+              <a:srgbClr val="D7DCE1"/>
             </a:solidFill>
           </a:ln>
           <a:effectLst/>
@@ -3782,15 +3774,15 @@
         </p:nvCxnSpPr>
         <p:spPr>
           <a:xfrm flipV="1">
-            <a:off x="7040880" y="2926080"/>
-            <a:ext cx="685799" cy="1005840"/>
+            <a:off x="7360920" y="2926080"/>
+            <a:ext cx="685800" cy="1005840"/>
           </a:xfrm>
           <a:prstGeom prst="line">
             <a:avLst/>
           </a:prstGeom>
           <a:ln w="9525">
             <a:solidFill>
-              <a:srgbClr val="4A9384"/>
+              <a:srgbClr val="D7DCE1"/>
             </a:solidFill>
           </a:ln>
           <a:effectLst/>
@@ -3818,15 +3810,15 @@
         </p:nvCxnSpPr>
         <p:spPr>
           <a:xfrm>
-            <a:off x="7040880" y="3931920"/>
-            <a:ext cx="1234440" cy="640080"/>
+            <a:off x="7360920" y="3931920"/>
+            <a:ext cx="1097280" cy="685800"/>
           </a:xfrm>
           <a:prstGeom prst="line">
             <a:avLst/>
           </a:prstGeom>
           <a:ln w="9525">
             <a:solidFill>
-              <a:srgbClr val="4A9384"/>
+              <a:srgbClr val="D7DCE1"/>
             </a:solidFill>
           </a:ln>
           <a:effectLst/>
@@ -3854,15 +3846,15 @@
         </p:nvCxnSpPr>
         <p:spPr>
           <a:xfrm flipH="1">
-            <a:off x="6537960" y="3931920"/>
-            <a:ext cx="502920" cy="960120"/>
+            <a:off x="6903720" y="3931920"/>
+            <a:ext cx="457200" cy="960120"/>
           </a:xfrm>
           <a:prstGeom prst="line">
             <a:avLst/>
           </a:prstGeom>
           <a:ln w="9525">
             <a:solidFill>
-              <a:srgbClr val="4A9384"/>
+              <a:srgbClr val="D7DCE1"/>
             </a:solidFill>
           </a:ln>
           <a:effectLst/>
@@ -3890,15 +3882,15 @@
         </p:nvCxnSpPr>
         <p:spPr>
           <a:xfrm flipV="1">
-            <a:off x="9921240" y="1005840"/>
-            <a:ext cx="1783080" cy="228600"/>
+            <a:off x="10058400" y="1078992"/>
+            <a:ext cx="1691640" cy="155448"/>
           </a:xfrm>
           <a:prstGeom prst="line">
             <a:avLst/>
           </a:prstGeom>
           <a:ln w="9525">
             <a:solidFill>
-              <a:srgbClr val="4A9384"/>
+              <a:srgbClr val="D7DCE1"/>
             </a:solidFill>
           </a:ln>
           <a:effectLst/>
@@ -3926,15 +3918,15 @@
         </p:nvCxnSpPr>
         <p:spPr>
           <a:xfrm flipH="1">
-            <a:off x="7726679" y="2697480"/>
-            <a:ext cx="1828801" cy="228600"/>
+            <a:off x="8046720" y="2697480"/>
+            <a:ext cx="1645920" cy="228600"/>
           </a:xfrm>
           <a:prstGeom prst="line">
             <a:avLst/>
           </a:prstGeom>
           <a:ln w="9525">
             <a:solidFill>
-              <a:srgbClr val="4A9384"/>
+              <a:srgbClr val="D7DCE1"/>
             </a:solidFill>
           </a:ln>
           <a:effectLst/>
@@ -3962,15 +3954,15 @@
         </p:nvCxnSpPr>
         <p:spPr>
           <a:xfrm>
-            <a:off x="8275320" y="4572000"/>
-            <a:ext cx="1371600" cy="228600"/>
+            <a:off x="8458200" y="4617720"/>
+            <a:ext cx="1325880" cy="182880"/>
           </a:xfrm>
           <a:prstGeom prst="line">
             <a:avLst/>
           </a:prstGeom>
           <a:ln w="9525">
             <a:solidFill>
-              <a:srgbClr val="4A9384"/>
+              <a:srgbClr val="D7DCE1"/>
             </a:solidFill>
           </a:ln>
           <a:effectLst/>
@@ -3998,15 +3990,15 @@
         </p:nvCxnSpPr>
         <p:spPr>
           <a:xfrm>
-            <a:off x="11475720" y="1965960"/>
-            <a:ext cx="429768" cy="1097280"/>
+            <a:off x="11539728" y="2011680"/>
+            <a:ext cx="393192" cy="1051560"/>
           </a:xfrm>
           <a:prstGeom prst="line">
             <a:avLst/>
           </a:prstGeom>
           <a:ln w="9525">
             <a:solidFill>
-              <a:srgbClr val="4A9384"/>
+              <a:srgbClr val="D7DCE1"/>
             </a:solidFill>
           </a:ln>
           <a:effectLst/>
@@ -4034,15 +4026,15 @@
         </p:nvCxnSpPr>
         <p:spPr>
           <a:xfrm flipH="1" flipV="1">
-            <a:off x="7452360" y="1920240"/>
-            <a:ext cx="274319" cy="1005840"/>
+            <a:off x="7726679" y="1965960"/>
+            <a:ext cx="320041" cy="960120"/>
           </a:xfrm>
           <a:prstGeom prst="line">
             <a:avLst/>
           </a:prstGeom>
           <a:ln w="9525">
             <a:solidFill>
-              <a:srgbClr val="4A9384"/>
+              <a:srgbClr val="D7DCE1"/>
             </a:solidFill>
           </a:ln>
           <a:effectLst/>
@@ -4070,15 +4062,15 @@
         </p:nvCxnSpPr>
         <p:spPr>
           <a:xfrm flipH="1">
-            <a:off x="6053328" y="1188720"/>
-            <a:ext cx="667512" cy="1143000"/>
+            <a:off x="6812280" y="1234440"/>
+            <a:ext cx="365760" cy="1234440"/>
           </a:xfrm>
           <a:prstGeom prst="line">
             <a:avLst/>
           </a:prstGeom>
           <a:ln w="9525">
             <a:solidFill>
-              <a:srgbClr val="4A9384"/>
+              <a:srgbClr val="D7DCE1"/>
             </a:solidFill>
           </a:ln>
           <a:effectLst/>
@@ -4106,15 +4098,15 @@
         </p:nvCxnSpPr>
         <p:spPr>
           <a:xfrm flipV="1">
-            <a:off x="9646920" y="4617720"/>
-            <a:ext cx="1645920" cy="182880"/>
+            <a:off x="9784080" y="4617720"/>
+            <a:ext cx="1600200" cy="182880"/>
           </a:xfrm>
           <a:prstGeom prst="line">
             <a:avLst/>
           </a:prstGeom>
           <a:ln w="9525">
             <a:solidFill>
-              <a:srgbClr val="4A9384"/>
+              <a:srgbClr val="D7DCE1"/>
             </a:solidFill>
           </a:ln>
           <a:effectLst/>
@@ -4142,18 +4134,18 @@
         </p:nvSpPr>
         <p:spPr>
           <a:xfrm>
-            <a:off x="6601968" y="1069848"/>
+            <a:off x="7059168" y="1115568"/>
             <a:ext cx="237744" cy="237744"/>
           </a:xfrm>
           <a:prstGeom prst="ellipse">
             <a:avLst/>
           </a:prstGeom>
           <a:solidFill>
-            <a:srgbClr val="F2F7F5"/>
+            <a:srgbClr val="CFD6DC"/>
           </a:solidFill>
           <a:ln w="9525">
             <a:solidFill>
-              <a:srgbClr val="0C332C"/>
+              <a:srgbClr val="BDC4CB"/>
             </a:solidFill>
           </a:ln>
           <a:effectLst/>
@@ -4188,18 +4180,18 @@
         </p:nvSpPr>
         <p:spPr>
           <a:xfrm>
-            <a:off x="7863840" y="749808"/>
+            <a:off x="8183880" y="777240"/>
             <a:ext cx="182880" cy="182880"/>
           </a:xfrm>
           <a:prstGeom prst="ellipse">
             <a:avLst/>
           </a:prstGeom>
           <a:solidFill>
-            <a:srgbClr val="DAB462"/>
+            <a:srgbClr val="E4002B"/>
           </a:solidFill>
           <a:ln w="9525">
             <a:solidFill>
-              <a:srgbClr val="0C332C"/>
+              <a:srgbClr val="BDC4CB"/>
             </a:solidFill>
           </a:ln>
           <a:effectLst/>
@@ -4234,18 +4226,18 @@
         </p:nvSpPr>
         <p:spPr>
           <a:xfrm>
-            <a:off x="9784080" y="1097280"/>
+            <a:off x="9921240" y="1097280"/>
             <a:ext cx="274320" cy="274320"/>
           </a:xfrm>
           <a:prstGeom prst="ellipse">
             <a:avLst/>
           </a:prstGeom>
           <a:solidFill>
-            <a:srgbClr val="F2F7F5"/>
+            <a:srgbClr val="CFD6DC"/>
           </a:solidFill>
           <a:ln w="9525">
             <a:solidFill>
-              <a:srgbClr val="0C332C"/>
+              <a:srgbClr val="BDC4CB"/>
             </a:solidFill>
           </a:ln>
           <a:effectLst/>
@@ -4280,18 +4272,18 @@
         </p:nvSpPr>
         <p:spPr>
           <a:xfrm>
-            <a:off x="11365992" y="1856231"/>
+            <a:off x="11430000" y="1901952"/>
             <a:ext cx="219456" cy="219456"/>
           </a:xfrm>
           <a:prstGeom prst="ellipse">
             <a:avLst/>
           </a:prstGeom>
           <a:solidFill>
-            <a:srgbClr val="5FC9B4"/>
+            <a:srgbClr val="1FA87E"/>
           </a:solidFill>
           <a:ln w="9525">
             <a:solidFill>
-              <a:srgbClr val="0C332C"/>
+              <a:srgbClr val="BDC4CB"/>
             </a:solidFill>
           </a:ln>
           <a:effectLst/>
@@ -4326,18 +4318,18 @@
         </p:nvSpPr>
         <p:spPr>
           <a:xfrm>
-            <a:off x="11622024" y="923544"/>
+            <a:off x="11667744" y="996695"/>
             <a:ext cx="164592" cy="164592"/>
           </a:xfrm>
           <a:prstGeom prst="ellipse">
             <a:avLst/>
           </a:prstGeom>
           <a:solidFill>
-            <a:srgbClr val="F2F7F5"/>
+            <a:srgbClr val="CFD6DC"/>
           </a:solidFill>
           <a:ln w="9525">
             <a:solidFill>
-              <a:srgbClr val="0C332C"/>
+              <a:srgbClr val="BDC4CB"/>
             </a:solidFill>
           </a:ln>
           <a:effectLst/>
@@ -4372,18 +4364,18 @@
         </p:nvSpPr>
         <p:spPr>
           <a:xfrm>
-            <a:off x="5943600" y="2221991"/>
+            <a:off x="6702552" y="2359152"/>
             <a:ext cx="219456" cy="219456"/>
           </a:xfrm>
           <a:prstGeom prst="ellipse">
             <a:avLst/>
           </a:prstGeom>
           <a:solidFill>
-            <a:srgbClr val="DAB462"/>
+            <a:srgbClr val="1FA87E"/>
           </a:solidFill>
           <a:ln w="9525">
             <a:solidFill>
-              <a:srgbClr val="0C332C"/>
+              <a:srgbClr val="BDC4CB"/>
             </a:solidFill>
           </a:ln>
           <a:effectLst/>
@@ -4418,18 +4410,18 @@
         </p:nvSpPr>
         <p:spPr>
           <a:xfrm>
-            <a:off x="5715000" y="3218688"/>
+            <a:off x="6583680" y="3310128"/>
             <a:ext cx="182880" cy="182880"/>
           </a:xfrm>
           <a:prstGeom prst="ellipse">
             <a:avLst/>
           </a:prstGeom>
           <a:solidFill>
-            <a:srgbClr val="F2F7F5"/>
+            <a:srgbClr val="CFD6DC"/>
           </a:solidFill>
           <a:ln w="9525">
             <a:solidFill>
-              <a:srgbClr val="0C332C"/>
+              <a:srgbClr val="BDC4CB"/>
             </a:solidFill>
           </a:ln>
           <a:effectLst/>
@@ -4464,18 +4456,18 @@
         </p:nvSpPr>
         <p:spPr>
           <a:xfrm>
-            <a:off x="7598663" y="2798064"/>
+            <a:off x="7918704" y="2798064"/>
             <a:ext cx="256032" cy="256032"/>
           </a:xfrm>
           <a:prstGeom prst="ellipse">
             <a:avLst/>
           </a:prstGeom>
           <a:solidFill>
-            <a:srgbClr val="5FC9B4"/>
+            <a:srgbClr val="E4002B"/>
           </a:solidFill>
           <a:ln w="9525">
             <a:solidFill>
-              <a:srgbClr val="0C332C"/>
+              <a:srgbClr val="BDC4CB"/>
             </a:solidFill>
           </a:ln>
           <a:effectLst/>
@@ -4510,18 +4502,18 @@
         </p:nvSpPr>
         <p:spPr>
           <a:xfrm>
-            <a:off x="9454896" y="2596896"/>
+            <a:off x="9592056" y="2596896"/>
             <a:ext cx="201168" cy="201168"/>
           </a:xfrm>
           <a:prstGeom prst="ellipse">
             <a:avLst/>
           </a:prstGeom>
           <a:solidFill>
-            <a:srgbClr val="DAB462"/>
+            <a:srgbClr val="CFD6DC"/>
           </a:solidFill>
           <a:ln w="9525">
             <a:solidFill>
-              <a:srgbClr val="0C332C"/>
+              <a:srgbClr val="BDC4CB"/>
             </a:solidFill>
           </a:ln>
           <a:effectLst/>
@@ -4556,18 +4548,18 @@
         </p:nvSpPr>
         <p:spPr>
           <a:xfrm>
-            <a:off x="11183112" y="4507992"/>
+            <a:off x="11274552" y="4507992"/>
             <a:ext cx="219456" cy="219456"/>
           </a:xfrm>
           <a:prstGeom prst="ellipse">
             <a:avLst/>
           </a:prstGeom>
           <a:solidFill>
-            <a:srgbClr val="5FC9B4"/>
+            <a:srgbClr val="1FA87E"/>
           </a:solidFill>
           <a:ln w="9525">
             <a:solidFill>
-              <a:srgbClr val="0C332C"/>
+              <a:srgbClr val="BDC4CB"/>
             </a:solidFill>
           </a:ln>
           <a:effectLst/>
@@ -4602,18 +4594,18 @@
         </p:nvSpPr>
         <p:spPr>
           <a:xfrm>
-            <a:off x="9546336" y="4700016"/>
+            <a:off x="9683496" y="4700016"/>
             <a:ext cx="201168" cy="201168"/>
           </a:xfrm>
           <a:prstGeom prst="ellipse">
             <a:avLst/>
           </a:prstGeom>
           <a:solidFill>
-            <a:srgbClr val="F2F7F5"/>
+            <a:srgbClr val="CFD6DC"/>
           </a:solidFill>
           <a:ln w="9525">
             <a:solidFill>
-              <a:srgbClr val="0C332C"/>
+              <a:srgbClr val="BDC4CB"/>
             </a:solidFill>
           </a:ln>
           <a:effectLst/>
@@ -4648,18 +4640,18 @@
         </p:nvSpPr>
         <p:spPr>
           <a:xfrm>
-            <a:off x="8147304" y="4443984"/>
+            <a:off x="8330183" y="4489704"/>
             <a:ext cx="256032" cy="256032"/>
           </a:xfrm>
           <a:prstGeom prst="ellipse">
             <a:avLst/>
           </a:prstGeom>
           <a:solidFill>
-            <a:srgbClr val="DAB462"/>
+            <a:srgbClr val="E4002B"/>
           </a:solidFill>
           <a:ln w="9525">
             <a:solidFill>
-              <a:srgbClr val="0C332C"/>
+              <a:srgbClr val="BDC4CB"/>
             </a:solidFill>
           </a:ln>
           <a:effectLst/>
@@ -4694,18 +4686,18 @@
         </p:nvSpPr>
         <p:spPr>
           <a:xfrm>
-            <a:off x="6446520" y="4800600"/>
+            <a:off x="6812280" y="4800600"/>
             <a:ext cx="182880" cy="182880"/>
           </a:xfrm>
           <a:prstGeom prst="ellipse">
             <a:avLst/>
           </a:prstGeom>
           <a:solidFill>
-            <a:srgbClr val="5FC9B4"/>
+            <a:srgbClr val="1FA87E"/>
           </a:solidFill>
           <a:ln w="9525">
             <a:solidFill>
-              <a:srgbClr val="0C332C"/>
+              <a:srgbClr val="BDC4CB"/>
             </a:solidFill>
           </a:ln>
           <a:effectLst/>
@@ -4740,18 +4732,18 @@
         </p:nvSpPr>
         <p:spPr>
           <a:xfrm>
-            <a:off x="10021824" y="4078224"/>
+            <a:off x="10113264" y="4078224"/>
             <a:ext cx="164592" cy="164592"/>
           </a:xfrm>
           <a:prstGeom prst="ellipse">
             <a:avLst/>
           </a:prstGeom>
           <a:solidFill>
-            <a:srgbClr val="F2F7F5"/>
+            <a:srgbClr val="CFD6DC"/>
           </a:solidFill>
           <a:ln w="9525">
             <a:solidFill>
-              <a:srgbClr val="0C332C"/>
+              <a:srgbClr val="BDC4CB"/>
             </a:solidFill>
           </a:ln>
           <a:effectLst/>
@@ -4786,18 +4778,18 @@
         </p:nvSpPr>
         <p:spPr>
           <a:xfrm>
-            <a:off x="11814048" y="2971800"/>
+            <a:off x="11841480" y="2971800"/>
             <a:ext cx="182880" cy="182880"/>
           </a:xfrm>
           <a:prstGeom prst="ellipse">
             <a:avLst/>
           </a:prstGeom>
           <a:solidFill>
-            <a:srgbClr val="DAB462"/>
+            <a:srgbClr val="E4002B"/>
           </a:solidFill>
           <a:ln w="9525">
             <a:solidFill>
-              <a:srgbClr val="0C332C"/>
+              <a:srgbClr val="BDC4CB"/>
             </a:solidFill>
           </a:ln>
           <a:effectLst/>
@@ -4832,18 +4824,18 @@
         </p:nvSpPr>
         <p:spPr>
           <a:xfrm>
-            <a:off x="7370064" y="1837944"/>
+            <a:off x="7644383" y="1883664"/>
             <a:ext cx="164592" cy="164592"/>
           </a:xfrm>
           <a:prstGeom prst="ellipse">
             <a:avLst/>
           </a:prstGeom>
           <a:solidFill>
-            <a:srgbClr val="F2F7F5"/>
+            <a:srgbClr val="CFD6DC"/>
           </a:solidFill>
           <a:ln w="9525">
             <a:solidFill>
-              <a:srgbClr val="0C332C"/>
+              <a:srgbClr val="BDC4CB"/>
             </a:solidFill>
           </a:ln>
           <a:effectLst/>
@@ -4878,14 +4870,14 @@
         </p:nvSpPr>
         <p:spPr>
           <a:xfrm>
-            <a:off x="6272784" y="3163824"/>
+            <a:off x="6592824" y="3163824"/>
             <a:ext cx="1536192" cy="1536192"/>
           </a:xfrm>
           <a:prstGeom prst="ellipse">
             <a:avLst/>
           </a:prstGeom>
           <a:solidFill>
-            <a:srgbClr val="1C554C"/>
+            <a:srgbClr val="FBE3E7"/>
           </a:solidFill>
           <a:ln>
             <a:noFill/>
@@ -4922,14 +4914,14 @@
         </p:nvSpPr>
         <p:spPr>
           <a:xfrm>
-            <a:off x="6503212" y="3394252"/>
+            <a:off x="6823252" y="3394252"/>
             <a:ext cx="1075334" cy="1075334"/>
           </a:xfrm>
           <a:prstGeom prst="ellipse">
             <a:avLst/>
           </a:prstGeom>
           <a:solidFill>
-            <a:srgbClr val="2C7769"/>
+            <a:srgbClr val="F3B3BD"/>
           </a:solidFill>
           <a:ln>
             <a:noFill/>
@@ -4966,14 +4958,14 @@
         </p:nvSpPr>
         <p:spPr>
           <a:xfrm>
-            <a:off x="6656832" y="3547872"/>
+            <a:off x="6976872" y="3547872"/>
             <a:ext cx="768096" cy="768096"/>
           </a:xfrm>
           <a:prstGeom prst="ellipse">
             <a:avLst/>
           </a:prstGeom>
           <a:solidFill>
-            <a:srgbClr val="45A08E"/>
+            <a:srgbClr val="EC7484"/>
           </a:solidFill>
           <a:ln>
             <a:noFill/>
@@ -5010,18 +5002,18 @@
         </p:nvSpPr>
         <p:spPr>
           <a:xfrm>
-            <a:off x="6784848" y="3675887"/>
+            <a:off x="7104888" y="3675887"/>
             <a:ext cx="512064" cy="512064"/>
           </a:xfrm>
           <a:prstGeom prst="ellipse">
             <a:avLst/>
           </a:prstGeom>
           <a:solidFill>
-            <a:srgbClr val="5FC9B4"/>
+            <a:srgbClr val="E4002B"/>
           </a:solidFill>
           <a:ln w="9525">
             <a:solidFill>
-              <a:srgbClr val="0C332C"/>
+              <a:srgbClr val="BDC4CB"/>
             </a:solidFill>
           </a:ln>
           <a:effectLst/>
@@ -5056,14 +5048,14 @@
         </p:nvSpPr>
         <p:spPr>
           <a:xfrm>
-            <a:off x="6933346" y="3824386"/>
-            <a:ext cx="215066" cy="215066"/>
+            <a:off x="7258507" y="3829507"/>
+            <a:ext cx="204825" cy="204825"/>
           </a:xfrm>
           <a:prstGeom prst="ellipse">
             <a:avLst/>
           </a:prstGeom>
           <a:solidFill>
-            <a:srgbClr val="F2F7F5"/>
+            <a:srgbClr val="FFFFFF"/>
           </a:solidFill>
           <a:ln>
             <a:noFill/>
@@ -5100,14 +5092,14 @@
         </p:nvSpPr>
         <p:spPr>
           <a:xfrm>
-            <a:off x="9838944" y="2706624"/>
+            <a:off x="9930384" y="2706624"/>
             <a:ext cx="1810512" cy="1810512"/>
           </a:xfrm>
           <a:prstGeom prst="ellipse">
             <a:avLst/>
           </a:prstGeom>
           <a:solidFill>
-            <a:srgbClr val="4A4A30"/>
+            <a:srgbClr val="DDF1EA"/>
           </a:solidFill>
           <a:ln>
             <a:noFill/>
@@ -5144,14 +5136,14 @@
         </p:nvSpPr>
         <p:spPr>
           <a:xfrm>
-            <a:off x="10110520" y="2978200"/>
+            <a:off x="10201960" y="2978200"/>
             <a:ext cx="1267358" cy="1267358"/>
           </a:xfrm>
           <a:prstGeom prst="ellipse">
             <a:avLst/>
           </a:prstGeom>
           <a:solidFill>
-            <a:srgbClr val="7A6A38"/>
+            <a:srgbClr val="A6DCCA"/>
           </a:solidFill>
           <a:ln>
             <a:noFill/>
@@ -5188,14 +5180,14 @@
         </p:nvSpPr>
         <p:spPr>
           <a:xfrm>
-            <a:off x="10291572" y="3159252"/>
+            <a:off x="10383012" y="3159252"/>
             <a:ext cx="905256" cy="905256"/>
           </a:xfrm>
           <a:prstGeom prst="ellipse">
             <a:avLst/>
           </a:prstGeom>
           <a:solidFill>
-            <a:srgbClr val="B09244"/>
+            <a:srgbClr val="54C1A1"/>
           </a:solidFill>
           <a:ln>
             <a:noFill/>
@@ -5232,18 +5224,18 @@
         </p:nvSpPr>
         <p:spPr>
           <a:xfrm>
-            <a:off x="10442448" y="3310128"/>
+            <a:off x="10533888" y="3310128"/>
             <a:ext cx="603504" cy="603504"/>
           </a:xfrm>
           <a:prstGeom prst="ellipse">
             <a:avLst/>
           </a:prstGeom>
           <a:solidFill>
-            <a:srgbClr val="DAB462"/>
+            <a:srgbClr val="1FA87E"/>
           </a:solidFill>
           <a:ln w="9525">
             <a:solidFill>
-              <a:srgbClr val="0C332C"/>
+              <a:srgbClr val="BDC4CB"/>
             </a:solidFill>
           </a:ln>
           <a:effectLst/>
@@ -5278,14 +5270,14 @@
         </p:nvSpPr>
         <p:spPr>
           <a:xfrm>
-            <a:off x="10617464" y="3485144"/>
-            <a:ext cx="253471" cy="253471"/>
+            <a:off x="10714939" y="3491179"/>
+            <a:ext cx="241401" cy="241401"/>
           </a:xfrm>
           <a:prstGeom prst="ellipse">
             <a:avLst/>
           </a:prstGeom>
           <a:solidFill>
-            <a:srgbClr val="F2F7F5"/>
+            <a:srgbClr val="FFFFFF"/>
           </a:solidFill>
           <a:ln>
             <a:noFill/>
@@ -5322,14 +5314,14 @@
         </p:nvSpPr>
         <p:spPr>
           <a:xfrm>
-            <a:off x="7635240" y="914400"/>
+            <a:off x="7818120" y="914400"/>
             <a:ext cx="2194560" cy="2194560"/>
           </a:xfrm>
           <a:prstGeom prst="ellipse">
             <a:avLst/>
           </a:prstGeom>
           <a:solidFill>
-            <a:srgbClr val="1C554C"/>
+            <a:srgbClr val="FBE3E7"/>
           </a:solidFill>
           <a:ln>
             <a:noFill/>
@@ -5366,14 +5358,14 @@
         </p:nvSpPr>
         <p:spPr>
           <a:xfrm>
-            <a:off x="7964424" y="1243584"/>
+            <a:off x="8147304" y="1243584"/>
             <a:ext cx="1536192" cy="1536192"/>
           </a:xfrm>
           <a:prstGeom prst="ellipse">
             <a:avLst/>
           </a:prstGeom>
           <a:solidFill>
-            <a:srgbClr val="2C7769"/>
+            <a:srgbClr val="F3B3BD"/>
           </a:solidFill>
           <a:ln>
             <a:noFill/>
@@ -5410,14 +5402,14 @@
         </p:nvSpPr>
         <p:spPr>
           <a:xfrm>
-            <a:off x="8183880" y="1463040"/>
+            <a:off x="8366760" y="1463040"/>
             <a:ext cx="1097280" cy="1097280"/>
           </a:xfrm>
           <a:prstGeom prst="ellipse">
             <a:avLst/>
           </a:prstGeom>
           <a:solidFill>
-            <a:srgbClr val="45A08E"/>
+            <a:srgbClr val="EC7484"/>
           </a:solidFill>
           <a:ln>
             <a:noFill/>
@@ -5454,18 +5446,18 @@
         </p:nvSpPr>
         <p:spPr>
           <a:xfrm>
-            <a:off x="8366760" y="1645920"/>
+            <a:off x="8549640" y="1645920"/>
             <a:ext cx="731520" cy="731520"/>
           </a:xfrm>
           <a:prstGeom prst="ellipse">
             <a:avLst/>
           </a:prstGeom>
           <a:solidFill>
-            <a:srgbClr val="5FC9B4"/>
+            <a:srgbClr val="E4002B"/>
           </a:solidFill>
           <a:ln w="9525">
             <a:solidFill>
-              <a:srgbClr val="0C332C"/>
+              <a:srgbClr val="BDC4CB"/>
             </a:solidFill>
           </a:ln>
           <a:effectLst/>
@@ -5500,14 +5492,14 @@
         </p:nvSpPr>
         <p:spPr>
           <a:xfrm>
-            <a:off x="8578900" y="1858060"/>
-            <a:ext cx="307238" cy="307238"/>
+            <a:off x="8769096" y="1865376"/>
+            <a:ext cx="292608" cy="292608"/>
           </a:xfrm>
           <a:prstGeom prst="ellipse">
             <a:avLst/>
           </a:prstGeom>
           <a:solidFill>
-            <a:srgbClr val="F2F7F5"/>
+            <a:srgbClr val="FFFFFF"/>
           </a:solidFill>
           <a:ln>
             <a:noFill/>
@@ -5572,7 +5564,7 @@
             <a:r>
               <a:rPr sz="1300" b="1" i="0">
                 <a:solidFill>
-                  <a:srgbClr val="4E6B84"/>
+                  <a:srgbClr val="E4002B"/>
                 </a:solidFill>
                 <a:latin typeface="Calibri"/>
               </a:rPr>
@@ -5581,7 +5573,7 @@
             <a:r>
               <a:rPr sz="1150" b="1" i="0">
                 <a:solidFill>
-                  <a:srgbClr val="D8ECE8"/>
+                  <a:srgbClr val="9AA3AB"/>
                 </a:solidFill>
                 <a:latin typeface="Calibri"/>
               </a:rPr>
@@ -5626,7 +5618,7 @@
             <a:r>
               <a:rPr sz="4000" b="1" i="0">
                 <a:solidFill>
-                  <a:srgbClr val="FFFFFF"/>
+                  <a:srgbClr val="1E2933"/>
                 </a:solidFill>
                 <a:latin typeface="Calibri"/>
               </a:rPr>
@@ -5650,7 +5642,7 @@
             <a:avLst/>
           </a:prstGeom>
           <a:solidFill>
-            <a:srgbClr val="4E6B84"/>
+            <a:srgbClr val="E4002B"/>
           </a:solidFill>
           <a:ln>
             <a:noFill/>
@@ -5715,7 +5707,7 @@
             <a:r>
               <a:rPr sz="1450" b="0" i="0">
                 <a:solidFill>
-                  <a:srgbClr val="D8ECE8"/>
+                  <a:srgbClr val="5B6670"/>
                 </a:solidFill>
                 <a:latin typeface="Calibri"/>
               </a:rPr>
@@ -5726,65 +5718,20 @@
       </p:sp>
       <p:sp>
         <p:nvSpPr>
-          <p:cNvPr id="65" name="TextBox 64"/>
-          <p:cNvSpPr txBox="1"/>
-          <p:nvPr/>
-        </p:nvSpPr>
-        <p:spPr>
-          <a:xfrm>
-            <a:off x="841248" y="3529584"/>
-            <a:ext cx="4572000" cy="237744"/>
-          </a:xfrm>
-          <a:prstGeom prst="rect">
-            <a:avLst/>
-          </a:prstGeom>
-          <a:noFill/>
-        </p:spPr>
-        <p:txBody>
-          <a:bodyPr wrap="square" anchor="t" lIns="0" rIns="0" tIns="0" bIns="0">
-            <a:spAutoFit/>
-          </a:bodyPr>
-          <a:lstStyle/>
-          <a:p>
-            <a:pPr algn="l">
-              <a:lnSpc>
-                <a:spcPct val="106000"/>
-              </a:lnSpc>
-              <a:spcBef>
-                <a:spcPts val="0"/>
-              </a:spcBef>
-              <a:spcAft>
-                <a:spcPts val="0"/>
-              </a:spcAft>
-            </a:pPr>
-            <a:r>
-              <a:rPr sz="1050" b="1" i="0">
-                <a:solidFill>
-                  <a:srgbClr val="4E6B84"/>
-                </a:solidFill>
-                <a:latin typeface="Calibri"/>
-              </a:rPr>
-              <a:t>LIVE IN PILOT TODAY</a:t>
-            </a:r>
-          </a:p>
-        </p:txBody>
-      </p:sp>
-      <p:sp>
-        <p:nvSpPr>
-          <p:cNvPr id="66" name="Oval 65"/>
+          <p:cNvPr id="65" name="Rectangle 64"/>
           <p:cNvSpPr/>
           <p:nvPr/>
         </p:nvSpPr>
         <p:spPr>
           <a:xfrm>
-            <a:off x="841248" y="3922776"/>
-            <a:ext cx="137160" cy="137160"/>
-          </a:xfrm>
-          <a:prstGeom prst="ellipse">
+            <a:off x="841248" y="5504688"/>
+            <a:ext cx="10509199" cy="12700"/>
+          </a:xfrm>
+          <a:prstGeom prst="rect">
             <a:avLst/>
           </a:prstGeom>
           <a:solidFill>
-            <a:srgbClr val="4E6B84"/>
+            <a:srgbClr val="DDE1E5"/>
           </a:solidFill>
           <a:ln>
             <a:noFill/>
@@ -5815,14 +5762,14 @@
       </p:sp>
       <p:sp>
         <p:nvSpPr>
-          <p:cNvPr id="67" name="TextBox 66"/>
+          <p:cNvPr id="66" name="TextBox 65"/>
           <p:cNvSpPr txBox="1"/>
           <p:nvPr/>
         </p:nvSpPr>
         <p:spPr>
           <a:xfrm>
-            <a:off x="1133856" y="3858768"/>
-            <a:ext cx="4480560" cy="310896"/>
+            <a:off x="0" y="5614416"/>
+            <a:ext cx="12191695" cy="256032"/>
           </a:xfrm>
           <a:prstGeom prst="rect">
             <a:avLst/>
@@ -5830,12 +5777,12 @@
           <a:noFill/>
         </p:spPr>
         <p:txBody>
-          <a:bodyPr wrap="square" anchor="ctr" lIns="0" rIns="0" tIns="0" bIns="0">
+          <a:bodyPr wrap="square" anchor="t" lIns="0" rIns="0" tIns="0" bIns="0">
             <a:spAutoFit/>
           </a:bodyPr>
           <a:lstStyle/>
           <a:p>
-            <a:pPr algn="l">
+            <a:pPr algn="ctr">
               <a:lnSpc>
                 <a:spcPct val="106000"/>
               </a:lnSpc>
@@ -5847,23 +5794,60 @@
               </a:spcAft>
             </a:pPr>
             <a:r>
-              <a:rPr sz="1600" b="1" i="0">
-                <a:solidFill>
-                  <a:srgbClr val="FFFFFF"/>
-                </a:solidFill>
-                <a:latin typeface="Calibri"/>
-              </a:rPr>
-              <a:t>1,313   </a:t>
-            </a:r>
-            <a:r>
-              <a:rPr sz="1250" b="0" i="0">
-                <a:solidFill>
-                  <a:srgbClr val="D8ECE8"/>
-                </a:solidFill>
-                <a:latin typeface="Calibri"/>
-              </a:rPr>
-              <a:t>frontliners onboarded</a:t>
-            </a:r>
+              <a:rPr sz="1100" b="1" i="0">
+                <a:solidFill>
+                  <a:srgbClr val="E4002B"/>
+                </a:solidFill>
+                <a:latin typeface="Calibri"/>
+              </a:rPr>
+              <a:t>PROJECT TEAM</a:t>
+            </a:r>
+          </a:p>
+        </p:txBody>
+      </p:sp>
+      <p:sp>
+        <p:nvSpPr>
+          <p:cNvPr id="67" name="Oval 66"/>
+          <p:cNvSpPr/>
+          <p:nvPr/>
+        </p:nvSpPr>
+        <p:spPr>
+          <a:xfrm>
+            <a:off x="1938528" y="5843016"/>
+            <a:ext cx="786384" cy="786384"/>
+          </a:xfrm>
+          <a:prstGeom prst="ellipse">
+            <a:avLst/>
+          </a:prstGeom>
+          <a:solidFill>
+            <a:srgbClr val="EDF0F2"/>
+          </a:solidFill>
+          <a:ln w="19050">
+            <a:solidFill>
+              <a:srgbClr val="C7CED4"/>
+            </a:solidFill>
+          </a:ln>
+          <a:effectLst/>
+        </p:spPr>
+        <p:style>
+          <a:lnRef idx="1">
+            <a:schemeClr val="accent1"/>
+          </a:lnRef>
+          <a:fillRef idx="3">
+            <a:schemeClr val="accent1"/>
+          </a:fillRef>
+          <a:effectRef idx="2">
+            <a:schemeClr val="accent1"/>
+          </a:effectRef>
+          <a:fontRef idx="minor">
+            <a:schemeClr val="lt1"/>
+          </a:fontRef>
+        </p:style>
+        <p:txBody>
+          <a:bodyPr rtlCol="0" anchor="ctr"/>
+          <a:lstStyle/>
+          <a:p>
+            <a:pPr algn="ctr"/>
           </a:p>
         </p:txBody>
       </p:sp>
@@ -5875,14 +5859,14 @@
         </p:nvSpPr>
         <p:spPr>
           <a:xfrm>
-            <a:off x="841248" y="4398264"/>
-            <a:ext cx="137160" cy="137160"/>
+            <a:off x="2213763" y="5968837"/>
+            <a:ext cx="235915" cy="235915"/>
           </a:xfrm>
           <a:prstGeom prst="ellipse">
             <a:avLst/>
           </a:prstGeom>
           <a:solidFill>
-            <a:srgbClr val="4E6B84"/>
+            <a:srgbClr val="333E48"/>
           </a:solidFill>
           <a:ln>
             <a:noFill/>
@@ -5913,74 +5897,20 @@
       </p:sp>
       <p:sp>
         <p:nvSpPr>
-          <p:cNvPr id="69" name="TextBox 68"/>
-          <p:cNvSpPr txBox="1"/>
-          <p:nvPr/>
-        </p:nvSpPr>
-        <p:spPr>
-          <a:xfrm>
-            <a:off x="1133856" y="4334256"/>
-            <a:ext cx="4480560" cy="310896"/>
-          </a:xfrm>
-          <a:prstGeom prst="rect">
-            <a:avLst/>
-          </a:prstGeom>
-          <a:noFill/>
-        </p:spPr>
-        <p:txBody>
-          <a:bodyPr wrap="square" anchor="ctr" lIns="0" rIns="0" tIns="0" bIns="0">
-            <a:spAutoFit/>
-          </a:bodyPr>
-          <a:lstStyle/>
-          <a:p>
-            <a:pPr algn="l">
-              <a:lnSpc>
-                <a:spcPct val="106000"/>
-              </a:lnSpc>
-              <a:spcBef>
-                <a:spcPts val="0"/>
-              </a:spcBef>
-              <a:spcAft>
-                <a:spcPts val="0"/>
-              </a:spcAft>
-            </a:pPr>
-            <a:r>
-              <a:rPr sz="1600" b="1" i="0">
-                <a:solidFill>
-                  <a:srgbClr val="FFFFFF"/>
-                </a:solidFill>
-                <a:latin typeface="Calibri"/>
-              </a:rPr>
-              <a:t>12,944   </a:t>
-            </a:r>
-            <a:r>
-              <a:rPr sz="1250" b="0" i="0">
-                <a:solidFill>
-                  <a:srgbClr val="D8ECE8"/>
-                </a:solidFill>
-                <a:latin typeface="Calibri"/>
-              </a:rPr>
-              <a:t>questions answered</a:t>
-            </a:r>
-          </a:p>
-        </p:txBody>
-      </p:sp>
-      <p:sp>
-        <p:nvSpPr>
-          <p:cNvPr id="70" name="Oval 69"/>
+          <p:cNvPr id="69" name="Oval 68"/>
           <p:cNvSpPr/>
           <p:nvPr/>
         </p:nvSpPr>
         <p:spPr>
           <a:xfrm>
-            <a:off x="841248" y="4873752"/>
-            <a:ext cx="137160" cy="137160"/>
+            <a:off x="2095805" y="6267663"/>
+            <a:ext cx="471830" cy="361736"/>
           </a:xfrm>
           <a:prstGeom prst="ellipse">
             <a:avLst/>
           </a:prstGeom>
           <a:solidFill>
-            <a:srgbClr val="4E6B84"/>
+            <a:srgbClr val="333E48"/>
           </a:solidFill>
           <a:ln>
             <a:noFill/>
@@ -6011,14 +5941,14 @@
       </p:sp>
       <p:sp>
         <p:nvSpPr>
-          <p:cNvPr id="71" name="TextBox 70"/>
+          <p:cNvPr id="70" name="TextBox 69"/>
           <p:cNvSpPr txBox="1"/>
           <p:nvPr/>
         </p:nvSpPr>
         <p:spPr>
           <a:xfrm>
-            <a:off x="1133856" y="4809744"/>
-            <a:ext cx="4480560" cy="310896"/>
+            <a:off x="1600200" y="6693408"/>
+            <a:ext cx="1463040" cy="219456"/>
           </a:xfrm>
           <a:prstGeom prst="rect">
             <a:avLst/>
@@ -6026,12 +5956,12 @@
           <a:noFill/>
         </p:spPr>
         <p:txBody>
-          <a:bodyPr wrap="square" anchor="ctr" lIns="0" rIns="0" tIns="0" bIns="0">
+          <a:bodyPr wrap="square" anchor="t" lIns="0" rIns="0" tIns="0" bIns="0">
             <a:spAutoFit/>
           </a:bodyPr>
           <a:lstStyle/>
           <a:p>
-            <a:pPr algn="l">
+            <a:pPr algn="ctr">
               <a:lnSpc>
                 <a:spcPct val="106000"/>
               </a:lnSpc>
@@ -6043,42 +5973,79 @@
               </a:spcAft>
             </a:pPr>
             <a:r>
-              <a:rPr sz="1600" b="1" i="0">
-                <a:solidFill>
-                  <a:srgbClr val="FFFFFF"/>
-                </a:solidFill>
-                <a:latin typeface="Calibri"/>
-              </a:rPr>
-              <a:t>326   </a:t>
-            </a:r>
-            <a:r>
-              <a:rPr sz="1250" b="0" i="0">
-                <a:solidFill>
-                  <a:srgbClr val="D8ECE8"/>
-                </a:solidFill>
-                <a:latin typeface="Calibri"/>
-              </a:rPr>
-              <a:t>products &amp; promos live</a:t>
-            </a:r>
-          </a:p>
-        </p:txBody>
-      </p:sp>
-      <p:sp>
-        <p:nvSpPr>
-          <p:cNvPr id="72" name="Rectangle 71"/>
+              <a:rPr sz="1000" b="0" i="0">
+                <a:solidFill>
+                  <a:srgbClr val="5B6670"/>
+                </a:solidFill>
+                <a:latin typeface="Calibri"/>
+              </a:rPr>
+              <a:t>Name</a:t>
+            </a:r>
+          </a:p>
+        </p:txBody>
+      </p:sp>
+      <p:sp>
+        <p:nvSpPr>
+          <p:cNvPr id="71" name="Oval 70"/>
           <p:cNvSpPr/>
           <p:nvPr/>
         </p:nvSpPr>
         <p:spPr>
           <a:xfrm>
-            <a:off x="841248" y="5577840"/>
-            <a:ext cx="10509199" cy="12700"/>
-          </a:xfrm>
-          <a:prstGeom prst="rect">
+            <a:off x="3950208" y="5843016"/>
+            <a:ext cx="786384" cy="786384"/>
+          </a:xfrm>
+          <a:prstGeom prst="ellipse">
             <a:avLst/>
           </a:prstGeom>
           <a:solidFill>
-            <a:srgbClr val="3A6C60"/>
+            <a:srgbClr val="EDF0F2"/>
+          </a:solidFill>
+          <a:ln w="19050">
+            <a:solidFill>
+              <a:srgbClr val="C7CED4"/>
+            </a:solidFill>
+          </a:ln>
+          <a:effectLst/>
+        </p:spPr>
+        <p:style>
+          <a:lnRef idx="1">
+            <a:schemeClr val="accent1"/>
+          </a:lnRef>
+          <a:fillRef idx="3">
+            <a:schemeClr val="accent1"/>
+          </a:fillRef>
+          <a:effectRef idx="2">
+            <a:schemeClr val="accent1"/>
+          </a:effectRef>
+          <a:fontRef idx="minor">
+            <a:schemeClr val="lt1"/>
+          </a:fontRef>
+        </p:style>
+        <p:txBody>
+          <a:bodyPr rtlCol="0" anchor="ctr"/>
+          <a:lstStyle/>
+          <a:p>
+            <a:pPr algn="ctr"/>
+          </a:p>
+        </p:txBody>
+      </p:sp>
+      <p:sp>
+        <p:nvSpPr>
+          <p:cNvPr id="72" name="Oval 71"/>
+          <p:cNvSpPr/>
+          <p:nvPr/>
+        </p:nvSpPr>
+        <p:spPr>
+          <a:xfrm>
+            <a:off x="4225443" y="5968837"/>
+            <a:ext cx="235915" cy="235915"/>
+          </a:xfrm>
+          <a:prstGeom prst="ellipse">
+            <a:avLst/>
+          </a:prstGeom>
+          <a:solidFill>
+            <a:srgbClr val="333E48"/>
           </a:solidFill>
           <a:ln>
             <a:noFill/>
@@ -6109,70 +6076,23 @@
       </p:sp>
       <p:sp>
         <p:nvSpPr>
-          <p:cNvPr id="73" name="TextBox 72"/>
-          <p:cNvSpPr txBox="1"/>
-          <p:nvPr/>
-        </p:nvSpPr>
-        <p:spPr>
-          <a:xfrm>
-            <a:off x="0" y="5705856"/>
-            <a:ext cx="12191695" cy="256032"/>
-          </a:xfrm>
-          <a:prstGeom prst="rect">
-            <a:avLst/>
-          </a:prstGeom>
-          <a:noFill/>
-        </p:spPr>
-        <p:txBody>
-          <a:bodyPr wrap="square" anchor="t" lIns="0" rIns="0" tIns="0" bIns="0">
-            <a:spAutoFit/>
-          </a:bodyPr>
-          <a:lstStyle/>
-          <a:p>
-            <a:pPr algn="ctr">
-              <a:lnSpc>
-                <a:spcPct val="106000"/>
-              </a:lnSpc>
-              <a:spcBef>
-                <a:spcPts val="0"/>
-              </a:spcBef>
-              <a:spcAft>
-                <a:spcPts val="0"/>
-              </a:spcAft>
-            </a:pPr>
-            <a:r>
-              <a:rPr sz="1100" b="1" i="0">
-                <a:solidFill>
-                  <a:srgbClr val="4E6B84"/>
-                </a:solidFill>
-                <a:latin typeface="Calibri"/>
-              </a:rPr>
-              <a:t>PROJECT TEAM</a:t>
-            </a:r>
-          </a:p>
-        </p:txBody>
-      </p:sp>
-      <p:sp>
-        <p:nvSpPr>
-          <p:cNvPr id="74" name="Oval 73"/>
+          <p:cNvPr id="73" name="Oval 72"/>
           <p:cNvSpPr/>
           <p:nvPr/>
         </p:nvSpPr>
         <p:spPr>
           <a:xfrm>
-            <a:off x="2066544" y="6062472"/>
-            <a:ext cx="530352" cy="530352"/>
+            <a:off x="4107485" y="6267663"/>
+            <a:ext cx="471830" cy="361736"/>
           </a:xfrm>
           <a:prstGeom prst="ellipse">
             <a:avLst/>
           </a:prstGeom>
           <a:solidFill>
-            <a:srgbClr val="E6EFEC"/>
+            <a:srgbClr val="333E48"/>
           </a:solidFill>
-          <a:ln w="19050">
-            <a:solidFill>
-              <a:srgbClr val="FFFFFF"/>
-            </a:solidFill>
+          <a:ln>
+            <a:noFill/>
           </a:ln>
           <a:effectLst/>
         </p:spPr>
@@ -6200,20 +6120,111 @@
       </p:sp>
       <p:sp>
         <p:nvSpPr>
+          <p:cNvPr id="74" name="TextBox 73"/>
+          <p:cNvSpPr txBox="1"/>
+          <p:nvPr/>
+        </p:nvSpPr>
+        <p:spPr>
+          <a:xfrm>
+            <a:off x="3611880" y="6693408"/>
+            <a:ext cx="1463040" cy="219456"/>
+          </a:xfrm>
+          <a:prstGeom prst="rect">
+            <a:avLst/>
+          </a:prstGeom>
+          <a:noFill/>
+        </p:spPr>
+        <p:txBody>
+          <a:bodyPr wrap="square" anchor="t" lIns="0" rIns="0" tIns="0" bIns="0">
+            <a:spAutoFit/>
+          </a:bodyPr>
+          <a:lstStyle/>
+          <a:p>
+            <a:pPr algn="ctr">
+              <a:lnSpc>
+                <a:spcPct val="106000"/>
+              </a:lnSpc>
+              <a:spcBef>
+                <a:spcPts val="0"/>
+              </a:spcBef>
+              <a:spcAft>
+                <a:spcPts val="0"/>
+              </a:spcAft>
+            </a:pPr>
+            <a:r>
+              <a:rPr sz="1000" b="0" i="0">
+                <a:solidFill>
+                  <a:srgbClr val="5B6670"/>
+                </a:solidFill>
+                <a:latin typeface="Calibri"/>
+              </a:rPr>
+              <a:t>Name</a:t>
+            </a:r>
+          </a:p>
+        </p:txBody>
+      </p:sp>
+      <p:sp>
+        <p:nvSpPr>
           <p:cNvPr id="75" name="Oval 74"/>
           <p:cNvSpPr/>
           <p:nvPr/>
         </p:nvSpPr>
         <p:spPr>
           <a:xfrm>
-            <a:off x="2252168" y="6147328"/>
-            <a:ext cx="159105" cy="159105"/>
+            <a:off x="5961888" y="5843016"/>
+            <a:ext cx="786384" cy="786384"/>
           </a:xfrm>
           <a:prstGeom prst="ellipse">
             <a:avLst/>
           </a:prstGeom>
           <a:solidFill>
-            <a:srgbClr val="395268"/>
+            <a:srgbClr val="EDF0F2"/>
+          </a:solidFill>
+          <a:ln w="19050">
+            <a:solidFill>
+              <a:srgbClr val="C7CED4"/>
+            </a:solidFill>
+          </a:ln>
+          <a:effectLst/>
+        </p:spPr>
+        <p:style>
+          <a:lnRef idx="1">
+            <a:schemeClr val="accent1"/>
+          </a:lnRef>
+          <a:fillRef idx="3">
+            <a:schemeClr val="accent1"/>
+          </a:fillRef>
+          <a:effectRef idx="2">
+            <a:schemeClr val="accent1"/>
+          </a:effectRef>
+          <a:fontRef idx="minor">
+            <a:schemeClr val="lt1"/>
+          </a:fontRef>
+        </p:style>
+        <p:txBody>
+          <a:bodyPr rtlCol="0" anchor="ctr"/>
+          <a:lstStyle/>
+          <a:p>
+            <a:pPr algn="ctr"/>
+          </a:p>
+        </p:txBody>
+      </p:sp>
+      <p:sp>
+        <p:nvSpPr>
+          <p:cNvPr id="76" name="Oval 75"/>
+          <p:cNvSpPr/>
+          <p:nvPr/>
+        </p:nvSpPr>
+        <p:spPr>
+          <a:xfrm>
+            <a:off x="6237123" y="5968837"/>
+            <a:ext cx="235915" cy="235915"/>
+          </a:xfrm>
+          <a:prstGeom prst="ellipse">
+            <a:avLst/>
+          </a:prstGeom>
+          <a:solidFill>
+            <a:srgbClr val="333E48"/>
           </a:solidFill>
           <a:ln>
             <a:noFill/>
@@ -6244,20 +6255,20 @@
       </p:sp>
       <p:sp>
         <p:nvSpPr>
-          <p:cNvPr id="76" name="Oval 75"/>
+          <p:cNvPr id="77" name="Oval 76"/>
           <p:cNvSpPr/>
           <p:nvPr/>
         </p:nvSpPr>
         <p:spPr>
           <a:xfrm>
-            <a:off x="2172615" y="6348862"/>
-            <a:ext cx="318211" cy="243961"/>
+            <a:off x="6119165" y="6267663"/>
+            <a:ext cx="471830" cy="361736"/>
           </a:xfrm>
           <a:prstGeom prst="ellipse">
             <a:avLst/>
           </a:prstGeom>
           <a:solidFill>
-            <a:srgbClr val="395268"/>
+            <a:srgbClr val="333E48"/>
           </a:solidFill>
           <a:ln>
             <a:noFill/>
@@ -6288,14 +6299,14 @@
       </p:sp>
       <p:sp>
         <p:nvSpPr>
-          <p:cNvPr id="77" name="TextBox 76"/>
+          <p:cNvPr id="78" name="TextBox 77"/>
           <p:cNvSpPr txBox="1"/>
           <p:nvPr/>
         </p:nvSpPr>
         <p:spPr>
           <a:xfrm>
-            <a:off x="1691640" y="6656832"/>
-            <a:ext cx="1280160" cy="219456"/>
+            <a:off x="5623560" y="6693408"/>
+            <a:ext cx="1463040" cy="219456"/>
           </a:xfrm>
           <a:prstGeom prst="rect">
             <a:avLst/>
@@ -6320,9 +6331,9 @@
               </a:spcAft>
             </a:pPr>
             <a:r>
-              <a:rPr sz="950" b="0" i="0">
-                <a:solidFill>
-                  <a:srgbClr val="D8ECE8"/>
+              <a:rPr sz="1000" b="0" i="0">
+                <a:solidFill>
+                  <a:srgbClr val="5B6670"/>
                 </a:solidFill>
                 <a:latin typeface="Calibri"/>
               </a:rPr>
@@ -6333,24 +6344,24 @@
       </p:sp>
       <p:sp>
         <p:nvSpPr>
-          <p:cNvPr id="78" name="Oval 77"/>
+          <p:cNvPr id="79" name="Oval 78"/>
           <p:cNvSpPr/>
           <p:nvPr/>
         </p:nvSpPr>
         <p:spPr>
           <a:xfrm>
-            <a:off x="4078224" y="6062472"/>
-            <a:ext cx="530352" cy="530352"/>
+            <a:off x="7973568" y="5843016"/>
+            <a:ext cx="786384" cy="786384"/>
           </a:xfrm>
           <a:prstGeom prst="ellipse">
             <a:avLst/>
           </a:prstGeom>
           <a:solidFill>
-            <a:srgbClr val="E6EFEC"/>
+            <a:srgbClr val="EDF0F2"/>
           </a:solidFill>
           <a:ln w="19050">
             <a:solidFill>
-              <a:srgbClr val="FFFFFF"/>
+              <a:srgbClr val="C7CED4"/>
             </a:solidFill>
           </a:ln>
           <a:effectLst/>
@@ -6379,20 +6390,20 @@
       </p:sp>
       <p:sp>
         <p:nvSpPr>
-          <p:cNvPr id="79" name="Oval 78"/>
+          <p:cNvPr id="80" name="Oval 79"/>
           <p:cNvSpPr/>
           <p:nvPr/>
         </p:nvSpPr>
         <p:spPr>
           <a:xfrm>
-            <a:off x="4263848" y="6147328"/>
-            <a:ext cx="159105" cy="159105"/>
+            <a:off x="8248803" y="5968837"/>
+            <a:ext cx="235915" cy="235915"/>
           </a:xfrm>
           <a:prstGeom prst="ellipse">
             <a:avLst/>
           </a:prstGeom>
           <a:solidFill>
-            <a:srgbClr val="395268"/>
+            <a:srgbClr val="333E48"/>
           </a:solidFill>
           <a:ln>
             <a:noFill/>
@@ -6423,20 +6434,20 @@
       </p:sp>
       <p:sp>
         <p:nvSpPr>
-          <p:cNvPr id="80" name="Oval 79"/>
+          <p:cNvPr id="81" name="Oval 80"/>
           <p:cNvSpPr/>
           <p:nvPr/>
         </p:nvSpPr>
         <p:spPr>
           <a:xfrm>
-            <a:off x="4184295" y="6348862"/>
-            <a:ext cx="318211" cy="243961"/>
+            <a:off x="8130845" y="6267663"/>
+            <a:ext cx="471830" cy="361736"/>
           </a:xfrm>
           <a:prstGeom prst="ellipse">
             <a:avLst/>
           </a:prstGeom>
           <a:solidFill>
-            <a:srgbClr val="395268"/>
+            <a:srgbClr val="333E48"/>
           </a:solidFill>
           <a:ln>
             <a:noFill/>
@@ -6467,14 +6478,14 @@
       </p:sp>
       <p:sp>
         <p:nvSpPr>
-          <p:cNvPr id="81" name="TextBox 80"/>
+          <p:cNvPr id="82" name="TextBox 81"/>
           <p:cNvSpPr txBox="1"/>
           <p:nvPr/>
         </p:nvSpPr>
         <p:spPr>
           <a:xfrm>
-            <a:off x="3703320" y="6656832"/>
-            <a:ext cx="1280160" cy="219456"/>
+            <a:off x="7635240" y="6693408"/>
+            <a:ext cx="1463040" cy="219456"/>
           </a:xfrm>
           <a:prstGeom prst="rect">
             <a:avLst/>
@@ -6499,9 +6510,9 @@
               </a:spcAft>
             </a:pPr>
             <a:r>
-              <a:rPr sz="950" b="0" i="0">
-                <a:solidFill>
-                  <a:srgbClr val="D8ECE8"/>
+              <a:rPr sz="1000" b="0" i="0">
+                <a:solidFill>
+                  <a:srgbClr val="5B6670"/>
                 </a:solidFill>
                 <a:latin typeface="Calibri"/>
               </a:rPr>
@@ -6512,24 +6523,24 @@
       </p:sp>
       <p:sp>
         <p:nvSpPr>
-          <p:cNvPr id="82" name="Oval 81"/>
+          <p:cNvPr id="83" name="Oval 82"/>
           <p:cNvSpPr/>
           <p:nvPr/>
         </p:nvSpPr>
         <p:spPr>
           <a:xfrm>
-            <a:off x="6089904" y="6062472"/>
-            <a:ext cx="530352" cy="530352"/>
+            <a:off x="9985248" y="5843016"/>
+            <a:ext cx="786384" cy="786384"/>
           </a:xfrm>
           <a:prstGeom prst="ellipse">
             <a:avLst/>
           </a:prstGeom>
           <a:solidFill>
-            <a:srgbClr val="E6EFEC"/>
+            <a:srgbClr val="EDF0F2"/>
           </a:solidFill>
           <a:ln w="19050">
             <a:solidFill>
-              <a:srgbClr val="FFFFFF"/>
+              <a:srgbClr val="C7CED4"/>
             </a:solidFill>
           </a:ln>
           <a:effectLst/>
@@ -6558,20 +6569,20 @@
       </p:sp>
       <p:sp>
         <p:nvSpPr>
-          <p:cNvPr id="83" name="Oval 82"/>
+          <p:cNvPr id="84" name="Oval 83"/>
           <p:cNvSpPr/>
           <p:nvPr/>
         </p:nvSpPr>
         <p:spPr>
           <a:xfrm>
-            <a:off x="6275528" y="6147328"/>
-            <a:ext cx="159105" cy="159105"/>
+            <a:off x="10260483" y="5968837"/>
+            <a:ext cx="235915" cy="235915"/>
           </a:xfrm>
           <a:prstGeom prst="ellipse">
             <a:avLst/>
           </a:prstGeom>
           <a:solidFill>
-            <a:srgbClr val="395268"/>
+            <a:srgbClr val="333E48"/>
           </a:solidFill>
           <a:ln>
             <a:noFill/>
@@ -6602,20 +6613,20 @@
       </p:sp>
       <p:sp>
         <p:nvSpPr>
-          <p:cNvPr id="84" name="Oval 83"/>
+          <p:cNvPr id="85" name="Oval 84"/>
           <p:cNvSpPr/>
           <p:nvPr/>
         </p:nvSpPr>
         <p:spPr>
           <a:xfrm>
-            <a:off x="6195975" y="6348862"/>
-            <a:ext cx="318211" cy="243961"/>
+            <a:off x="10142525" y="6267663"/>
+            <a:ext cx="471830" cy="361736"/>
           </a:xfrm>
           <a:prstGeom prst="ellipse">
             <a:avLst/>
           </a:prstGeom>
           <a:solidFill>
-            <a:srgbClr val="395268"/>
+            <a:srgbClr val="333E48"/>
           </a:solidFill>
           <a:ln>
             <a:noFill/>
@@ -6646,14 +6657,14 @@
       </p:sp>
       <p:sp>
         <p:nvSpPr>
-          <p:cNvPr id="85" name="TextBox 84"/>
+          <p:cNvPr id="86" name="TextBox 85"/>
           <p:cNvSpPr txBox="1"/>
           <p:nvPr/>
         </p:nvSpPr>
         <p:spPr>
           <a:xfrm>
-            <a:off x="5715000" y="6656832"/>
-            <a:ext cx="1280160" cy="219456"/>
+            <a:off x="9646920" y="6693408"/>
+            <a:ext cx="1463040" cy="219456"/>
           </a:xfrm>
           <a:prstGeom prst="rect">
             <a:avLst/>
@@ -6678,367 +6689,9 @@
               </a:spcAft>
             </a:pPr>
             <a:r>
-              <a:rPr sz="950" b="0" i="0">
-                <a:solidFill>
-                  <a:srgbClr val="D8ECE8"/>
-                </a:solidFill>
-                <a:latin typeface="Calibri"/>
-              </a:rPr>
-              <a:t>Name</a:t>
-            </a:r>
-          </a:p>
-        </p:txBody>
-      </p:sp>
-      <p:sp>
-        <p:nvSpPr>
-          <p:cNvPr id="86" name="Oval 85"/>
-          <p:cNvSpPr/>
-          <p:nvPr/>
-        </p:nvSpPr>
-        <p:spPr>
-          <a:xfrm>
-            <a:off x="8101584" y="6062472"/>
-            <a:ext cx="530352" cy="530352"/>
-          </a:xfrm>
-          <a:prstGeom prst="ellipse">
-            <a:avLst/>
-          </a:prstGeom>
-          <a:solidFill>
-            <a:srgbClr val="E6EFEC"/>
-          </a:solidFill>
-          <a:ln w="19050">
-            <a:solidFill>
-              <a:srgbClr val="FFFFFF"/>
-            </a:solidFill>
-          </a:ln>
-          <a:effectLst/>
-        </p:spPr>
-        <p:style>
-          <a:lnRef idx="1">
-            <a:schemeClr val="accent1"/>
-          </a:lnRef>
-          <a:fillRef idx="3">
-            <a:schemeClr val="accent1"/>
-          </a:fillRef>
-          <a:effectRef idx="2">
-            <a:schemeClr val="accent1"/>
-          </a:effectRef>
-          <a:fontRef idx="minor">
-            <a:schemeClr val="lt1"/>
-          </a:fontRef>
-        </p:style>
-        <p:txBody>
-          <a:bodyPr rtlCol="0" anchor="ctr"/>
-          <a:lstStyle/>
-          <a:p>
-            <a:pPr algn="ctr"/>
-          </a:p>
-        </p:txBody>
-      </p:sp>
-      <p:sp>
-        <p:nvSpPr>
-          <p:cNvPr id="87" name="Oval 86"/>
-          <p:cNvSpPr/>
-          <p:nvPr/>
-        </p:nvSpPr>
-        <p:spPr>
-          <a:xfrm>
-            <a:off x="8287208" y="6147328"/>
-            <a:ext cx="159105" cy="159105"/>
-          </a:xfrm>
-          <a:prstGeom prst="ellipse">
-            <a:avLst/>
-          </a:prstGeom>
-          <a:solidFill>
-            <a:srgbClr val="395268"/>
-          </a:solidFill>
-          <a:ln>
-            <a:noFill/>
-          </a:ln>
-          <a:effectLst/>
-        </p:spPr>
-        <p:style>
-          <a:lnRef idx="1">
-            <a:schemeClr val="accent1"/>
-          </a:lnRef>
-          <a:fillRef idx="3">
-            <a:schemeClr val="accent1"/>
-          </a:fillRef>
-          <a:effectRef idx="2">
-            <a:schemeClr val="accent1"/>
-          </a:effectRef>
-          <a:fontRef idx="minor">
-            <a:schemeClr val="lt1"/>
-          </a:fontRef>
-        </p:style>
-        <p:txBody>
-          <a:bodyPr rtlCol="0" anchor="ctr"/>
-          <a:lstStyle/>
-          <a:p>
-            <a:pPr algn="ctr"/>
-          </a:p>
-        </p:txBody>
-      </p:sp>
-      <p:sp>
-        <p:nvSpPr>
-          <p:cNvPr id="88" name="Oval 87"/>
-          <p:cNvSpPr/>
-          <p:nvPr/>
-        </p:nvSpPr>
-        <p:spPr>
-          <a:xfrm>
-            <a:off x="8207655" y="6348862"/>
-            <a:ext cx="318211" cy="243961"/>
-          </a:xfrm>
-          <a:prstGeom prst="ellipse">
-            <a:avLst/>
-          </a:prstGeom>
-          <a:solidFill>
-            <a:srgbClr val="395268"/>
-          </a:solidFill>
-          <a:ln>
-            <a:noFill/>
-          </a:ln>
-          <a:effectLst/>
-        </p:spPr>
-        <p:style>
-          <a:lnRef idx="1">
-            <a:schemeClr val="accent1"/>
-          </a:lnRef>
-          <a:fillRef idx="3">
-            <a:schemeClr val="accent1"/>
-          </a:fillRef>
-          <a:effectRef idx="2">
-            <a:schemeClr val="accent1"/>
-          </a:effectRef>
-          <a:fontRef idx="minor">
-            <a:schemeClr val="lt1"/>
-          </a:fontRef>
-        </p:style>
-        <p:txBody>
-          <a:bodyPr rtlCol="0" anchor="ctr"/>
-          <a:lstStyle/>
-          <a:p>
-            <a:pPr algn="ctr"/>
-          </a:p>
-        </p:txBody>
-      </p:sp>
-      <p:sp>
-        <p:nvSpPr>
-          <p:cNvPr id="89" name="TextBox 88"/>
-          <p:cNvSpPr txBox="1"/>
-          <p:nvPr/>
-        </p:nvSpPr>
-        <p:spPr>
-          <a:xfrm>
-            <a:off x="7726680" y="6656832"/>
-            <a:ext cx="1280160" cy="219456"/>
-          </a:xfrm>
-          <a:prstGeom prst="rect">
-            <a:avLst/>
-          </a:prstGeom>
-          <a:noFill/>
-        </p:spPr>
-        <p:txBody>
-          <a:bodyPr wrap="square" anchor="t" lIns="0" rIns="0" tIns="0" bIns="0">
-            <a:spAutoFit/>
-          </a:bodyPr>
-          <a:lstStyle/>
-          <a:p>
-            <a:pPr algn="ctr">
-              <a:lnSpc>
-                <a:spcPct val="106000"/>
-              </a:lnSpc>
-              <a:spcBef>
-                <a:spcPts val="0"/>
-              </a:spcBef>
-              <a:spcAft>
-                <a:spcPts val="0"/>
-              </a:spcAft>
-            </a:pPr>
-            <a:r>
-              <a:rPr sz="950" b="0" i="0">
-                <a:solidFill>
-                  <a:srgbClr val="D8ECE8"/>
-                </a:solidFill>
-                <a:latin typeface="Calibri"/>
-              </a:rPr>
-              <a:t>Name</a:t>
-            </a:r>
-          </a:p>
-        </p:txBody>
-      </p:sp>
-      <p:sp>
-        <p:nvSpPr>
-          <p:cNvPr id="90" name="Oval 89"/>
-          <p:cNvSpPr/>
-          <p:nvPr/>
-        </p:nvSpPr>
-        <p:spPr>
-          <a:xfrm>
-            <a:off x="10113264" y="6062472"/>
-            <a:ext cx="530352" cy="530352"/>
-          </a:xfrm>
-          <a:prstGeom prst="ellipse">
-            <a:avLst/>
-          </a:prstGeom>
-          <a:solidFill>
-            <a:srgbClr val="E6EFEC"/>
-          </a:solidFill>
-          <a:ln w="19050">
-            <a:solidFill>
-              <a:srgbClr val="FFFFFF"/>
-            </a:solidFill>
-          </a:ln>
-          <a:effectLst/>
-        </p:spPr>
-        <p:style>
-          <a:lnRef idx="1">
-            <a:schemeClr val="accent1"/>
-          </a:lnRef>
-          <a:fillRef idx="3">
-            <a:schemeClr val="accent1"/>
-          </a:fillRef>
-          <a:effectRef idx="2">
-            <a:schemeClr val="accent1"/>
-          </a:effectRef>
-          <a:fontRef idx="minor">
-            <a:schemeClr val="lt1"/>
-          </a:fontRef>
-        </p:style>
-        <p:txBody>
-          <a:bodyPr rtlCol="0" anchor="ctr"/>
-          <a:lstStyle/>
-          <a:p>
-            <a:pPr algn="ctr"/>
-          </a:p>
-        </p:txBody>
-      </p:sp>
-      <p:sp>
-        <p:nvSpPr>
-          <p:cNvPr id="91" name="Oval 90"/>
-          <p:cNvSpPr/>
-          <p:nvPr/>
-        </p:nvSpPr>
-        <p:spPr>
-          <a:xfrm>
-            <a:off x="10298888" y="6147328"/>
-            <a:ext cx="159105" cy="159105"/>
-          </a:xfrm>
-          <a:prstGeom prst="ellipse">
-            <a:avLst/>
-          </a:prstGeom>
-          <a:solidFill>
-            <a:srgbClr val="395268"/>
-          </a:solidFill>
-          <a:ln>
-            <a:noFill/>
-          </a:ln>
-          <a:effectLst/>
-        </p:spPr>
-        <p:style>
-          <a:lnRef idx="1">
-            <a:schemeClr val="accent1"/>
-          </a:lnRef>
-          <a:fillRef idx="3">
-            <a:schemeClr val="accent1"/>
-          </a:fillRef>
-          <a:effectRef idx="2">
-            <a:schemeClr val="accent1"/>
-          </a:effectRef>
-          <a:fontRef idx="minor">
-            <a:schemeClr val="lt1"/>
-          </a:fontRef>
-        </p:style>
-        <p:txBody>
-          <a:bodyPr rtlCol="0" anchor="ctr"/>
-          <a:lstStyle/>
-          <a:p>
-            <a:pPr algn="ctr"/>
-          </a:p>
-        </p:txBody>
-      </p:sp>
-      <p:sp>
-        <p:nvSpPr>
-          <p:cNvPr id="92" name="Oval 91"/>
-          <p:cNvSpPr/>
-          <p:nvPr/>
-        </p:nvSpPr>
-        <p:spPr>
-          <a:xfrm>
-            <a:off x="10219335" y="6348862"/>
-            <a:ext cx="318211" cy="243961"/>
-          </a:xfrm>
-          <a:prstGeom prst="ellipse">
-            <a:avLst/>
-          </a:prstGeom>
-          <a:solidFill>
-            <a:srgbClr val="395268"/>
-          </a:solidFill>
-          <a:ln>
-            <a:noFill/>
-          </a:ln>
-          <a:effectLst/>
-        </p:spPr>
-        <p:style>
-          <a:lnRef idx="1">
-            <a:schemeClr val="accent1"/>
-          </a:lnRef>
-          <a:fillRef idx="3">
-            <a:schemeClr val="accent1"/>
-          </a:fillRef>
-          <a:effectRef idx="2">
-            <a:schemeClr val="accent1"/>
-          </a:effectRef>
-          <a:fontRef idx="minor">
-            <a:schemeClr val="lt1"/>
-          </a:fontRef>
-        </p:style>
-        <p:txBody>
-          <a:bodyPr rtlCol="0" anchor="ctr"/>
-          <a:lstStyle/>
-          <a:p>
-            <a:pPr algn="ctr"/>
-          </a:p>
-        </p:txBody>
-      </p:sp>
-      <p:sp>
-        <p:nvSpPr>
-          <p:cNvPr id="93" name="TextBox 92"/>
-          <p:cNvSpPr txBox="1"/>
-          <p:nvPr/>
-        </p:nvSpPr>
-        <p:spPr>
-          <a:xfrm>
-            <a:off x="9738360" y="6656832"/>
-            <a:ext cx="1280160" cy="219456"/>
-          </a:xfrm>
-          <a:prstGeom prst="rect">
-            <a:avLst/>
-          </a:prstGeom>
-          <a:noFill/>
-        </p:spPr>
-        <p:txBody>
-          <a:bodyPr wrap="square" anchor="t" lIns="0" rIns="0" tIns="0" bIns="0">
-            <a:spAutoFit/>
-          </a:bodyPr>
-          <a:lstStyle/>
-          <a:p>
-            <a:pPr algn="ctr">
-              <a:lnSpc>
-                <a:spcPct val="106000"/>
-              </a:lnSpc>
-              <a:spcBef>
-                <a:spcPts val="0"/>
-              </a:spcBef>
-              <a:spcAft>
-                <a:spcPts val="0"/>
-              </a:spcAft>
-            </a:pPr>
-            <a:r>
-              <a:rPr sz="950" b="0" i="0">
-                <a:solidFill>
-                  <a:srgbClr val="D8ECE8"/>
+              <a:rPr sz="1000" b="0" i="0">
+                <a:solidFill>
+                  <a:srgbClr val="5B6670"/>
                 </a:solidFill>
                 <a:latin typeface="Calibri"/>
               </a:rPr>
@@ -16068,7 +15721,7 @@
                 </a:solidFill>
                 <a:latin typeface="Calibri"/>
               </a:rPr>
-              <a:t>A secure, self-updating AI assistant can cut frontliner lookup time and error risk today, with a low-cost, low-risk path to bank-wide rollout</a:t>
+              <a:t>A secure AI assistant already saves frontliners time and prevents errors today, and it is low cost and low risk to scale bank-wide</a:t>
             </a:r>
           </a:p>
         </p:txBody>
@@ -16423,7 +16076,7 @@
                 </a:solidFill>
                 <a:latin typeface="Calibri"/>
               </a:rPr>
-              <a:t>OSG lets frontliners ask in plain language and returns a source-cited answer in seconds, grounded only in the bank's own content, so speed no longer trades off against accuracy or compliance.</a:t>
+              <a:t>Frontliners ask in plain language and get a source-cited answer in seconds, taken only from the bank's own approved content. Speed no longer trades off against accuracy or compliance.</a:t>
             </a:r>
           </a:p>
         </p:txBody>
@@ -16580,7 +16233,7 @@
                 </a:solidFill>
                 <a:latin typeface="Calibri"/>
               </a:rPr>
-              <a:t>Knowledge is scattered across portals and PDFs and changes constantly; manual lookup is slow, and a wrong or expired figure is a compliance and trust risk.</a:t>
+              <a:t>Product and promo details sit across many portals and PDFs and change often. Looking them up is slow, and a wrong or expired answer is a compliance and trust risk.</a:t>
             </a:r>
           </a:p>
         </p:txBody>
@@ -16737,7 +16390,7 @@
                 </a:solidFill>
                 <a:latin typeface="Calibri"/>
               </a:rPr>
-              <a:t>A secure AI assistant that answers only from the bank's own approved content and shows the source for every figure. Expired offers are flagged. Works in Bahasa Indonesia and English.</a:t>
+              <a:t>One secure assistant answers only from approved bank content and shows the source for every answer. Expired offers are flagged. It works in Bahasa Indonesia and English.</a:t>
             </a:r>
           </a:p>
         </p:txBody>
@@ -16894,7 +16547,7 @@
                 </a:solidFill>
                 <a:latin typeface="Calibri"/>
               </a:rPr>
-              <a:t>Faster service and higher first-contact resolution, fewer errors, and new cross-sell moments, at a low running cost.</a:t>
+              <a:t>Faster service, higher first-contact resolution, fewer errors, and new cross-sell moments, all at a low running cost.</a:t>
             </a:r>
           </a:p>
         </p:txBody>

</xml_diff>

<commit_message>
cover: add soft red-to-green gradient panel behind the knowledge graph
</commit_message>
<xml_diff>
--- a/OSG-Smart-Guide.pptx
+++ b/OSG-Smart-Guide.pptx
@@ -3190,42 +3190,58 @@
           </a:p>
         </p:txBody>
       </p:sp>
-      <p:cxnSp>
-        <p:nvCxnSpPr>
-          <p:cNvPr id="4" name="Connector 3"/>
-          <p:cNvCxnSpPr/>
-          <p:nvPr/>
-        </p:nvCxnSpPr>
-        <p:spPr>
-          <a:xfrm flipH="1" flipV="1">
-            <a:off x="7178040" y="1234440"/>
-            <a:ext cx="1737360" cy="777240"/>
-          </a:xfrm>
-          <a:prstGeom prst="line">
-            <a:avLst/>
-          </a:prstGeom>
-          <a:ln w="9525">
-            <a:solidFill>
-              <a:srgbClr val="D7DCE1"/>
-            </a:solidFill>
+      <p:sp>
+        <p:nvSpPr>
+          <p:cNvPr id="4" name="Rounded Rectangle 3"/>
+          <p:cNvSpPr/>
+          <p:nvPr/>
+        </p:nvSpPr>
+        <p:spPr>
+          <a:xfrm>
+            <a:off x="6126480" y="658368"/>
+            <a:ext cx="5870448" cy="4681728"/>
+          </a:xfrm>
+          <a:prstGeom prst="roundRect">
+            <a:avLst/>
+          </a:prstGeom>
+          <a:gradFill rotWithShape="1">
+            <a:gsLst>
+              <a:gs pos="0">
+                <a:srgbClr val="FBDFE4"/>
+              </a:gs>
+              <a:gs pos="100000">
+                <a:srgbClr val="DCF0E9"/>
+              </a:gs>
+            </a:gsLst>
+            <a:lin scaled="0" ang="18600000"/>
+          </a:gradFill>
+          <a:ln>
+            <a:noFill/>
           </a:ln>
           <a:effectLst/>
         </p:spPr>
         <p:style>
-          <a:lnRef idx="2">
+          <a:lnRef idx="1">
             <a:schemeClr val="accent1"/>
           </a:lnRef>
-          <a:fillRef idx="0">
+          <a:fillRef idx="3">
             <a:schemeClr val="accent1"/>
           </a:fillRef>
-          <a:effectRef idx="1">
+          <a:effectRef idx="2">
             <a:schemeClr val="accent1"/>
           </a:effectRef>
           <a:fontRef idx="minor">
-            <a:schemeClr val="tx1"/>
+            <a:schemeClr val="lt1"/>
           </a:fontRef>
         </p:style>
-      </p:cxnSp>
+        <p:txBody>
+          <a:bodyPr rtlCol="0" anchor="ctr"/>
+          <a:lstStyle/>
+          <a:p>
+            <a:pPr algn="ctr"/>
+          </a:p>
+        </p:txBody>
+      </p:sp>
       <p:cxnSp>
         <p:nvCxnSpPr>
           <p:cNvPr id="5" name="Connector 4"/>
@@ -3234,8 +3250,8 @@
         </p:nvCxnSpPr>
         <p:spPr>
           <a:xfrm flipH="1" flipV="1">
-            <a:off x="8275320" y="868680"/>
-            <a:ext cx="640080" cy="1143000"/>
+            <a:off x="7178040" y="1234440"/>
+            <a:ext cx="1737360" cy="777240"/>
           </a:xfrm>
           <a:prstGeom prst="line">
             <a:avLst/>
@@ -3269,9 +3285,9 @@
           <p:nvPr/>
         </p:nvCxnSpPr>
         <p:spPr>
-          <a:xfrm flipV="1">
-            <a:off x="8915400" y="1234440"/>
-            <a:ext cx="1143000" cy="777240"/>
+          <a:xfrm flipH="1" flipV="1">
+            <a:off x="8275320" y="868680"/>
+            <a:ext cx="640080" cy="1143000"/>
           </a:xfrm>
           <a:prstGeom prst="line">
             <a:avLst/>
@@ -3305,9 +3321,9 @@
           <p:nvPr/>
         </p:nvCxnSpPr>
         <p:spPr>
-          <a:xfrm flipH="1">
-            <a:off x="8046720" y="2011680"/>
-            <a:ext cx="868680" cy="914400"/>
+          <a:xfrm flipV="1">
+            <a:off x="8915400" y="1234440"/>
+            <a:ext cx="1143000" cy="777240"/>
           </a:xfrm>
           <a:prstGeom prst="line">
             <a:avLst/>
@@ -3341,9 +3357,9 @@
           <p:nvPr/>
         </p:nvCxnSpPr>
         <p:spPr>
-          <a:xfrm>
-            <a:off x="8915400" y="2011680"/>
-            <a:ext cx="777240" cy="685800"/>
+          <a:xfrm flipH="1">
+            <a:off x="8046720" y="2011680"/>
+            <a:ext cx="868680" cy="914400"/>
           </a:xfrm>
           <a:prstGeom prst="line">
             <a:avLst/>
@@ -3377,9 +3393,9 @@
           <p:nvPr/>
         </p:nvCxnSpPr>
         <p:spPr>
-          <a:xfrm flipH="1" flipV="1">
-            <a:off x="7726679" y="1965960"/>
-            <a:ext cx="1188721" cy="45720"/>
+          <a:xfrm>
+            <a:off x="8915400" y="2011680"/>
+            <a:ext cx="777240" cy="685800"/>
           </a:xfrm>
           <a:prstGeom prst="line">
             <a:avLst/>
@@ -3413,9 +3429,9 @@
           <p:nvPr/>
         </p:nvCxnSpPr>
         <p:spPr>
-          <a:xfrm flipH="1">
-            <a:off x="7360920" y="2011680"/>
-            <a:ext cx="1554480" cy="1920240"/>
+          <a:xfrm flipH="1" flipV="1">
+            <a:off x="7726679" y="1965960"/>
+            <a:ext cx="1188721" cy="45720"/>
           </a:xfrm>
           <a:prstGeom prst="line">
             <a:avLst/>
@@ -3449,9 +3465,9 @@
           <p:nvPr/>
         </p:nvCxnSpPr>
         <p:spPr>
-          <a:xfrm flipH="1" flipV="1">
-            <a:off x="10058400" y="1234440"/>
-            <a:ext cx="777240" cy="2377440"/>
+          <a:xfrm flipH="1">
+            <a:off x="7360920" y="2011680"/>
+            <a:ext cx="1554480" cy="1920240"/>
           </a:xfrm>
           <a:prstGeom prst="line">
             <a:avLst/>
@@ -3485,9 +3501,9 @@
           <p:nvPr/>
         </p:nvCxnSpPr>
         <p:spPr>
-          <a:xfrm flipV="1">
-            <a:off x="10835640" y="2011680"/>
-            <a:ext cx="704088" cy="1600200"/>
+          <a:xfrm flipH="1" flipV="1">
+            <a:off x="10058400" y="1234440"/>
+            <a:ext cx="777240" cy="2377440"/>
           </a:xfrm>
           <a:prstGeom prst="line">
             <a:avLst/>
@@ -3521,9 +3537,9 @@
           <p:nvPr/>
         </p:nvCxnSpPr>
         <p:spPr>
-          <a:xfrm flipH="1" flipV="1">
-            <a:off x="9692640" y="2697480"/>
-            <a:ext cx="1143000" cy="914400"/>
+          <a:xfrm flipV="1">
+            <a:off x="10835640" y="2011680"/>
+            <a:ext cx="704088" cy="1600200"/>
           </a:xfrm>
           <a:prstGeom prst="line">
             <a:avLst/>
@@ -3557,9 +3573,9 @@
           <p:nvPr/>
         </p:nvCxnSpPr>
         <p:spPr>
-          <a:xfrm>
-            <a:off x="10835640" y="3611880"/>
-            <a:ext cx="548640" cy="1005840"/>
+          <a:xfrm flipH="1" flipV="1">
+            <a:off x="9692640" y="2697480"/>
+            <a:ext cx="1143000" cy="914400"/>
           </a:xfrm>
           <a:prstGeom prst="line">
             <a:avLst/>
@@ -3593,9 +3609,9 @@
           <p:nvPr/>
         </p:nvCxnSpPr>
         <p:spPr>
-          <a:xfrm flipH="1">
-            <a:off x="10195560" y="3611880"/>
-            <a:ext cx="640080" cy="548640"/>
+          <a:xfrm>
+            <a:off x="10835640" y="3611880"/>
+            <a:ext cx="548640" cy="1005840"/>
           </a:xfrm>
           <a:prstGeom prst="line">
             <a:avLst/>
@@ -3629,9 +3645,9 @@
           <p:nvPr/>
         </p:nvCxnSpPr>
         <p:spPr>
-          <a:xfrm flipV="1">
-            <a:off x="10835640" y="3063240"/>
-            <a:ext cx="1097280" cy="548640"/>
+          <a:xfrm flipH="1">
+            <a:off x="10195560" y="3611880"/>
+            <a:ext cx="640080" cy="548640"/>
           </a:xfrm>
           <a:prstGeom prst="line">
             <a:avLst/>
@@ -3665,9 +3681,9 @@
           <p:nvPr/>
         </p:nvCxnSpPr>
         <p:spPr>
-          <a:xfrm flipH="1">
-            <a:off x="9784080" y="3611880"/>
-            <a:ext cx="1051560" cy="1188720"/>
+          <a:xfrm flipV="1">
+            <a:off x="10835640" y="3063240"/>
+            <a:ext cx="1097280" cy="548640"/>
           </a:xfrm>
           <a:prstGeom prst="line">
             <a:avLst/>
@@ -3701,9 +3717,9 @@
           <p:nvPr/>
         </p:nvCxnSpPr>
         <p:spPr>
-          <a:xfrm flipH="1" flipV="1">
-            <a:off x="6812280" y="2468880"/>
-            <a:ext cx="548640" cy="1463040"/>
+          <a:xfrm flipH="1">
+            <a:off x="9784080" y="3611880"/>
+            <a:ext cx="1051560" cy="1188720"/>
           </a:xfrm>
           <a:prstGeom prst="line">
             <a:avLst/>
@@ -3738,8 +3754,8 @@
         </p:nvCxnSpPr>
         <p:spPr>
           <a:xfrm flipH="1" flipV="1">
-            <a:off x="6675120" y="3401568"/>
-            <a:ext cx="685800" cy="530352"/>
+            <a:off x="6812280" y="2468880"/>
+            <a:ext cx="548640" cy="1463040"/>
           </a:xfrm>
           <a:prstGeom prst="line">
             <a:avLst/>
@@ -3773,9 +3789,9 @@
           <p:nvPr/>
         </p:nvCxnSpPr>
         <p:spPr>
-          <a:xfrm flipV="1">
-            <a:off x="7360920" y="2926080"/>
-            <a:ext cx="685800" cy="1005840"/>
+          <a:xfrm flipH="1" flipV="1">
+            <a:off x="6675120" y="3401568"/>
+            <a:ext cx="685800" cy="530352"/>
           </a:xfrm>
           <a:prstGeom prst="line">
             <a:avLst/>
@@ -3809,9 +3825,9 @@
           <p:nvPr/>
         </p:nvCxnSpPr>
         <p:spPr>
-          <a:xfrm>
-            <a:off x="7360920" y="3931920"/>
-            <a:ext cx="1097280" cy="685800"/>
+          <a:xfrm flipV="1">
+            <a:off x="7360920" y="2926080"/>
+            <a:ext cx="685800" cy="1005840"/>
           </a:xfrm>
           <a:prstGeom prst="line">
             <a:avLst/>
@@ -3845,9 +3861,9 @@
           <p:nvPr/>
         </p:nvCxnSpPr>
         <p:spPr>
-          <a:xfrm flipH="1">
-            <a:off x="6903720" y="3931920"/>
-            <a:ext cx="457200" cy="960120"/>
+          <a:xfrm>
+            <a:off x="7360920" y="3931920"/>
+            <a:ext cx="1097280" cy="685800"/>
           </a:xfrm>
           <a:prstGeom prst="line">
             <a:avLst/>
@@ -3881,9 +3897,9 @@
           <p:nvPr/>
         </p:nvCxnSpPr>
         <p:spPr>
-          <a:xfrm flipV="1">
-            <a:off x="10058400" y="1078992"/>
-            <a:ext cx="1691640" cy="155448"/>
+          <a:xfrm flipH="1">
+            <a:off x="6903720" y="3931920"/>
+            <a:ext cx="457200" cy="960120"/>
           </a:xfrm>
           <a:prstGeom prst="line">
             <a:avLst/>
@@ -3917,9 +3933,9 @@
           <p:nvPr/>
         </p:nvCxnSpPr>
         <p:spPr>
-          <a:xfrm flipH="1">
-            <a:off x="8046720" y="2697480"/>
-            <a:ext cx="1645920" cy="228600"/>
+          <a:xfrm flipV="1">
+            <a:off x="10058400" y="1078992"/>
+            <a:ext cx="1691640" cy="155448"/>
           </a:xfrm>
           <a:prstGeom prst="line">
             <a:avLst/>
@@ -3953,9 +3969,9 @@
           <p:nvPr/>
         </p:nvCxnSpPr>
         <p:spPr>
-          <a:xfrm>
-            <a:off x="8458200" y="4617720"/>
-            <a:ext cx="1325880" cy="182880"/>
+          <a:xfrm flipH="1">
+            <a:off x="8046720" y="2697480"/>
+            <a:ext cx="1645920" cy="228600"/>
           </a:xfrm>
           <a:prstGeom prst="line">
             <a:avLst/>
@@ -3990,8 +4006,8 @@
         </p:nvCxnSpPr>
         <p:spPr>
           <a:xfrm>
-            <a:off x="11539728" y="2011680"/>
-            <a:ext cx="393192" cy="1051560"/>
+            <a:off x="8458200" y="4617720"/>
+            <a:ext cx="1325880" cy="182880"/>
           </a:xfrm>
           <a:prstGeom prst="line">
             <a:avLst/>
@@ -4025,9 +4041,9 @@
           <p:nvPr/>
         </p:nvCxnSpPr>
         <p:spPr>
-          <a:xfrm flipH="1" flipV="1">
-            <a:off x="7726679" y="1965960"/>
-            <a:ext cx="320041" cy="960120"/>
+          <a:xfrm>
+            <a:off x="11539728" y="2011680"/>
+            <a:ext cx="393192" cy="1051560"/>
           </a:xfrm>
           <a:prstGeom prst="line">
             <a:avLst/>
@@ -4061,9 +4077,9 @@
           <p:nvPr/>
         </p:nvCxnSpPr>
         <p:spPr>
-          <a:xfrm flipH="1">
-            <a:off x="6812280" y="1234440"/>
-            <a:ext cx="365760" cy="1234440"/>
+          <a:xfrm flipH="1" flipV="1">
+            <a:off x="7726679" y="1965960"/>
+            <a:ext cx="320041" cy="960120"/>
           </a:xfrm>
           <a:prstGeom prst="line">
             <a:avLst/>
@@ -4097,9 +4113,9 @@
           <p:nvPr/>
         </p:nvCxnSpPr>
         <p:spPr>
-          <a:xfrm flipV="1">
-            <a:off x="9784080" y="4617720"/>
-            <a:ext cx="1600200" cy="182880"/>
+          <a:xfrm flipH="1">
+            <a:off x="6812280" y="1234440"/>
+            <a:ext cx="365760" cy="1234440"/>
           </a:xfrm>
           <a:prstGeom prst="line">
             <a:avLst/>
@@ -4126,9 +4142,45 @@
           </a:fontRef>
         </p:style>
       </p:cxnSp>
-      <p:sp>
-        <p:nvSpPr>
-          <p:cNvPr id="30" name="Oval 29"/>
+      <p:cxnSp>
+        <p:nvCxnSpPr>
+          <p:cNvPr id="30" name="Connector 29"/>
+          <p:cNvCxnSpPr/>
+          <p:nvPr/>
+        </p:nvCxnSpPr>
+        <p:spPr>
+          <a:xfrm flipV="1">
+            <a:off x="9784080" y="4617720"/>
+            <a:ext cx="1600200" cy="182880"/>
+          </a:xfrm>
+          <a:prstGeom prst="line">
+            <a:avLst/>
+          </a:prstGeom>
+          <a:ln w="9525">
+            <a:solidFill>
+              <a:srgbClr val="D7DCE1"/>
+            </a:solidFill>
+          </a:ln>
+          <a:effectLst/>
+        </p:spPr>
+        <p:style>
+          <a:lnRef idx="2">
+            <a:schemeClr val="accent1"/>
+          </a:lnRef>
+          <a:fillRef idx="0">
+            <a:schemeClr val="accent1"/>
+          </a:fillRef>
+          <a:effectRef idx="1">
+            <a:schemeClr val="accent1"/>
+          </a:effectRef>
+          <a:fontRef idx="minor">
+            <a:schemeClr val="tx1"/>
+          </a:fontRef>
+        </p:style>
+      </p:cxnSp>
+      <p:sp>
+        <p:nvSpPr>
+          <p:cNvPr id="31" name="Oval 30"/>
           <p:cNvSpPr/>
           <p:nvPr/>
         </p:nvSpPr>
@@ -4174,7 +4226,7 @@
       </p:sp>
       <p:sp>
         <p:nvSpPr>
-          <p:cNvPr id="31" name="Oval 30"/>
+          <p:cNvPr id="32" name="Oval 31"/>
           <p:cNvSpPr/>
           <p:nvPr/>
         </p:nvSpPr>
@@ -4220,7 +4272,7 @@
       </p:sp>
       <p:sp>
         <p:nvSpPr>
-          <p:cNvPr id="32" name="Oval 31"/>
+          <p:cNvPr id="33" name="Oval 32"/>
           <p:cNvSpPr/>
           <p:nvPr/>
         </p:nvSpPr>
@@ -4266,7 +4318,7 @@
       </p:sp>
       <p:sp>
         <p:nvSpPr>
-          <p:cNvPr id="33" name="Oval 32"/>
+          <p:cNvPr id="34" name="Oval 33"/>
           <p:cNvSpPr/>
           <p:nvPr/>
         </p:nvSpPr>
@@ -4312,7 +4364,7 @@
       </p:sp>
       <p:sp>
         <p:nvSpPr>
-          <p:cNvPr id="34" name="Oval 33"/>
+          <p:cNvPr id="35" name="Oval 34"/>
           <p:cNvSpPr/>
           <p:nvPr/>
         </p:nvSpPr>
@@ -4358,7 +4410,7 @@
       </p:sp>
       <p:sp>
         <p:nvSpPr>
-          <p:cNvPr id="35" name="Oval 34"/>
+          <p:cNvPr id="36" name="Oval 35"/>
           <p:cNvSpPr/>
           <p:nvPr/>
         </p:nvSpPr>
@@ -4404,7 +4456,7 @@
       </p:sp>
       <p:sp>
         <p:nvSpPr>
-          <p:cNvPr id="36" name="Oval 35"/>
+          <p:cNvPr id="37" name="Oval 36"/>
           <p:cNvSpPr/>
           <p:nvPr/>
         </p:nvSpPr>
@@ -4450,7 +4502,7 @@
       </p:sp>
       <p:sp>
         <p:nvSpPr>
-          <p:cNvPr id="37" name="Oval 36"/>
+          <p:cNvPr id="38" name="Oval 37"/>
           <p:cNvSpPr/>
           <p:nvPr/>
         </p:nvSpPr>
@@ -4496,7 +4548,7 @@
       </p:sp>
       <p:sp>
         <p:nvSpPr>
-          <p:cNvPr id="38" name="Oval 37"/>
+          <p:cNvPr id="39" name="Oval 38"/>
           <p:cNvSpPr/>
           <p:nvPr/>
         </p:nvSpPr>
@@ -4542,7 +4594,7 @@
       </p:sp>
       <p:sp>
         <p:nvSpPr>
-          <p:cNvPr id="39" name="Oval 38"/>
+          <p:cNvPr id="40" name="Oval 39"/>
           <p:cNvSpPr/>
           <p:nvPr/>
         </p:nvSpPr>
@@ -4588,7 +4640,7 @@
       </p:sp>
       <p:sp>
         <p:nvSpPr>
-          <p:cNvPr id="40" name="Oval 39"/>
+          <p:cNvPr id="41" name="Oval 40"/>
           <p:cNvSpPr/>
           <p:nvPr/>
         </p:nvSpPr>
@@ -4634,7 +4686,7 @@
       </p:sp>
       <p:sp>
         <p:nvSpPr>
-          <p:cNvPr id="41" name="Oval 40"/>
+          <p:cNvPr id="42" name="Oval 41"/>
           <p:cNvSpPr/>
           <p:nvPr/>
         </p:nvSpPr>
@@ -4680,7 +4732,7 @@
       </p:sp>
       <p:sp>
         <p:nvSpPr>
-          <p:cNvPr id="42" name="Oval 41"/>
+          <p:cNvPr id="43" name="Oval 42"/>
           <p:cNvSpPr/>
           <p:nvPr/>
         </p:nvSpPr>
@@ -4726,7 +4778,7 @@
       </p:sp>
       <p:sp>
         <p:nvSpPr>
-          <p:cNvPr id="43" name="Oval 42"/>
+          <p:cNvPr id="44" name="Oval 43"/>
           <p:cNvSpPr/>
           <p:nvPr/>
         </p:nvSpPr>
@@ -4772,7 +4824,7 @@
       </p:sp>
       <p:sp>
         <p:nvSpPr>
-          <p:cNvPr id="44" name="Oval 43"/>
+          <p:cNvPr id="45" name="Oval 44"/>
           <p:cNvSpPr/>
           <p:nvPr/>
         </p:nvSpPr>
@@ -4818,7 +4870,7 @@
       </p:sp>
       <p:sp>
         <p:nvSpPr>
-          <p:cNvPr id="45" name="Oval 44"/>
+          <p:cNvPr id="46" name="Oval 45"/>
           <p:cNvSpPr/>
           <p:nvPr/>
         </p:nvSpPr>
@@ -4864,7 +4916,7 @@
       </p:sp>
       <p:sp>
         <p:nvSpPr>
-          <p:cNvPr id="46" name="Oval 45"/>
+          <p:cNvPr id="47" name="Oval 46"/>
           <p:cNvSpPr/>
           <p:nvPr/>
         </p:nvSpPr>
@@ -4908,7 +4960,7 @@
       </p:sp>
       <p:sp>
         <p:nvSpPr>
-          <p:cNvPr id="47" name="Oval 46"/>
+          <p:cNvPr id="48" name="Oval 47"/>
           <p:cNvSpPr/>
           <p:nvPr/>
         </p:nvSpPr>
@@ -4952,7 +5004,7 @@
       </p:sp>
       <p:sp>
         <p:nvSpPr>
-          <p:cNvPr id="48" name="Oval 47"/>
+          <p:cNvPr id="49" name="Oval 48"/>
           <p:cNvSpPr/>
           <p:nvPr/>
         </p:nvSpPr>
@@ -4996,7 +5048,7 @@
       </p:sp>
       <p:sp>
         <p:nvSpPr>
-          <p:cNvPr id="49" name="Oval 48"/>
+          <p:cNvPr id="50" name="Oval 49"/>
           <p:cNvSpPr/>
           <p:nvPr/>
         </p:nvSpPr>
@@ -5042,7 +5094,7 @@
       </p:sp>
       <p:sp>
         <p:nvSpPr>
-          <p:cNvPr id="50" name="Oval 49"/>
+          <p:cNvPr id="51" name="Oval 50"/>
           <p:cNvSpPr/>
           <p:nvPr/>
         </p:nvSpPr>
@@ -5086,7 +5138,7 @@
       </p:sp>
       <p:sp>
         <p:nvSpPr>
-          <p:cNvPr id="51" name="Oval 50"/>
+          <p:cNvPr id="52" name="Oval 51"/>
           <p:cNvSpPr/>
           <p:nvPr/>
         </p:nvSpPr>
@@ -5130,7 +5182,7 @@
       </p:sp>
       <p:sp>
         <p:nvSpPr>
-          <p:cNvPr id="52" name="Oval 51"/>
+          <p:cNvPr id="53" name="Oval 52"/>
           <p:cNvSpPr/>
           <p:nvPr/>
         </p:nvSpPr>
@@ -5174,7 +5226,7 @@
       </p:sp>
       <p:sp>
         <p:nvSpPr>
-          <p:cNvPr id="53" name="Oval 52"/>
+          <p:cNvPr id="54" name="Oval 53"/>
           <p:cNvSpPr/>
           <p:nvPr/>
         </p:nvSpPr>
@@ -5218,7 +5270,7 @@
       </p:sp>
       <p:sp>
         <p:nvSpPr>
-          <p:cNvPr id="54" name="Oval 53"/>
+          <p:cNvPr id="55" name="Oval 54"/>
           <p:cNvSpPr/>
           <p:nvPr/>
         </p:nvSpPr>
@@ -5264,7 +5316,7 @@
       </p:sp>
       <p:sp>
         <p:nvSpPr>
-          <p:cNvPr id="55" name="Oval 54"/>
+          <p:cNvPr id="56" name="Oval 55"/>
           <p:cNvSpPr/>
           <p:nvPr/>
         </p:nvSpPr>
@@ -5308,7 +5360,7 @@
       </p:sp>
       <p:sp>
         <p:nvSpPr>
-          <p:cNvPr id="56" name="Oval 55"/>
+          <p:cNvPr id="57" name="Oval 56"/>
           <p:cNvSpPr/>
           <p:nvPr/>
         </p:nvSpPr>
@@ -5352,7 +5404,7 @@
       </p:sp>
       <p:sp>
         <p:nvSpPr>
-          <p:cNvPr id="57" name="Oval 56"/>
+          <p:cNvPr id="58" name="Oval 57"/>
           <p:cNvSpPr/>
           <p:nvPr/>
         </p:nvSpPr>
@@ -5396,7 +5448,7 @@
       </p:sp>
       <p:sp>
         <p:nvSpPr>
-          <p:cNvPr id="58" name="Oval 57"/>
+          <p:cNvPr id="59" name="Oval 58"/>
           <p:cNvSpPr/>
           <p:nvPr/>
         </p:nvSpPr>
@@ -5440,7 +5492,7 @@
       </p:sp>
       <p:sp>
         <p:nvSpPr>
-          <p:cNvPr id="59" name="Oval 58"/>
+          <p:cNvPr id="60" name="Oval 59"/>
           <p:cNvSpPr/>
           <p:nvPr/>
         </p:nvSpPr>
@@ -5486,7 +5538,7 @@
       </p:sp>
       <p:sp>
         <p:nvSpPr>
-          <p:cNvPr id="60" name="Oval 59"/>
+          <p:cNvPr id="61" name="Oval 60"/>
           <p:cNvSpPr/>
           <p:nvPr/>
         </p:nvSpPr>
@@ -5530,7 +5582,7 @@
       </p:sp>
       <p:sp>
         <p:nvSpPr>
-          <p:cNvPr id="61" name="TextBox 60"/>
+          <p:cNvPr id="62" name="TextBox 61"/>
           <p:cNvSpPr txBox="1"/>
           <p:nvPr/>
         </p:nvSpPr>
@@ -5584,7 +5636,7 @@
       </p:sp>
       <p:sp>
         <p:nvSpPr>
-          <p:cNvPr id="62" name="TextBox 61"/>
+          <p:cNvPr id="63" name="TextBox 62"/>
           <p:cNvSpPr txBox="1"/>
           <p:nvPr/>
         </p:nvSpPr>
@@ -5629,7 +5681,7 @@
       </p:sp>
       <p:sp>
         <p:nvSpPr>
-          <p:cNvPr id="63" name="Rounded Rectangle 62"/>
+          <p:cNvPr id="64" name="Rounded Rectangle 63"/>
           <p:cNvSpPr/>
           <p:nvPr/>
         </p:nvSpPr>
@@ -5673,7 +5725,7 @@
       </p:sp>
       <p:sp>
         <p:nvSpPr>
-          <p:cNvPr id="64" name="TextBox 63"/>
+          <p:cNvPr id="65" name="TextBox 64"/>
           <p:cNvSpPr txBox="1"/>
           <p:nvPr/>
         </p:nvSpPr>
@@ -5718,7 +5770,7 @@
       </p:sp>
       <p:sp>
         <p:nvSpPr>
-          <p:cNvPr id="65" name="Rectangle 64"/>
+          <p:cNvPr id="66" name="Rectangle 65"/>
           <p:cNvSpPr/>
           <p:nvPr/>
         </p:nvSpPr>
@@ -5762,7 +5814,7 @@
       </p:sp>
       <p:sp>
         <p:nvSpPr>
-          <p:cNvPr id="66" name="TextBox 65"/>
+          <p:cNvPr id="67" name="TextBox 66"/>
           <p:cNvSpPr txBox="1"/>
           <p:nvPr/>
         </p:nvSpPr>
@@ -5807,7 +5859,7 @@
       </p:sp>
       <p:sp>
         <p:nvSpPr>
-          <p:cNvPr id="67" name="Oval 66"/>
+          <p:cNvPr id="68" name="Oval 67"/>
           <p:cNvSpPr/>
           <p:nvPr/>
         </p:nvSpPr>
@@ -5853,7 +5905,7 @@
       </p:sp>
       <p:sp>
         <p:nvSpPr>
-          <p:cNvPr id="68" name="Oval 67"/>
+          <p:cNvPr id="69" name="Oval 68"/>
           <p:cNvSpPr/>
           <p:nvPr/>
         </p:nvSpPr>
@@ -5897,7 +5949,7 @@
       </p:sp>
       <p:sp>
         <p:nvSpPr>
-          <p:cNvPr id="69" name="Oval 68"/>
+          <p:cNvPr id="70" name="Oval 69"/>
           <p:cNvSpPr/>
           <p:nvPr/>
         </p:nvSpPr>
@@ -5941,7 +5993,7 @@
       </p:sp>
       <p:sp>
         <p:nvSpPr>
-          <p:cNvPr id="70" name="TextBox 69"/>
+          <p:cNvPr id="71" name="TextBox 70"/>
           <p:cNvSpPr txBox="1"/>
           <p:nvPr/>
         </p:nvSpPr>
@@ -5986,7 +6038,7 @@
       </p:sp>
       <p:sp>
         <p:nvSpPr>
-          <p:cNvPr id="71" name="Oval 70"/>
+          <p:cNvPr id="72" name="Oval 71"/>
           <p:cNvSpPr/>
           <p:nvPr/>
         </p:nvSpPr>
@@ -6032,7 +6084,7 @@
       </p:sp>
       <p:sp>
         <p:nvSpPr>
-          <p:cNvPr id="72" name="Oval 71"/>
+          <p:cNvPr id="73" name="Oval 72"/>
           <p:cNvSpPr/>
           <p:nvPr/>
         </p:nvSpPr>
@@ -6076,7 +6128,7 @@
       </p:sp>
       <p:sp>
         <p:nvSpPr>
-          <p:cNvPr id="73" name="Oval 72"/>
+          <p:cNvPr id="74" name="Oval 73"/>
           <p:cNvSpPr/>
           <p:nvPr/>
         </p:nvSpPr>
@@ -6120,7 +6172,7 @@
       </p:sp>
       <p:sp>
         <p:nvSpPr>
-          <p:cNvPr id="74" name="TextBox 73"/>
+          <p:cNvPr id="75" name="TextBox 74"/>
           <p:cNvSpPr txBox="1"/>
           <p:nvPr/>
         </p:nvSpPr>
@@ -6165,7 +6217,7 @@
       </p:sp>
       <p:sp>
         <p:nvSpPr>
-          <p:cNvPr id="75" name="Oval 74"/>
+          <p:cNvPr id="76" name="Oval 75"/>
           <p:cNvSpPr/>
           <p:nvPr/>
         </p:nvSpPr>
@@ -6211,7 +6263,7 @@
       </p:sp>
       <p:sp>
         <p:nvSpPr>
-          <p:cNvPr id="76" name="Oval 75"/>
+          <p:cNvPr id="77" name="Oval 76"/>
           <p:cNvSpPr/>
           <p:nvPr/>
         </p:nvSpPr>
@@ -6255,7 +6307,7 @@
       </p:sp>
       <p:sp>
         <p:nvSpPr>
-          <p:cNvPr id="77" name="Oval 76"/>
+          <p:cNvPr id="78" name="Oval 77"/>
           <p:cNvSpPr/>
           <p:nvPr/>
         </p:nvSpPr>
@@ -6299,7 +6351,7 @@
       </p:sp>
       <p:sp>
         <p:nvSpPr>
-          <p:cNvPr id="78" name="TextBox 77"/>
+          <p:cNvPr id="79" name="TextBox 78"/>
           <p:cNvSpPr txBox="1"/>
           <p:nvPr/>
         </p:nvSpPr>
@@ -6344,7 +6396,7 @@
       </p:sp>
       <p:sp>
         <p:nvSpPr>
-          <p:cNvPr id="79" name="Oval 78"/>
+          <p:cNvPr id="80" name="Oval 79"/>
           <p:cNvSpPr/>
           <p:nvPr/>
         </p:nvSpPr>
@@ -6390,7 +6442,7 @@
       </p:sp>
       <p:sp>
         <p:nvSpPr>
-          <p:cNvPr id="80" name="Oval 79"/>
+          <p:cNvPr id="81" name="Oval 80"/>
           <p:cNvSpPr/>
           <p:nvPr/>
         </p:nvSpPr>
@@ -6434,7 +6486,7 @@
       </p:sp>
       <p:sp>
         <p:nvSpPr>
-          <p:cNvPr id="81" name="Oval 80"/>
+          <p:cNvPr id="82" name="Oval 81"/>
           <p:cNvSpPr/>
           <p:nvPr/>
         </p:nvSpPr>
@@ -6478,7 +6530,7 @@
       </p:sp>
       <p:sp>
         <p:nvSpPr>
-          <p:cNvPr id="82" name="TextBox 81"/>
+          <p:cNvPr id="83" name="TextBox 82"/>
           <p:cNvSpPr txBox="1"/>
           <p:nvPr/>
         </p:nvSpPr>
@@ -6523,7 +6575,7 @@
       </p:sp>
       <p:sp>
         <p:nvSpPr>
-          <p:cNvPr id="83" name="Oval 82"/>
+          <p:cNvPr id="84" name="Oval 83"/>
           <p:cNvSpPr/>
           <p:nvPr/>
         </p:nvSpPr>
@@ -6569,7 +6621,7 @@
       </p:sp>
       <p:sp>
         <p:nvSpPr>
-          <p:cNvPr id="84" name="Oval 83"/>
+          <p:cNvPr id="85" name="Oval 84"/>
           <p:cNvSpPr/>
           <p:nvPr/>
         </p:nvSpPr>
@@ -6613,7 +6665,7 @@
       </p:sp>
       <p:sp>
         <p:nvSpPr>
-          <p:cNvPr id="85" name="Oval 84"/>
+          <p:cNvPr id="86" name="Oval 85"/>
           <p:cNvSpPr/>
           <p:nvPr/>
         </p:nvSpPr>
@@ -6657,7 +6709,7 @@
       </p:sp>
       <p:sp>
         <p:nvSpPr>
-          <p:cNvPr id="86" name="TextBox 85"/>
+          <p:cNvPr id="87" name="TextBox 86"/>
           <p:cNvSpPr txBox="1"/>
           <p:nvPr/>
         </p:nvSpPr>

</xml_diff>

<commit_message>
deck: update OSG-Smart-Guide.pptx (python-pptx build)
Executive-summary one-pager (5 sections + headline metrics), enhanced project charter
with real timeline (CMS upload Nov 2025 to launch Apr 2026), brand-red palette,
frontliner framing, plain business language.

Co-Authored-By: Claude Opus 4.8 (1M context) <noreply@anthropic.com>
</commit_message>
<xml_diff>
--- a/OSG-Smart-Guide.pptx
+++ b/OSG-Smart-Guide.pptx
@@ -15773,7 +15773,7 @@
                 </a:solidFill>
                 <a:latin typeface="Calibri"/>
               </a:rPr>
-              <a:t>A secure AI assistant already saves frontliners time and prevents errors today, and it is low cost and low risk to scale bank-wide</a:t>
+              <a:t>A lean, secure AI single source of truth turns slow, scattered lookups into instant, cited answers, with a fast payback and launch by April 2026</a:t>
             </a:r>
           </a:p>
         </p:txBody>
@@ -16002,20 +16002,20 @@
       </p:sp>
       <p:sp>
         <p:nvSpPr>
-          <p:cNvPr id="10" name="Rectangle 9"/>
+          <p:cNvPr id="10" name="Rounded Rectangle 9"/>
           <p:cNvSpPr/>
           <p:nvPr/>
         </p:nvSpPr>
         <p:spPr>
           <a:xfrm>
-            <a:off x="685800" y="1737360"/>
-            <a:ext cx="10820095" cy="749808"/>
-          </a:xfrm>
-          <a:prstGeom prst="rect">
+            <a:off x="685800" y="1892808"/>
+            <a:ext cx="493776" cy="493776"/>
+          </a:xfrm>
+          <a:prstGeom prst="roundRect">
             <a:avLst/>
           </a:prstGeom>
           <a:solidFill>
-            <a:srgbClr val="F4F1F2"/>
+            <a:srgbClr val="4E6B84"/>
           </a:solidFill>
           <a:ln>
             <a:noFill/>
@@ -16046,16 +16046,365 @@
       </p:sp>
       <p:sp>
         <p:nvSpPr>
-          <p:cNvPr id="11" name="Rectangle 10"/>
+          <p:cNvPr id="11" name="TextBox 10"/>
+          <p:cNvSpPr txBox="1"/>
+          <p:nvPr/>
+        </p:nvSpPr>
+        <p:spPr>
+          <a:xfrm>
+            <a:off x="685800" y="1892808"/>
+            <a:ext cx="493776" cy="493776"/>
+          </a:xfrm>
+          <a:prstGeom prst="rect">
+            <a:avLst/>
+          </a:prstGeom>
+          <a:noFill/>
+        </p:spPr>
+        <p:txBody>
+          <a:bodyPr wrap="square" anchor="ctr" lIns="0" rIns="0" tIns="0" bIns="0">
+            <a:spAutoFit/>
+          </a:bodyPr>
+          <a:lstStyle/>
+          <a:p>
+            <a:pPr algn="ctr">
+              <a:lnSpc>
+                <a:spcPct val="106000"/>
+              </a:lnSpc>
+              <a:spcBef>
+                <a:spcPts val="0"/>
+              </a:spcBef>
+              <a:spcAft>
+                <a:spcPts val="0"/>
+              </a:spcAft>
+            </a:pPr>
+            <a:r>
+              <a:rPr sz="1600" b="1" i="0">
+                <a:solidFill>
+                  <a:srgbClr val="FFFFFF"/>
+                </a:solidFill>
+                <a:latin typeface="Calibri"/>
+              </a:rPr>
+              <a:t>01</a:t>
+            </a:r>
+          </a:p>
+        </p:txBody>
+      </p:sp>
+      <p:sp>
+        <p:nvSpPr>
+          <p:cNvPr id="12" name="TextBox 11"/>
+          <p:cNvSpPr txBox="1"/>
+          <p:nvPr/>
+        </p:nvSpPr>
+        <p:spPr>
+          <a:xfrm>
+            <a:off x="1325880" y="1746504"/>
+            <a:ext cx="8074152" cy="256032"/>
+          </a:xfrm>
+          <a:prstGeom prst="rect">
+            <a:avLst/>
+          </a:prstGeom>
+          <a:noFill/>
+        </p:spPr>
+        <p:txBody>
+          <a:bodyPr wrap="square" anchor="t" lIns="0" rIns="0" tIns="0" bIns="0">
+            <a:spAutoFit/>
+          </a:bodyPr>
+          <a:lstStyle/>
+          <a:p>
+            <a:pPr algn="l">
+              <a:lnSpc>
+                <a:spcPct val="106000"/>
+              </a:lnSpc>
+              <a:spcBef>
+                <a:spcPts val="0"/>
+              </a:spcBef>
+              <a:spcAft>
+                <a:spcPts val="0"/>
+              </a:spcAft>
+            </a:pPr>
+            <a:r>
+              <a:rPr sz="1350" b="1" i="0">
+                <a:solidFill>
+                  <a:srgbClr val="24282C"/>
+                </a:solidFill>
+                <a:latin typeface="Calibri"/>
+              </a:rPr>
+              <a:t>Background</a:t>
+            </a:r>
+          </a:p>
+        </p:txBody>
+      </p:sp>
+      <p:sp>
+        <p:nvSpPr>
+          <p:cNvPr id="13" name="TextBox 12"/>
+          <p:cNvSpPr txBox="1"/>
+          <p:nvPr/>
+        </p:nvSpPr>
+        <p:spPr>
+          <a:xfrm>
+            <a:off x="1325880" y="2002536"/>
+            <a:ext cx="8074152" cy="566928"/>
+          </a:xfrm>
+          <a:prstGeom prst="rect">
+            <a:avLst/>
+          </a:prstGeom>
+          <a:noFill/>
+        </p:spPr>
+        <p:txBody>
+          <a:bodyPr wrap="square" anchor="t" lIns="0" rIns="0" tIns="0" bIns="0">
+            <a:spAutoFit/>
+          </a:bodyPr>
+          <a:lstStyle/>
+          <a:p>
+            <a:pPr algn="l">
+              <a:lnSpc>
+                <a:spcPct val="112000"/>
+              </a:lnSpc>
+              <a:spcBef>
+                <a:spcPts val="0"/>
+              </a:spcBef>
+              <a:spcAft>
+                <a:spcPts val="0"/>
+              </a:spcAft>
+            </a:pPr>
+            <a:r>
+              <a:rPr sz="1100" b="1" i="0">
+                <a:solidFill>
+                  <a:srgbClr val="24282C"/>
+                </a:solidFill>
+                <a:latin typeface="Calibri"/>
+              </a:rPr>
+              <a:t>EES 2025:  </a:t>
+            </a:r>
+            <a:r>
+              <a:rPr sz="1100" b="1" i="0">
+                <a:solidFill>
+                  <a:srgbClr val="4E6B84"/>
+                </a:solidFill>
+                <a:latin typeface="Calibri"/>
+              </a:rPr>
+              <a:t>36%</a:t>
+            </a:r>
+            <a:r>
+              <a:rPr sz="1100" b="0" i="0">
+                <a:solidFill>
+                  <a:srgbClr val="4C5359"/>
+                </a:solidFill>
+                <a:latin typeface="Calibri"/>
+              </a:rPr>
+              <a:t> of frontliners (</a:t>
+            </a:r>
+            <a:r>
+              <a:rPr sz="1100" b="1" i="0">
+                <a:solidFill>
+                  <a:srgbClr val="4E6B84"/>
+                </a:solidFill>
+                <a:latin typeface="Calibri"/>
+              </a:rPr>
+              <a:t>1,200+</a:t>
+            </a:r>
+            <a:r>
+              <a:rPr sz="1100" b="0" i="0">
+                <a:solidFill>
+                  <a:srgbClr val="4C5359"/>
+                </a:solidFill>
+                <a:latin typeface="Calibri"/>
+              </a:rPr>
+              <a:t>) cannot easily find current product, promo and procedure information. It is scattered across email, intranet and other channels and mixed with expired documents, with no single source of truth, so frontliners search manually or repeatedly ask Product Owners, cutting productivity at branches and Head Office.</a:t>
+            </a:r>
+          </a:p>
+        </p:txBody>
+      </p:sp>
+      <p:sp>
+        <p:nvSpPr>
+          <p:cNvPr id="14" name="Rectangle 13"/>
           <p:cNvSpPr/>
           <p:nvPr/>
         </p:nvSpPr>
         <p:spPr>
           <a:xfrm>
-            <a:off x="685800" y="1737360"/>
-            <a:ext cx="64008" cy="749808"/>
-          </a:xfrm>
-          <a:prstGeom prst="rect">
+            <a:off x="9454896" y="1828800"/>
+            <a:ext cx="12700" cy="640080"/>
+          </a:xfrm>
+          <a:prstGeom prst="rect">
+            <a:avLst/>
+          </a:prstGeom>
+          <a:solidFill>
+            <a:srgbClr val="E2E3E5"/>
+          </a:solidFill>
+          <a:ln>
+            <a:noFill/>
+          </a:ln>
+          <a:effectLst/>
+        </p:spPr>
+        <p:style>
+          <a:lnRef idx="1">
+            <a:schemeClr val="accent1"/>
+          </a:lnRef>
+          <a:fillRef idx="3">
+            <a:schemeClr val="accent1"/>
+          </a:fillRef>
+          <a:effectRef idx="2">
+            <a:schemeClr val="accent1"/>
+          </a:effectRef>
+          <a:fontRef idx="minor">
+            <a:schemeClr val="lt1"/>
+          </a:fontRef>
+        </p:style>
+        <p:txBody>
+          <a:bodyPr rtlCol="0" anchor="ctr"/>
+          <a:lstStyle/>
+          <a:p>
+            <a:pPr algn="ctr"/>
+          </a:p>
+        </p:txBody>
+      </p:sp>
+      <p:sp>
+        <p:nvSpPr>
+          <p:cNvPr id="15" name="TextBox 14"/>
+          <p:cNvSpPr txBox="1"/>
+          <p:nvPr/>
+        </p:nvSpPr>
+        <p:spPr>
+          <a:xfrm>
+            <a:off x="9582912" y="1901952"/>
+            <a:ext cx="2105863" cy="384048"/>
+          </a:xfrm>
+          <a:prstGeom prst="rect">
+            <a:avLst/>
+          </a:prstGeom>
+          <a:noFill/>
+        </p:spPr>
+        <p:txBody>
+          <a:bodyPr wrap="square" anchor="t" lIns="0" rIns="0" tIns="0" bIns="0">
+            <a:spAutoFit/>
+          </a:bodyPr>
+          <a:lstStyle/>
+          <a:p>
+            <a:pPr algn="ctr">
+              <a:lnSpc>
+                <a:spcPct val="106000"/>
+              </a:lnSpc>
+              <a:spcBef>
+                <a:spcPts val="0"/>
+              </a:spcBef>
+              <a:spcAft>
+                <a:spcPts val="0"/>
+              </a:spcAft>
+            </a:pPr>
+            <a:r>
+              <a:rPr sz="1900" b="1" i="0">
+                <a:solidFill>
+                  <a:srgbClr val="4E6B84"/>
+                </a:solidFill>
+                <a:latin typeface="Calibri"/>
+              </a:rPr>
+              <a:t>36%</a:t>
+            </a:r>
+          </a:p>
+        </p:txBody>
+      </p:sp>
+      <p:sp>
+        <p:nvSpPr>
+          <p:cNvPr id="16" name="TextBox 15"/>
+          <p:cNvSpPr txBox="1"/>
+          <p:nvPr/>
+        </p:nvSpPr>
+        <p:spPr>
+          <a:xfrm>
+            <a:off x="9582912" y="2286000"/>
+            <a:ext cx="2105863" cy="237744"/>
+          </a:xfrm>
+          <a:prstGeom prst="rect">
+            <a:avLst/>
+          </a:prstGeom>
+          <a:noFill/>
+        </p:spPr>
+        <p:txBody>
+          <a:bodyPr wrap="square" anchor="t" lIns="0" rIns="0" tIns="0" bIns="0">
+            <a:spAutoFit/>
+          </a:bodyPr>
+          <a:lstStyle/>
+          <a:p>
+            <a:pPr algn="ctr">
+              <a:lnSpc>
+                <a:spcPct val="106000"/>
+              </a:lnSpc>
+              <a:spcBef>
+                <a:spcPts val="0"/>
+              </a:spcBef>
+              <a:spcAft>
+                <a:spcPts val="0"/>
+              </a:spcAft>
+            </a:pPr>
+            <a:r>
+              <a:rPr sz="900" b="0" i="0">
+                <a:solidFill>
+                  <a:srgbClr val="6A7177"/>
+                </a:solidFill>
+                <a:latin typeface="Calibri"/>
+              </a:rPr>
+              <a:t>frontliners affected</a:t>
+            </a:r>
+          </a:p>
+        </p:txBody>
+      </p:sp>
+      <p:sp>
+        <p:nvSpPr>
+          <p:cNvPr id="17" name="Rectangle 16"/>
+          <p:cNvSpPr/>
+          <p:nvPr/>
+        </p:nvSpPr>
+        <p:spPr>
+          <a:xfrm>
+            <a:off x="685800" y="2596896"/>
+            <a:ext cx="10820095" cy="10160"/>
+          </a:xfrm>
+          <a:prstGeom prst="rect">
+            <a:avLst/>
+          </a:prstGeom>
+          <a:solidFill>
+            <a:srgbClr val="E2E3E5"/>
+          </a:solidFill>
+          <a:ln>
+            <a:noFill/>
+          </a:ln>
+          <a:effectLst/>
+        </p:spPr>
+        <p:style>
+          <a:lnRef idx="1">
+            <a:schemeClr val="accent1"/>
+          </a:lnRef>
+          <a:fillRef idx="3">
+            <a:schemeClr val="accent1"/>
+          </a:fillRef>
+          <a:effectRef idx="2">
+            <a:schemeClr val="accent1"/>
+          </a:effectRef>
+          <a:fontRef idx="minor">
+            <a:schemeClr val="lt1"/>
+          </a:fontRef>
+        </p:style>
+        <p:txBody>
+          <a:bodyPr rtlCol="0" anchor="ctr"/>
+          <a:lstStyle/>
+          <a:p>
+            <a:pPr algn="ctr"/>
+          </a:p>
+        </p:txBody>
+      </p:sp>
+      <p:sp>
+        <p:nvSpPr>
+          <p:cNvPr id="18" name="Rounded Rectangle 17"/>
+          <p:cNvSpPr/>
+          <p:nvPr/>
+        </p:nvSpPr>
+        <p:spPr>
+          <a:xfrm>
+            <a:off x="685800" y="2807208"/>
+            <a:ext cx="493776" cy="493776"/>
+          </a:xfrm>
+          <a:prstGeom prst="roundRect">
             <a:avLst/>
           </a:prstGeom>
           <a:solidFill>
@@ -16090,14 +16439,14 @@
       </p:sp>
       <p:sp>
         <p:nvSpPr>
-          <p:cNvPr id="12" name="TextBox 11"/>
+          <p:cNvPr id="19" name="TextBox 18"/>
           <p:cNvSpPr txBox="1"/>
           <p:nvPr/>
         </p:nvSpPr>
         <p:spPr>
           <a:xfrm>
-            <a:off x="941832" y="1737360"/>
-            <a:ext cx="10362895" cy="749808"/>
+            <a:off x="685800" y="2807208"/>
+            <a:ext cx="493776" cy="493776"/>
           </a:xfrm>
           <a:prstGeom prst="rect">
             <a:avLst/>
@@ -16110,50 +16459,210 @@
           </a:bodyPr>
           <a:lstStyle/>
           <a:p>
+            <a:pPr algn="ctr">
+              <a:lnSpc>
+                <a:spcPct val="106000"/>
+              </a:lnSpc>
+              <a:spcBef>
+                <a:spcPts val="0"/>
+              </a:spcBef>
+              <a:spcAft>
+                <a:spcPts val="0"/>
+              </a:spcAft>
+            </a:pPr>
+            <a:r>
+              <a:rPr sz="1600" b="1" i="0">
+                <a:solidFill>
+                  <a:srgbClr val="FFFFFF"/>
+                </a:solidFill>
+                <a:latin typeface="Calibri"/>
+              </a:rPr>
+              <a:t>02</a:t>
+            </a:r>
+          </a:p>
+        </p:txBody>
+      </p:sp>
+      <p:sp>
+        <p:nvSpPr>
+          <p:cNvPr id="20" name="TextBox 19"/>
+          <p:cNvSpPr txBox="1"/>
+          <p:nvPr/>
+        </p:nvSpPr>
+        <p:spPr>
+          <a:xfrm>
+            <a:off x="1325880" y="2660903"/>
+            <a:ext cx="8074152" cy="256032"/>
+          </a:xfrm>
+          <a:prstGeom prst="rect">
+            <a:avLst/>
+          </a:prstGeom>
+          <a:noFill/>
+        </p:spPr>
+        <p:txBody>
+          <a:bodyPr wrap="square" anchor="t" lIns="0" rIns="0" tIns="0" bIns="0">
+            <a:spAutoFit/>
+          </a:bodyPr>
+          <a:lstStyle/>
+          <a:p>
             <a:pPr algn="l">
               <a:lnSpc>
-                <a:spcPct val="108000"/>
-              </a:lnSpc>
-              <a:spcBef>
-                <a:spcPts val="0"/>
-              </a:spcBef>
-              <a:spcAft>
-                <a:spcPts val="0"/>
-              </a:spcAft>
-            </a:pPr>
-            <a:r>
-              <a:rPr sz="1400" b="1" i="0">
+                <a:spcPct val="106000"/>
+              </a:lnSpc>
+              <a:spcBef>
+                <a:spcPts val="0"/>
+              </a:spcBef>
+              <a:spcAft>
+                <a:spcPts val="0"/>
+              </a:spcAft>
+            </a:pPr>
+            <a:r>
+              <a:rPr sz="1350" b="1" i="0">
                 <a:solidFill>
                   <a:srgbClr val="24282C"/>
                 </a:solidFill>
                 <a:latin typeface="Calibri"/>
               </a:rPr>
-              <a:t>Frontliners ask in plain language and get a source-cited answer in seconds, taken only from the bank's own approved content. Speed no longer trades off against accuracy or compliance.</a:t>
-            </a:r>
-          </a:p>
-        </p:txBody>
-      </p:sp>
-      <p:sp>
-        <p:nvSpPr>
-          <p:cNvPr id="13" name="Rectangle 12"/>
+              <a:t>Problem statement</a:t>
+            </a:r>
+          </a:p>
+        </p:txBody>
+      </p:sp>
+      <p:sp>
+        <p:nvSpPr>
+          <p:cNvPr id="21" name="TextBox 20"/>
+          <p:cNvSpPr txBox="1"/>
+          <p:nvPr/>
+        </p:nvSpPr>
+        <p:spPr>
+          <a:xfrm>
+            <a:off x="1325880" y="2916936"/>
+            <a:ext cx="8074152" cy="566928"/>
+          </a:xfrm>
+          <a:prstGeom prst="rect">
+            <a:avLst/>
+          </a:prstGeom>
+          <a:noFill/>
+        </p:spPr>
+        <p:txBody>
+          <a:bodyPr wrap="square" anchor="t" lIns="0" rIns="0" tIns="0" bIns="0">
+            <a:spAutoFit/>
+          </a:bodyPr>
+          <a:lstStyle/>
+          <a:p>
+            <a:pPr algn="l">
+              <a:lnSpc>
+                <a:spcPct val="112000"/>
+              </a:lnSpc>
+              <a:spcBef>
+                <a:spcPts val="0"/>
+              </a:spcBef>
+              <a:spcAft>
+                <a:spcPts val="0"/>
+              </a:spcAft>
+            </a:pPr>
+            <a:r>
+              <a:rPr sz="1100" b="1" i="0">
+                <a:solidFill>
+                  <a:srgbClr val="24282C"/>
+                </a:solidFill>
+                <a:latin typeface="Calibri"/>
+              </a:rPr>
+              <a:t>Three pain points compound on every interaction: </a:t>
+            </a:r>
+            <a:r>
+              <a:rPr sz="1100" b="0" i="0">
+                <a:solidFill>
+                  <a:srgbClr val="4C5359"/>
+                </a:solidFill>
+                <a:latin typeface="Calibri"/>
+              </a:rPr>
+              <a:t>productivity</a:t>
+            </a:r>
+            <a:r>
+              <a:rPr sz="1100" b="0" i="0">
+                <a:solidFill>
+                  <a:srgbClr val="4C5359"/>
+                </a:solidFill>
+                <a:latin typeface="Calibri"/>
+              </a:rPr>
+              <a:t> (answers can take until next-day / H+1 from manual search and Head-Office bottlenecks); </a:t>
+            </a:r>
+            <a:r>
+              <a:rPr sz="1100" b="0" i="0">
+                <a:solidFill>
+                  <a:srgbClr val="4C5359"/>
+                </a:solidFill>
+                <a:latin typeface="Calibri"/>
+              </a:rPr>
+              <a:t>accuracy</a:t>
+            </a:r>
+            <a:r>
+              <a:rPr sz="1100" b="0" i="0">
+                <a:solidFill>
+                  <a:srgbClr val="4C5359"/>
+                </a:solidFill>
+                <a:latin typeface="Calibri"/>
+              </a:rPr>
+              <a:t> (inconsistent, biased information with no single source of truth); and </a:t>
+            </a:r>
+            <a:r>
+              <a:rPr sz="1100" b="0" i="0">
+                <a:solidFill>
+                  <a:srgbClr val="4C5359"/>
+                </a:solidFill>
+                <a:latin typeface="Calibri"/>
+              </a:rPr>
+              <a:t>customer experience</a:t>
+            </a:r>
+            <a:r>
+              <a:rPr sz="1100" b="0" i="0">
+                <a:solidFill>
+                  <a:srgbClr val="4C5359"/>
+                </a:solidFill>
+                <a:latin typeface="Calibri"/>
+              </a:rPr>
+              <a:t> (NPS H1 2025: </a:t>
+            </a:r>
+            <a:r>
+              <a:rPr sz="1100" b="1" i="0">
+                <a:solidFill>
+                  <a:srgbClr val="E4002B"/>
+                </a:solidFill>
+                <a:latin typeface="Calibri"/>
+              </a:rPr>
+              <a:t>38%</a:t>
+            </a:r>
+            <a:r>
+              <a:rPr sz="1100" b="0" i="0">
+                <a:solidFill>
+                  <a:srgbClr val="4C5359"/>
+                </a:solidFill>
+                <a:latin typeface="Calibri"/>
+              </a:rPr>
+              <a:t> of customers complained about frontliner answer quality).</a:t>
+            </a:r>
+          </a:p>
+        </p:txBody>
+      </p:sp>
+      <p:sp>
+        <p:nvSpPr>
+          <p:cNvPr id="22" name="Rectangle 21"/>
           <p:cNvSpPr/>
           <p:nvPr/>
         </p:nvSpPr>
         <p:spPr>
           <a:xfrm>
-            <a:off x="685800" y="2670048"/>
-            <a:ext cx="3423818" cy="1901952"/>
+            <a:off x="9454896" y="2743200"/>
+            <a:ext cx="12700" cy="640080"/>
           </a:xfrm>
           <a:prstGeom prst="rect">
             <a:avLst/>
           </a:prstGeom>
           <a:solidFill>
-            <a:srgbClr val="F7F7F8"/>
+            <a:srgbClr val="E2E3E5"/>
           </a:solidFill>
-          <a:ln w="12700">
-            <a:solidFill>
-              <a:srgbClr val="E2E3E5"/>
-            </a:solidFill>
+          <a:ln>
+            <a:noFill/>
           </a:ln>
           <a:effectLst/>
         </p:spPr>
@@ -16181,16 +16690,927 @@
       </p:sp>
       <p:sp>
         <p:nvSpPr>
-          <p:cNvPr id="14" name="Rectangle 13"/>
+          <p:cNvPr id="23" name="TextBox 22"/>
+          <p:cNvSpPr txBox="1"/>
+          <p:nvPr/>
+        </p:nvSpPr>
+        <p:spPr>
+          <a:xfrm>
+            <a:off x="9582912" y="2816352"/>
+            <a:ext cx="2105863" cy="384048"/>
+          </a:xfrm>
+          <a:prstGeom prst="rect">
+            <a:avLst/>
+          </a:prstGeom>
+          <a:noFill/>
+        </p:spPr>
+        <p:txBody>
+          <a:bodyPr wrap="square" anchor="t" lIns="0" rIns="0" tIns="0" bIns="0">
+            <a:spAutoFit/>
+          </a:bodyPr>
+          <a:lstStyle/>
+          <a:p>
+            <a:pPr algn="ctr">
+              <a:lnSpc>
+                <a:spcPct val="106000"/>
+              </a:lnSpc>
+              <a:spcBef>
+                <a:spcPts val="0"/>
+              </a:spcBef>
+              <a:spcAft>
+                <a:spcPts val="0"/>
+              </a:spcAft>
+            </a:pPr>
+            <a:r>
+              <a:rPr sz="1900" b="1" i="0">
+                <a:solidFill>
+                  <a:srgbClr val="E4002B"/>
+                </a:solidFill>
+                <a:latin typeface="Calibri"/>
+              </a:rPr>
+              <a:t>38%</a:t>
+            </a:r>
+          </a:p>
+        </p:txBody>
+      </p:sp>
+      <p:sp>
+        <p:nvSpPr>
+          <p:cNvPr id="24" name="TextBox 23"/>
+          <p:cNvSpPr txBox="1"/>
+          <p:nvPr/>
+        </p:nvSpPr>
+        <p:spPr>
+          <a:xfrm>
+            <a:off x="9582912" y="3200400"/>
+            <a:ext cx="2105863" cy="237744"/>
+          </a:xfrm>
+          <a:prstGeom prst="rect">
+            <a:avLst/>
+          </a:prstGeom>
+          <a:noFill/>
+        </p:spPr>
+        <p:txBody>
+          <a:bodyPr wrap="square" anchor="t" lIns="0" rIns="0" tIns="0" bIns="0">
+            <a:spAutoFit/>
+          </a:bodyPr>
+          <a:lstStyle/>
+          <a:p>
+            <a:pPr algn="ctr">
+              <a:lnSpc>
+                <a:spcPct val="106000"/>
+              </a:lnSpc>
+              <a:spcBef>
+                <a:spcPts val="0"/>
+              </a:spcBef>
+              <a:spcAft>
+                <a:spcPts val="0"/>
+              </a:spcAft>
+            </a:pPr>
+            <a:r>
+              <a:rPr sz="900" b="0" i="0">
+                <a:solidFill>
+                  <a:srgbClr val="6A7177"/>
+                </a:solidFill>
+                <a:latin typeface="Calibri"/>
+              </a:rPr>
+              <a:t>NPS complaints</a:t>
+            </a:r>
+          </a:p>
+        </p:txBody>
+      </p:sp>
+      <p:sp>
+        <p:nvSpPr>
+          <p:cNvPr id="25" name="Rectangle 24"/>
           <p:cNvSpPr/>
           <p:nvPr/>
         </p:nvSpPr>
         <p:spPr>
           <a:xfrm>
-            <a:off x="685800" y="2670048"/>
-            <a:ext cx="3423818" cy="77724"/>
-          </a:xfrm>
-          <a:prstGeom prst="rect">
+            <a:off x="685800" y="3511296"/>
+            <a:ext cx="10820095" cy="10160"/>
+          </a:xfrm>
+          <a:prstGeom prst="rect">
+            <a:avLst/>
+          </a:prstGeom>
+          <a:solidFill>
+            <a:srgbClr val="E2E3E5"/>
+          </a:solidFill>
+          <a:ln>
+            <a:noFill/>
+          </a:ln>
+          <a:effectLst/>
+        </p:spPr>
+        <p:style>
+          <a:lnRef idx="1">
+            <a:schemeClr val="accent1"/>
+          </a:lnRef>
+          <a:fillRef idx="3">
+            <a:schemeClr val="accent1"/>
+          </a:fillRef>
+          <a:effectRef idx="2">
+            <a:schemeClr val="accent1"/>
+          </a:effectRef>
+          <a:fontRef idx="minor">
+            <a:schemeClr val="lt1"/>
+          </a:fontRef>
+        </p:style>
+        <p:txBody>
+          <a:bodyPr rtlCol="0" anchor="ctr"/>
+          <a:lstStyle/>
+          <a:p>
+            <a:pPr algn="ctr"/>
+          </a:p>
+        </p:txBody>
+      </p:sp>
+      <p:sp>
+        <p:nvSpPr>
+          <p:cNvPr id="26" name="Rounded Rectangle 25"/>
+          <p:cNvSpPr/>
+          <p:nvPr/>
+        </p:nvSpPr>
+        <p:spPr>
+          <a:xfrm>
+            <a:off x="685800" y="3721608"/>
+            <a:ext cx="493776" cy="493776"/>
+          </a:xfrm>
+          <a:prstGeom prst="roundRect">
+            <a:avLst/>
+          </a:prstGeom>
+          <a:solidFill>
+            <a:srgbClr val="395268"/>
+          </a:solidFill>
+          <a:ln>
+            <a:noFill/>
+          </a:ln>
+          <a:effectLst/>
+        </p:spPr>
+        <p:style>
+          <a:lnRef idx="1">
+            <a:schemeClr val="accent1"/>
+          </a:lnRef>
+          <a:fillRef idx="3">
+            <a:schemeClr val="accent1"/>
+          </a:fillRef>
+          <a:effectRef idx="2">
+            <a:schemeClr val="accent1"/>
+          </a:effectRef>
+          <a:fontRef idx="minor">
+            <a:schemeClr val="lt1"/>
+          </a:fontRef>
+        </p:style>
+        <p:txBody>
+          <a:bodyPr rtlCol="0" anchor="ctr"/>
+          <a:lstStyle/>
+          <a:p>
+            <a:pPr algn="ctr"/>
+          </a:p>
+        </p:txBody>
+      </p:sp>
+      <p:sp>
+        <p:nvSpPr>
+          <p:cNvPr id="27" name="TextBox 26"/>
+          <p:cNvSpPr txBox="1"/>
+          <p:nvPr/>
+        </p:nvSpPr>
+        <p:spPr>
+          <a:xfrm>
+            <a:off x="685800" y="3721608"/>
+            <a:ext cx="493776" cy="493776"/>
+          </a:xfrm>
+          <a:prstGeom prst="rect">
+            <a:avLst/>
+          </a:prstGeom>
+          <a:noFill/>
+        </p:spPr>
+        <p:txBody>
+          <a:bodyPr wrap="square" anchor="ctr" lIns="0" rIns="0" tIns="0" bIns="0">
+            <a:spAutoFit/>
+          </a:bodyPr>
+          <a:lstStyle/>
+          <a:p>
+            <a:pPr algn="ctr">
+              <a:lnSpc>
+                <a:spcPct val="106000"/>
+              </a:lnSpc>
+              <a:spcBef>
+                <a:spcPts val="0"/>
+              </a:spcBef>
+              <a:spcAft>
+                <a:spcPts val="0"/>
+              </a:spcAft>
+            </a:pPr>
+            <a:r>
+              <a:rPr sz="1600" b="1" i="0">
+                <a:solidFill>
+                  <a:srgbClr val="FFFFFF"/>
+                </a:solidFill>
+                <a:latin typeface="Calibri"/>
+              </a:rPr>
+              <a:t>03</a:t>
+            </a:r>
+          </a:p>
+        </p:txBody>
+      </p:sp>
+      <p:sp>
+        <p:nvSpPr>
+          <p:cNvPr id="28" name="TextBox 27"/>
+          <p:cNvSpPr txBox="1"/>
+          <p:nvPr/>
+        </p:nvSpPr>
+        <p:spPr>
+          <a:xfrm>
+            <a:off x="1325880" y="3575303"/>
+            <a:ext cx="8074152" cy="256032"/>
+          </a:xfrm>
+          <a:prstGeom prst="rect">
+            <a:avLst/>
+          </a:prstGeom>
+          <a:noFill/>
+        </p:spPr>
+        <p:txBody>
+          <a:bodyPr wrap="square" anchor="t" lIns="0" rIns="0" tIns="0" bIns="0">
+            <a:spAutoFit/>
+          </a:bodyPr>
+          <a:lstStyle/>
+          <a:p>
+            <a:pPr algn="l">
+              <a:lnSpc>
+                <a:spcPct val="106000"/>
+              </a:lnSpc>
+              <a:spcBef>
+                <a:spcPts val="0"/>
+              </a:spcBef>
+              <a:spcAft>
+                <a:spcPts val="0"/>
+              </a:spcAft>
+            </a:pPr>
+            <a:r>
+              <a:rPr sz="1350" b="1" i="0">
+                <a:solidFill>
+                  <a:srgbClr val="24282C"/>
+                </a:solidFill>
+                <a:latin typeface="Calibri"/>
+              </a:rPr>
+              <a:t>Project objective</a:t>
+            </a:r>
+          </a:p>
+        </p:txBody>
+      </p:sp>
+      <p:sp>
+        <p:nvSpPr>
+          <p:cNvPr id="29" name="TextBox 28"/>
+          <p:cNvSpPr txBox="1"/>
+          <p:nvPr/>
+        </p:nvSpPr>
+        <p:spPr>
+          <a:xfrm>
+            <a:off x="1325880" y="3831335"/>
+            <a:ext cx="8074152" cy="566928"/>
+          </a:xfrm>
+          <a:prstGeom prst="rect">
+            <a:avLst/>
+          </a:prstGeom>
+          <a:noFill/>
+        </p:spPr>
+        <p:txBody>
+          <a:bodyPr wrap="square" anchor="t" lIns="0" rIns="0" tIns="0" bIns="0">
+            <a:spAutoFit/>
+          </a:bodyPr>
+          <a:lstStyle/>
+          <a:p>
+            <a:pPr algn="l">
+              <a:lnSpc>
+                <a:spcPct val="112000"/>
+              </a:lnSpc>
+              <a:spcBef>
+                <a:spcPts val="0"/>
+              </a:spcBef>
+              <a:spcAft>
+                <a:spcPts val="0"/>
+              </a:spcAft>
+            </a:pPr>
+            <a:r>
+              <a:rPr sz="1100" b="0" i="0">
+                <a:solidFill>
+                  <a:srgbClr val="4C5359"/>
+                </a:solidFill>
+                <a:latin typeface="Calibri"/>
+              </a:rPr>
+              <a:t>Deliver one secure AI single source of truth so frontliners answer product, promotion and service questions instantly, accurately and bilingually (ID/EN). Key results: cut lookups from &gt;30 minutes / next-day to </a:t>
+            </a:r>
+            <a:r>
+              <a:rPr sz="1100" b="1" i="0">
+                <a:solidFill>
+                  <a:srgbClr val="395268"/>
+                </a:solidFill>
+                <a:latin typeface="Calibri"/>
+              </a:rPr>
+              <a:t>≤ 5 seconds</a:t>
+            </a:r>
+            <a:r>
+              <a:rPr sz="1100" b="0" i="0">
+                <a:solidFill>
+                  <a:srgbClr val="4C5359"/>
+                </a:solidFill>
+                <a:latin typeface="Calibri"/>
+              </a:rPr>
+              <a:t>; raise answer accuracy to </a:t>
+            </a:r>
+            <a:r>
+              <a:rPr sz="1100" b="1" i="0">
+                <a:solidFill>
+                  <a:srgbClr val="395268"/>
+                </a:solidFill>
+                <a:latin typeface="Calibri"/>
+              </a:rPr>
+              <a:t>95%</a:t>
+            </a:r>
+            <a:r>
+              <a:rPr sz="1100" b="0" i="0">
+                <a:solidFill>
+                  <a:srgbClr val="4C5359"/>
+                </a:solidFill>
+                <a:latin typeface="Calibri"/>
+              </a:rPr>
+              <a:t>; cut NPS complaints to </a:t>
+            </a:r>
+            <a:r>
+              <a:rPr sz="1100" b="1" i="0">
+                <a:solidFill>
+                  <a:srgbClr val="395268"/>
+                </a:solidFill>
+                <a:latin typeface="Calibri"/>
+              </a:rPr>
+              <a:t>below 10%</a:t>
+            </a:r>
+            <a:r>
+              <a:rPr sz="1100" b="0" i="0">
+                <a:solidFill>
+                  <a:srgbClr val="4C5359"/>
+                </a:solidFill>
+                <a:latin typeface="Calibri"/>
+              </a:rPr>
+              <a:t>; and reduce reliance on Product Owners.</a:t>
+            </a:r>
+          </a:p>
+        </p:txBody>
+      </p:sp>
+      <p:sp>
+        <p:nvSpPr>
+          <p:cNvPr id="30" name="Rectangle 29"/>
+          <p:cNvSpPr/>
+          <p:nvPr/>
+        </p:nvSpPr>
+        <p:spPr>
+          <a:xfrm>
+            <a:off x="9454896" y="3657600"/>
+            <a:ext cx="12700" cy="640080"/>
+          </a:xfrm>
+          <a:prstGeom prst="rect">
+            <a:avLst/>
+          </a:prstGeom>
+          <a:solidFill>
+            <a:srgbClr val="E2E3E5"/>
+          </a:solidFill>
+          <a:ln>
+            <a:noFill/>
+          </a:ln>
+          <a:effectLst/>
+        </p:spPr>
+        <p:style>
+          <a:lnRef idx="1">
+            <a:schemeClr val="accent1"/>
+          </a:lnRef>
+          <a:fillRef idx="3">
+            <a:schemeClr val="accent1"/>
+          </a:fillRef>
+          <a:effectRef idx="2">
+            <a:schemeClr val="accent1"/>
+          </a:effectRef>
+          <a:fontRef idx="minor">
+            <a:schemeClr val="lt1"/>
+          </a:fontRef>
+        </p:style>
+        <p:txBody>
+          <a:bodyPr rtlCol="0" anchor="ctr"/>
+          <a:lstStyle/>
+          <a:p>
+            <a:pPr algn="ctr"/>
+          </a:p>
+        </p:txBody>
+      </p:sp>
+      <p:sp>
+        <p:nvSpPr>
+          <p:cNvPr id="31" name="TextBox 30"/>
+          <p:cNvSpPr txBox="1"/>
+          <p:nvPr/>
+        </p:nvSpPr>
+        <p:spPr>
+          <a:xfrm>
+            <a:off x="9582912" y="3730752"/>
+            <a:ext cx="2105863" cy="384048"/>
+          </a:xfrm>
+          <a:prstGeom prst="rect">
+            <a:avLst/>
+          </a:prstGeom>
+          <a:noFill/>
+        </p:spPr>
+        <p:txBody>
+          <a:bodyPr wrap="square" anchor="t" lIns="0" rIns="0" tIns="0" bIns="0">
+            <a:spAutoFit/>
+          </a:bodyPr>
+          <a:lstStyle/>
+          <a:p>
+            <a:pPr algn="ctr">
+              <a:lnSpc>
+                <a:spcPct val="106000"/>
+              </a:lnSpc>
+              <a:spcBef>
+                <a:spcPts val="0"/>
+              </a:spcBef>
+              <a:spcAft>
+                <a:spcPts val="0"/>
+              </a:spcAft>
+            </a:pPr>
+            <a:r>
+              <a:rPr sz="1900" b="1" i="0">
+                <a:solidFill>
+                  <a:srgbClr val="395268"/>
+                </a:solidFill>
+                <a:latin typeface="Calibri"/>
+              </a:rPr>
+              <a:t>≤ 5 sec</a:t>
+            </a:r>
+          </a:p>
+        </p:txBody>
+      </p:sp>
+      <p:sp>
+        <p:nvSpPr>
+          <p:cNvPr id="32" name="TextBox 31"/>
+          <p:cNvSpPr txBox="1"/>
+          <p:nvPr/>
+        </p:nvSpPr>
+        <p:spPr>
+          <a:xfrm>
+            <a:off x="9582912" y="4114800"/>
+            <a:ext cx="2105863" cy="237744"/>
+          </a:xfrm>
+          <a:prstGeom prst="rect">
+            <a:avLst/>
+          </a:prstGeom>
+          <a:noFill/>
+        </p:spPr>
+        <p:txBody>
+          <a:bodyPr wrap="square" anchor="t" lIns="0" rIns="0" tIns="0" bIns="0">
+            <a:spAutoFit/>
+          </a:bodyPr>
+          <a:lstStyle/>
+          <a:p>
+            <a:pPr algn="ctr">
+              <a:lnSpc>
+                <a:spcPct val="106000"/>
+              </a:lnSpc>
+              <a:spcBef>
+                <a:spcPts val="0"/>
+              </a:spcBef>
+              <a:spcAft>
+                <a:spcPts val="0"/>
+              </a:spcAft>
+            </a:pPr>
+            <a:r>
+              <a:rPr sz="900" b="0" i="0">
+                <a:solidFill>
+                  <a:srgbClr val="6A7177"/>
+                </a:solidFill>
+                <a:latin typeface="Calibri"/>
+              </a:rPr>
+              <a:t>target lookup</a:t>
+            </a:r>
+          </a:p>
+        </p:txBody>
+      </p:sp>
+      <p:sp>
+        <p:nvSpPr>
+          <p:cNvPr id="33" name="Rectangle 32"/>
+          <p:cNvSpPr/>
+          <p:nvPr/>
+        </p:nvSpPr>
+        <p:spPr>
+          <a:xfrm>
+            <a:off x="685800" y="4425696"/>
+            <a:ext cx="10820095" cy="10160"/>
+          </a:xfrm>
+          <a:prstGeom prst="rect">
+            <a:avLst/>
+          </a:prstGeom>
+          <a:solidFill>
+            <a:srgbClr val="E2E3E5"/>
+          </a:solidFill>
+          <a:ln>
+            <a:noFill/>
+          </a:ln>
+          <a:effectLst/>
+        </p:spPr>
+        <p:style>
+          <a:lnRef idx="1">
+            <a:schemeClr val="accent1"/>
+          </a:lnRef>
+          <a:fillRef idx="3">
+            <a:schemeClr val="accent1"/>
+          </a:fillRef>
+          <a:effectRef idx="2">
+            <a:schemeClr val="accent1"/>
+          </a:effectRef>
+          <a:fontRef idx="minor">
+            <a:schemeClr val="lt1"/>
+          </a:fontRef>
+        </p:style>
+        <p:txBody>
+          <a:bodyPr rtlCol="0" anchor="ctr"/>
+          <a:lstStyle/>
+          <a:p>
+            <a:pPr algn="ctr"/>
+          </a:p>
+        </p:txBody>
+      </p:sp>
+      <p:sp>
+        <p:nvSpPr>
+          <p:cNvPr id="34" name="Rounded Rectangle 33"/>
+          <p:cNvSpPr/>
+          <p:nvPr/>
+        </p:nvSpPr>
+        <p:spPr>
+          <a:xfrm>
+            <a:off x="685800" y="4636008"/>
+            <a:ext cx="493776" cy="493776"/>
+          </a:xfrm>
+          <a:prstGeom prst="roundRect">
+            <a:avLst/>
+          </a:prstGeom>
+          <a:solidFill>
+            <a:srgbClr val="B0812C"/>
+          </a:solidFill>
+          <a:ln>
+            <a:noFill/>
+          </a:ln>
+          <a:effectLst/>
+        </p:spPr>
+        <p:style>
+          <a:lnRef idx="1">
+            <a:schemeClr val="accent1"/>
+          </a:lnRef>
+          <a:fillRef idx="3">
+            <a:schemeClr val="accent1"/>
+          </a:fillRef>
+          <a:effectRef idx="2">
+            <a:schemeClr val="accent1"/>
+          </a:effectRef>
+          <a:fontRef idx="minor">
+            <a:schemeClr val="lt1"/>
+          </a:fontRef>
+        </p:style>
+        <p:txBody>
+          <a:bodyPr rtlCol="0" anchor="ctr"/>
+          <a:lstStyle/>
+          <a:p>
+            <a:pPr algn="ctr"/>
+          </a:p>
+        </p:txBody>
+      </p:sp>
+      <p:sp>
+        <p:nvSpPr>
+          <p:cNvPr id="35" name="TextBox 34"/>
+          <p:cNvSpPr txBox="1"/>
+          <p:nvPr/>
+        </p:nvSpPr>
+        <p:spPr>
+          <a:xfrm>
+            <a:off x="685800" y="4636008"/>
+            <a:ext cx="493776" cy="493776"/>
+          </a:xfrm>
+          <a:prstGeom prst="rect">
+            <a:avLst/>
+          </a:prstGeom>
+          <a:noFill/>
+        </p:spPr>
+        <p:txBody>
+          <a:bodyPr wrap="square" anchor="ctr" lIns="0" rIns="0" tIns="0" bIns="0">
+            <a:spAutoFit/>
+          </a:bodyPr>
+          <a:lstStyle/>
+          <a:p>
+            <a:pPr algn="ctr">
+              <a:lnSpc>
+                <a:spcPct val="106000"/>
+              </a:lnSpc>
+              <a:spcBef>
+                <a:spcPts val="0"/>
+              </a:spcBef>
+              <a:spcAft>
+                <a:spcPts val="0"/>
+              </a:spcAft>
+            </a:pPr>
+            <a:r>
+              <a:rPr sz="1600" b="1" i="0">
+                <a:solidFill>
+                  <a:srgbClr val="FFFFFF"/>
+                </a:solidFill>
+                <a:latin typeface="Calibri"/>
+              </a:rPr>
+              <a:t>04</a:t>
+            </a:r>
+          </a:p>
+        </p:txBody>
+      </p:sp>
+      <p:sp>
+        <p:nvSpPr>
+          <p:cNvPr id="36" name="TextBox 35"/>
+          <p:cNvSpPr txBox="1"/>
+          <p:nvPr/>
+        </p:nvSpPr>
+        <p:spPr>
+          <a:xfrm>
+            <a:off x="1325880" y="4489704"/>
+            <a:ext cx="8074152" cy="256032"/>
+          </a:xfrm>
+          <a:prstGeom prst="rect">
+            <a:avLst/>
+          </a:prstGeom>
+          <a:noFill/>
+        </p:spPr>
+        <p:txBody>
+          <a:bodyPr wrap="square" anchor="t" lIns="0" rIns="0" tIns="0" bIns="0">
+            <a:spAutoFit/>
+          </a:bodyPr>
+          <a:lstStyle/>
+          <a:p>
+            <a:pPr algn="l">
+              <a:lnSpc>
+                <a:spcPct val="106000"/>
+              </a:lnSpc>
+              <a:spcBef>
+                <a:spcPts val="0"/>
+              </a:spcBef>
+              <a:spcAft>
+                <a:spcPts val="0"/>
+              </a:spcAft>
+            </a:pPr>
+            <a:r>
+              <a:rPr sz="1350" b="1" i="0">
+                <a:solidFill>
+                  <a:srgbClr val="24282C"/>
+                </a:solidFill>
+                <a:latin typeface="Calibri"/>
+              </a:rPr>
+              <a:t>Proposed solution</a:t>
+            </a:r>
+          </a:p>
+        </p:txBody>
+      </p:sp>
+      <p:sp>
+        <p:nvSpPr>
+          <p:cNvPr id="37" name="TextBox 36"/>
+          <p:cNvSpPr txBox="1"/>
+          <p:nvPr/>
+        </p:nvSpPr>
+        <p:spPr>
+          <a:xfrm>
+            <a:off x="1325880" y="4745736"/>
+            <a:ext cx="8074152" cy="566928"/>
+          </a:xfrm>
+          <a:prstGeom prst="rect">
+            <a:avLst/>
+          </a:prstGeom>
+          <a:noFill/>
+        </p:spPr>
+        <p:txBody>
+          <a:bodyPr wrap="square" anchor="t" lIns="0" rIns="0" tIns="0" bIns="0">
+            <a:spAutoFit/>
+          </a:bodyPr>
+          <a:lstStyle/>
+          <a:p>
+            <a:pPr algn="l">
+              <a:lnSpc>
+                <a:spcPct val="112000"/>
+              </a:lnSpc>
+              <a:spcBef>
+                <a:spcPts val="0"/>
+              </a:spcBef>
+              <a:spcAft>
+                <a:spcPts val="0"/>
+              </a:spcAft>
+            </a:pPr>
+            <a:r>
+              <a:rPr sz="1100" b="0" i="0">
+                <a:solidFill>
+                  <a:srgbClr val="4C5359"/>
+                </a:solidFill>
+                <a:latin typeface="Calibri"/>
+              </a:rPr>
+              <a:t>OSG is a secure AI assistant that answers only from the bank's own approved content and shows the source for every answer. Expired offers are flagged; it is bilingual, self-updating and vendor-flexible, and never handles customer secrets such as PINs or passwords. It is </a:t>
+            </a:r>
+            <a:r>
+              <a:rPr sz="1100" b="1" i="0">
+                <a:solidFill>
+                  <a:srgbClr val="B0812C"/>
+                </a:solidFill>
+                <a:latin typeface="Calibri"/>
+              </a:rPr>
+              <a:t>already live with 2,758 documents across 51 categories.</a:t>
+            </a:r>
+          </a:p>
+        </p:txBody>
+      </p:sp>
+      <p:sp>
+        <p:nvSpPr>
+          <p:cNvPr id="38" name="Rectangle 37"/>
+          <p:cNvSpPr/>
+          <p:nvPr/>
+        </p:nvSpPr>
+        <p:spPr>
+          <a:xfrm>
+            <a:off x="9454896" y="4572000"/>
+            <a:ext cx="12700" cy="640080"/>
+          </a:xfrm>
+          <a:prstGeom prst="rect">
+            <a:avLst/>
+          </a:prstGeom>
+          <a:solidFill>
+            <a:srgbClr val="E2E3E5"/>
+          </a:solidFill>
+          <a:ln>
+            <a:noFill/>
+          </a:ln>
+          <a:effectLst/>
+        </p:spPr>
+        <p:style>
+          <a:lnRef idx="1">
+            <a:schemeClr val="accent1"/>
+          </a:lnRef>
+          <a:fillRef idx="3">
+            <a:schemeClr val="accent1"/>
+          </a:fillRef>
+          <a:effectRef idx="2">
+            <a:schemeClr val="accent1"/>
+          </a:effectRef>
+          <a:fontRef idx="minor">
+            <a:schemeClr val="lt1"/>
+          </a:fontRef>
+        </p:style>
+        <p:txBody>
+          <a:bodyPr rtlCol="0" anchor="ctr"/>
+          <a:lstStyle/>
+          <a:p>
+            <a:pPr algn="ctr"/>
+          </a:p>
+        </p:txBody>
+      </p:sp>
+      <p:sp>
+        <p:nvSpPr>
+          <p:cNvPr id="39" name="TextBox 38"/>
+          <p:cNvSpPr txBox="1"/>
+          <p:nvPr/>
+        </p:nvSpPr>
+        <p:spPr>
+          <a:xfrm>
+            <a:off x="9582912" y="4645152"/>
+            <a:ext cx="2105863" cy="384048"/>
+          </a:xfrm>
+          <a:prstGeom prst="rect">
+            <a:avLst/>
+          </a:prstGeom>
+          <a:noFill/>
+        </p:spPr>
+        <p:txBody>
+          <a:bodyPr wrap="square" anchor="t" lIns="0" rIns="0" tIns="0" bIns="0">
+            <a:spAutoFit/>
+          </a:bodyPr>
+          <a:lstStyle/>
+          <a:p>
+            <a:pPr algn="ctr">
+              <a:lnSpc>
+                <a:spcPct val="106000"/>
+              </a:lnSpc>
+              <a:spcBef>
+                <a:spcPts val="0"/>
+              </a:spcBef>
+              <a:spcAft>
+                <a:spcPts val="0"/>
+              </a:spcAft>
+            </a:pPr>
+            <a:r>
+              <a:rPr sz="1900" b="1" i="0">
+                <a:solidFill>
+                  <a:srgbClr val="B0812C"/>
+                </a:solidFill>
+                <a:latin typeface="Calibri"/>
+              </a:rPr>
+              <a:t>2,758</a:t>
+            </a:r>
+          </a:p>
+        </p:txBody>
+      </p:sp>
+      <p:sp>
+        <p:nvSpPr>
+          <p:cNvPr id="40" name="TextBox 39"/>
+          <p:cNvSpPr txBox="1"/>
+          <p:nvPr/>
+        </p:nvSpPr>
+        <p:spPr>
+          <a:xfrm>
+            <a:off x="9582912" y="5029200"/>
+            <a:ext cx="2105863" cy="237744"/>
+          </a:xfrm>
+          <a:prstGeom prst="rect">
+            <a:avLst/>
+          </a:prstGeom>
+          <a:noFill/>
+        </p:spPr>
+        <p:txBody>
+          <a:bodyPr wrap="square" anchor="t" lIns="0" rIns="0" tIns="0" bIns="0">
+            <a:spAutoFit/>
+          </a:bodyPr>
+          <a:lstStyle/>
+          <a:p>
+            <a:pPr algn="ctr">
+              <a:lnSpc>
+                <a:spcPct val="106000"/>
+              </a:lnSpc>
+              <a:spcBef>
+                <a:spcPts val="0"/>
+              </a:spcBef>
+              <a:spcAft>
+                <a:spcPts val="0"/>
+              </a:spcAft>
+            </a:pPr>
+            <a:r>
+              <a:rPr sz="900" b="0" i="0">
+                <a:solidFill>
+                  <a:srgbClr val="6A7177"/>
+                </a:solidFill>
+                <a:latin typeface="Calibri"/>
+              </a:rPr>
+              <a:t>documents live</a:t>
+            </a:r>
+          </a:p>
+        </p:txBody>
+      </p:sp>
+      <p:sp>
+        <p:nvSpPr>
+          <p:cNvPr id="41" name="Rectangle 40"/>
+          <p:cNvSpPr/>
+          <p:nvPr/>
+        </p:nvSpPr>
+        <p:spPr>
+          <a:xfrm>
+            <a:off x="685800" y="5340096"/>
+            <a:ext cx="10820095" cy="10160"/>
+          </a:xfrm>
+          <a:prstGeom prst="rect">
+            <a:avLst/>
+          </a:prstGeom>
+          <a:solidFill>
+            <a:srgbClr val="E2E3E5"/>
+          </a:solidFill>
+          <a:ln>
+            <a:noFill/>
+          </a:ln>
+          <a:effectLst/>
+        </p:spPr>
+        <p:style>
+          <a:lnRef idx="1">
+            <a:schemeClr val="accent1"/>
+          </a:lnRef>
+          <a:fillRef idx="3">
+            <a:schemeClr val="accent1"/>
+          </a:fillRef>
+          <a:effectRef idx="2">
+            <a:schemeClr val="accent1"/>
+          </a:effectRef>
+          <a:fontRef idx="minor">
+            <a:schemeClr val="lt1"/>
+          </a:fontRef>
+        </p:style>
+        <p:txBody>
+          <a:bodyPr rtlCol="0" anchor="ctr"/>
+          <a:lstStyle/>
+          <a:p>
+            <a:pPr algn="ctr"/>
+          </a:p>
+        </p:txBody>
+      </p:sp>
+      <p:sp>
+        <p:nvSpPr>
+          <p:cNvPr id="42" name="Rounded Rectangle 41"/>
+          <p:cNvSpPr/>
+          <p:nvPr/>
+        </p:nvSpPr>
+        <p:spPr>
+          <a:xfrm>
+            <a:off x="685800" y="5550408"/>
+            <a:ext cx="493776" cy="493776"/>
+          </a:xfrm>
+          <a:prstGeom prst="roundRect">
             <a:avLst/>
           </a:prstGeom>
           <a:solidFill>
@@ -16225,14 +17645,59 @@
       </p:sp>
       <p:sp>
         <p:nvSpPr>
-          <p:cNvPr id="15" name="TextBox 14"/>
+          <p:cNvPr id="43" name="TextBox 42"/>
           <p:cNvSpPr txBox="1"/>
           <p:nvPr/>
         </p:nvSpPr>
         <p:spPr>
           <a:xfrm>
-            <a:off x="905256" y="2852928"/>
-            <a:ext cx="2984906" cy="1581912"/>
+            <a:off x="685800" y="5550408"/>
+            <a:ext cx="493776" cy="493776"/>
+          </a:xfrm>
+          <a:prstGeom prst="rect">
+            <a:avLst/>
+          </a:prstGeom>
+          <a:noFill/>
+        </p:spPr>
+        <p:txBody>
+          <a:bodyPr wrap="square" anchor="ctr" lIns="0" rIns="0" tIns="0" bIns="0">
+            <a:spAutoFit/>
+          </a:bodyPr>
+          <a:lstStyle/>
+          <a:p>
+            <a:pPr algn="ctr">
+              <a:lnSpc>
+                <a:spcPct val="106000"/>
+              </a:lnSpc>
+              <a:spcBef>
+                <a:spcPts val="0"/>
+              </a:spcBef>
+              <a:spcAft>
+                <a:spcPts val="0"/>
+              </a:spcAft>
+            </a:pPr>
+            <a:r>
+              <a:rPr sz="1600" b="1" i="0">
+                <a:solidFill>
+                  <a:srgbClr val="FFFFFF"/>
+                </a:solidFill>
+                <a:latin typeface="Calibri"/>
+              </a:rPr>
+              <a:t>05</a:t>
+            </a:r>
+          </a:p>
+        </p:txBody>
+      </p:sp>
+      <p:sp>
+        <p:nvSpPr>
+          <p:cNvPr id="44" name="TextBox 43"/>
+          <p:cNvSpPr txBox="1"/>
+          <p:nvPr/>
+        </p:nvSpPr>
+        <p:spPr>
+          <a:xfrm>
+            <a:off x="1325880" y="5404104"/>
+            <a:ext cx="8074152" cy="256032"/>
           </a:xfrm>
           <a:prstGeom prst="rect">
             <a:avLst/>
@@ -16247,70 +17712,136 @@
           <a:p>
             <a:pPr algn="l">
               <a:lnSpc>
-                <a:spcPct val="109000"/>
-              </a:lnSpc>
-              <a:spcBef>
-                <a:spcPts val="0"/>
-              </a:spcBef>
-              <a:spcAft>
-                <a:spcPts val="500"/>
-              </a:spcAft>
-            </a:pPr>
-            <a:r>
-              <a:rPr sz="1450" b="1" i="0">
+                <a:spcPct val="106000"/>
+              </a:lnSpc>
+              <a:spcBef>
+                <a:spcPts val="0"/>
+              </a:spcBef>
+              <a:spcAft>
+                <a:spcPts val="0"/>
+              </a:spcAft>
+            </a:pPr>
+            <a:r>
+              <a:rPr sz="1350" b="1" i="0">
                 <a:solidFill>
                   <a:srgbClr val="24282C"/>
                 </a:solidFill>
                 <a:latin typeface="Calibri"/>
               </a:rPr>
-              <a:t>The problem</a:t>
-            </a:r>
-          </a:p>
+              <a:t>Cost &amp; benefit analysis</a:t>
+            </a:r>
+          </a:p>
+        </p:txBody>
+      </p:sp>
+      <p:sp>
+        <p:nvSpPr>
+          <p:cNvPr id="45" name="TextBox 44"/>
+          <p:cNvSpPr txBox="1"/>
+          <p:nvPr/>
+        </p:nvSpPr>
+        <p:spPr>
+          <a:xfrm>
+            <a:off x="1325880" y="5660136"/>
+            <a:ext cx="8074152" cy="566928"/>
+          </a:xfrm>
+          <a:prstGeom prst="rect">
+            <a:avLst/>
+          </a:prstGeom>
+          <a:noFill/>
+        </p:spPr>
+        <p:txBody>
+          <a:bodyPr wrap="square" anchor="t" lIns="0" rIns="0" tIns="0" bIns="0">
+            <a:spAutoFit/>
+          </a:bodyPr>
+          <a:lstStyle/>
           <a:p>
             <a:pPr algn="l">
               <a:lnSpc>
-                <a:spcPct val="109000"/>
-              </a:lnSpc>
-              <a:spcBef>
-                <a:spcPts val="0"/>
-              </a:spcBef>
-              <a:spcAft>
-                <a:spcPts val="500"/>
-              </a:spcAft>
-            </a:pPr>
-            <a:r>
-              <a:rPr sz="1200" b="0" i="0">
-                <a:solidFill>
-                  <a:srgbClr val="6A7177"/>
-                </a:solidFill>
-                <a:latin typeface="Calibri"/>
-              </a:rPr>
-              <a:t>Product and promo details sit across many portals and PDFs and change often. Looking them up is slow, and a wrong or expired answer is a compliance and trust risk.</a:t>
-            </a:r>
-          </a:p>
-        </p:txBody>
-      </p:sp>
-      <p:sp>
-        <p:nvSpPr>
-          <p:cNvPr id="16" name="Rectangle 15"/>
+                <a:spcPct val="112000"/>
+              </a:lnSpc>
+              <a:spcBef>
+                <a:spcPts val="0"/>
+              </a:spcBef>
+              <a:spcAft>
+                <a:spcPts val="0"/>
+              </a:spcAft>
+            </a:pPr>
+            <a:r>
+              <a:rPr sz="1100" b="0" i="0">
+                <a:solidFill>
+                  <a:srgbClr val="4C5359"/>
+                </a:solidFill>
+                <a:latin typeface="Calibri"/>
+              </a:rPr>
+              <a:t>A lean design keeps costs low across </a:t>
+            </a:r>
+            <a:r>
+              <a:rPr sz="1100" b="1" i="0">
+                <a:solidFill>
+                  <a:srgbClr val="24282C"/>
+                </a:solidFill>
+                <a:latin typeface="Calibri"/>
+              </a:rPr>
+              <a:t>CAPEX</a:t>
+            </a:r>
+            <a:r>
+              <a:rPr sz="1100" b="0" i="0">
+                <a:solidFill>
+                  <a:srgbClr val="4C5359"/>
+                </a:solidFill>
+                <a:latin typeface="Calibri"/>
+              </a:rPr>
+              <a:t> (build, integration, content set-up) and </a:t>
+            </a:r>
+            <a:r>
+              <a:rPr sz="1100" b="1" i="0">
+                <a:solidFill>
+                  <a:srgbClr val="24282C"/>
+                </a:solidFill>
+                <a:latin typeface="Calibri"/>
+              </a:rPr>
+              <a:t>OPEX</a:t>
+            </a:r>
+            <a:r>
+              <a:rPr sz="1100" b="0" i="0">
+                <a:solidFill>
+                  <a:srgbClr val="4C5359"/>
+                </a:solidFill>
+                <a:latin typeface="Calibri"/>
+              </a:rPr>
+              <a:t> (AI usage, hosting, maintenance). Benefits are MECE across efficiency (frontliner-hours reclaimed), revenue (higher first-contact resolution and cross-sell) and risk mitigation (fewer errors, secrets never exposed), for a </a:t>
+            </a:r>
+            <a:r>
+              <a:rPr sz="1100" b="1" i="0">
+                <a:solidFill>
+                  <a:srgbClr val="24282C"/>
+                </a:solidFill>
+                <a:latin typeface="Calibri"/>
+              </a:rPr>
+              <a:t>fast projected payback.</a:t>
+            </a:r>
+          </a:p>
+        </p:txBody>
+      </p:sp>
+      <p:sp>
+        <p:nvSpPr>
+          <p:cNvPr id="46" name="Rectangle 45"/>
           <p:cNvSpPr/>
           <p:nvPr/>
         </p:nvSpPr>
         <p:spPr>
           <a:xfrm>
-            <a:off x="4383938" y="2670048"/>
-            <a:ext cx="3423818" cy="1901952"/>
+            <a:off x="9454896" y="5486400"/>
+            <a:ext cx="12700" cy="640080"/>
           </a:xfrm>
           <a:prstGeom prst="rect">
             <a:avLst/>
           </a:prstGeom>
           <a:solidFill>
-            <a:srgbClr val="F7F7F8"/>
+            <a:srgbClr val="E2E3E5"/>
           </a:solidFill>
-          <a:ln w="12700">
-            <a:solidFill>
-              <a:srgbClr val="E2E3E5"/>
-            </a:solidFill>
+          <a:ln>
+            <a:noFill/>
           </a:ln>
           <a:effectLst/>
         </p:spPr>
@@ -16338,58 +17869,14 @@
       </p:sp>
       <p:sp>
         <p:nvSpPr>
-          <p:cNvPr id="17" name="Rectangle 16"/>
-          <p:cNvSpPr/>
-          <p:nvPr/>
-        </p:nvSpPr>
-        <p:spPr>
-          <a:xfrm>
-            <a:off x="4383938" y="2670048"/>
-            <a:ext cx="3423818" cy="77724"/>
-          </a:xfrm>
-          <a:prstGeom prst="rect">
-            <a:avLst/>
-          </a:prstGeom>
-          <a:solidFill>
-            <a:srgbClr val="4E6B84"/>
-          </a:solidFill>
-          <a:ln>
-            <a:noFill/>
-          </a:ln>
-          <a:effectLst/>
-        </p:spPr>
-        <p:style>
-          <a:lnRef idx="1">
-            <a:schemeClr val="accent1"/>
-          </a:lnRef>
-          <a:fillRef idx="3">
-            <a:schemeClr val="accent1"/>
-          </a:fillRef>
-          <a:effectRef idx="2">
-            <a:schemeClr val="accent1"/>
-          </a:effectRef>
-          <a:fontRef idx="minor">
-            <a:schemeClr val="lt1"/>
-          </a:fontRef>
-        </p:style>
-        <p:txBody>
-          <a:bodyPr rtlCol="0" anchor="ctr"/>
-          <a:lstStyle/>
-          <a:p>
-            <a:pPr algn="ctr"/>
-          </a:p>
-        </p:txBody>
-      </p:sp>
-      <p:sp>
-        <p:nvSpPr>
-          <p:cNvPr id="18" name="TextBox 17"/>
+          <p:cNvPr id="47" name="TextBox 46"/>
           <p:cNvSpPr txBox="1"/>
           <p:nvPr/>
         </p:nvSpPr>
         <p:spPr>
           <a:xfrm>
-            <a:off x="4603394" y="2852928"/>
-            <a:ext cx="2984906" cy="1581912"/>
+            <a:off x="9582912" y="5559552"/>
+            <a:ext cx="2105863" cy="384048"/>
           </a:xfrm>
           <a:prstGeom prst="rect">
             <a:avLst/>
@@ -16402,151 +17889,39 @@
           </a:bodyPr>
           <a:lstStyle/>
           <a:p>
-            <a:pPr algn="l">
-              <a:lnSpc>
-                <a:spcPct val="109000"/>
-              </a:lnSpc>
-              <a:spcBef>
-                <a:spcPts val="0"/>
-              </a:spcBef>
-              <a:spcAft>
-                <a:spcPts val="500"/>
-              </a:spcAft>
-            </a:pPr>
-            <a:r>
-              <a:rPr sz="1450" b="1" i="0">
+            <a:pPr algn="ctr">
+              <a:lnSpc>
+                <a:spcPct val="106000"/>
+              </a:lnSpc>
+              <a:spcBef>
+                <a:spcPts val="0"/>
+              </a:spcBef>
+              <a:spcAft>
+                <a:spcPts val="0"/>
+              </a:spcAft>
+            </a:pPr>
+            <a:r>
+              <a:rPr sz="1900" b="1" i="0">
                 <a:solidFill>
                   <a:srgbClr val="24282C"/>
                 </a:solidFill>
                 <a:latin typeface="Calibri"/>
               </a:rPr>
-              <a:t>The solution</a:t>
-            </a:r>
-          </a:p>
-          <a:p>
-            <a:pPr algn="l">
-              <a:lnSpc>
-                <a:spcPct val="109000"/>
-              </a:lnSpc>
-              <a:spcBef>
-                <a:spcPts val="0"/>
-              </a:spcBef>
-              <a:spcAft>
-                <a:spcPts val="500"/>
-              </a:spcAft>
-            </a:pPr>
-            <a:r>
-              <a:rPr sz="1200" b="0" i="0">
-                <a:solidFill>
-                  <a:srgbClr val="6A7177"/>
-                </a:solidFill>
-                <a:latin typeface="Calibri"/>
-              </a:rPr>
-              <a:t>One secure assistant answers only from approved bank content and shows the source for every answer. Expired offers are flagged. It works in Bahasa Indonesia and English.</a:t>
-            </a:r>
-          </a:p>
-        </p:txBody>
-      </p:sp>
-      <p:sp>
-        <p:nvSpPr>
-          <p:cNvPr id="19" name="Rectangle 18"/>
-          <p:cNvSpPr/>
-          <p:nvPr/>
-        </p:nvSpPr>
-        <p:spPr>
-          <a:xfrm>
-            <a:off x="8082076" y="2670048"/>
-            <a:ext cx="3423818" cy="1901952"/>
-          </a:xfrm>
-          <a:prstGeom prst="rect">
-            <a:avLst/>
-          </a:prstGeom>
-          <a:solidFill>
-            <a:srgbClr val="F7F7F8"/>
-          </a:solidFill>
-          <a:ln w="12700">
-            <a:solidFill>
-              <a:srgbClr val="E2E3E5"/>
-            </a:solidFill>
-          </a:ln>
-          <a:effectLst/>
-        </p:spPr>
-        <p:style>
-          <a:lnRef idx="1">
-            <a:schemeClr val="accent1"/>
-          </a:lnRef>
-          <a:fillRef idx="3">
-            <a:schemeClr val="accent1"/>
-          </a:fillRef>
-          <a:effectRef idx="2">
-            <a:schemeClr val="accent1"/>
-          </a:effectRef>
-          <a:fontRef idx="minor">
-            <a:schemeClr val="lt1"/>
-          </a:fontRef>
-        </p:style>
-        <p:txBody>
-          <a:bodyPr rtlCol="0" anchor="ctr"/>
-          <a:lstStyle/>
-          <a:p>
-            <a:pPr algn="ctr"/>
-          </a:p>
-        </p:txBody>
-      </p:sp>
-      <p:sp>
-        <p:nvSpPr>
-          <p:cNvPr id="20" name="Rectangle 19"/>
-          <p:cNvSpPr/>
-          <p:nvPr/>
-        </p:nvSpPr>
-        <p:spPr>
-          <a:xfrm>
-            <a:off x="8082076" y="2670048"/>
-            <a:ext cx="3423818" cy="77724"/>
-          </a:xfrm>
-          <a:prstGeom prst="rect">
-            <a:avLst/>
-          </a:prstGeom>
-          <a:solidFill>
-            <a:srgbClr val="E4002B"/>
-          </a:solidFill>
-          <a:ln>
-            <a:noFill/>
-          </a:ln>
-          <a:effectLst/>
-        </p:spPr>
-        <p:style>
-          <a:lnRef idx="1">
-            <a:schemeClr val="accent1"/>
-          </a:lnRef>
-          <a:fillRef idx="3">
-            <a:schemeClr val="accent1"/>
-          </a:fillRef>
-          <a:effectRef idx="2">
-            <a:schemeClr val="accent1"/>
-          </a:effectRef>
-          <a:fontRef idx="minor">
-            <a:schemeClr val="lt1"/>
-          </a:fontRef>
-        </p:style>
-        <p:txBody>
-          <a:bodyPr rtlCol="0" anchor="ctr"/>
-          <a:lstStyle/>
-          <a:p>
-            <a:pPr algn="ctr"/>
-          </a:p>
-        </p:txBody>
-      </p:sp>
-      <p:sp>
-        <p:nvSpPr>
-          <p:cNvPr id="21" name="TextBox 20"/>
+              <a:t>Fast</a:t>
+            </a:r>
+          </a:p>
+        </p:txBody>
+      </p:sp>
+      <p:sp>
+        <p:nvSpPr>
+          <p:cNvPr id="48" name="TextBox 47"/>
           <p:cNvSpPr txBox="1"/>
           <p:nvPr/>
         </p:nvSpPr>
         <p:spPr>
           <a:xfrm>
-            <a:off x="8301532" y="2852928"/>
-            <a:ext cx="2984906" cy="1581912"/>
+            <a:off x="9582912" y="5943600"/>
+            <a:ext cx="2105863" cy="237744"/>
           </a:xfrm>
           <a:prstGeom prst="rect">
             <a:avLst/>
@@ -16559,452 +17934,25 @@
           </a:bodyPr>
           <a:lstStyle/>
           <a:p>
-            <a:pPr algn="l">
-              <a:lnSpc>
-                <a:spcPct val="109000"/>
-              </a:lnSpc>
-              <a:spcBef>
-                <a:spcPts val="0"/>
-              </a:spcBef>
-              <a:spcAft>
-                <a:spcPts val="500"/>
-              </a:spcAft>
-            </a:pPr>
-            <a:r>
-              <a:rPr sz="1450" b="1" i="0">
-                <a:solidFill>
-                  <a:srgbClr val="24282C"/>
-                </a:solidFill>
-                <a:latin typeface="Calibri"/>
-              </a:rPr>
-              <a:t>The prize</a:t>
-            </a:r>
-          </a:p>
-          <a:p>
-            <a:pPr algn="l">
-              <a:lnSpc>
-                <a:spcPct val="109000"/>
-              </a:lnSpc>
-              <a:spcBef>
-                <a:spcPts val="0"/>
-              </a:spcBef>
-              <a:spcAft>
-                <a:spcPts val="500"/>
-              </a:spcAft>
-            </a:pPr>
-            <a:r>
-              <a:rPr sz="1200" b="0" i="0">
+            <a:pPr algn="ctr">
+              <a:lnSpc>
+                <a:spcPct val="106000"/>
+              </a:lnSpc>
+              <a:spcBef>
+                <a:spcPts val="0"/>
+              </a:spcBef>
+              <a:spcAft>
+                <a:spcPts val="0"/>
+              </a:spcAft>
+            </a:pPr>
+            <a:r>
+              <a:rPr sz="900" b="0" i="0">
                 <a:solidFill>
                   <a:srgbClr val="6A7177"/>
                 </a:solidFill>
                 <a:latin typeface="Calibri"/>
               </a:rPr>
-              <a:t>Faster service, higher first-contact resolution, fewer errors, and new cross-sell moments, all at a low running cost.</a:t>
-            </a:r>
-          </a:p>
-        </p:txBody>
-      </p:sp>
-      <p:sp>
-        <p:nvSpPr>
-          <p:cNvPr id="22" name="TextBox 21"/>
-          <p:cNvSpPr txBox="1"/>
-          <p:nvPr/>
-        </p:nvSpPr>
-        <p:spPr>
-          <a:xfrm>
-            <a:off x="685800" y="4700016"/>
-            <a:ext cx="10820095" cy="274320"/>
-          </a:xfrm>
-          <a:prstGeom prst="rect">
-            <a:avLst/>
-          </a:prstGeom>
-          <a:noFill/>
-        </p:spPr>
-        <p:txBody>
-          <a:bodyPr wrap="square" anchor="t" lIns="0" rIns="0" tIns="0" bIns="0">
-            <a:spAutoFit/>
-          </a:bodyPr>
-          <a:lstStyle/>
-          <a:p>
-            <a:pPr algn="l">
-              <a:lnSpc>
-                <a:spcPct val="106000"/>
-              </a:lnSpc>
-              <a:spcBef>
-                <a:spcPts val="0"/>
-              </a:spcBef>
-              <a:spcAft>
-                <a:spcPts val="0"/>
-              </a:spcAft>
-            </a:pPr>
-            <a:r>
-              <a:rPr sz="1200" b="1" i="0">
-                <a:solidFill>
-                  <a:srgbClr val="4C5359"/>
-                </a:solidFill>
-                <a:latin typeface="Calibri"/>
-              </a:rPr>
-              <a:t>Impact snapshot · projected from the cost-benefit case, with live proof in gold</a:t>
-            </a:r>
-          </a:p>
-        </p:txBody>
-      </p:sp>
-      <p:sp>
-        <p:nvSpPr>
-          <p:cNvPr id="23" name="TextBox 22"/>
-          <p:cNvSpPr txBox="1"/>
-          <p:nvPr/>
-        </p:nvSpPr>
-        <p:spPr>
-          <a:xfrm>
-            <a:off x="685800" y="5047488"/>
-            <a:ext cx="2499283" cy="640080"/>
-          </a:xfrm>
-          <a:prstGeom prst="rect">
-            <a:avLst/>
-          </a:prstGeom>
-          <a:noFill/>
-        </p:spPr>
-        <p:txBody>
-          <a:bodyPr wrap="square" anchor="t" lIns="0" rIns="0" tIns="0" bIns="0">
-            <a:spAutoFit/>
-          </a:bodyPr>
-          <a:lstStyle/>
-          <a:p>
-            <a:pPr algn="ctr">
-              <a:lnSpc>
-                <a:spcPct val="106000"/>
-              </a:lnSpc>
-              <a:spcBef>
-                <a:spcPts val="0"/>
-              </a:spcBef>
-              <a:spcAft>
-                <a:spcPts val="0"/>
-              </a:spcAft>
-            </a:pPr>
-            <a:r>
-              <a:rPr sz="3000" b="1" i="0">
-                <a:solidFill>
-                  <a:srgbClr val="4E6B84"/>
-                </a:solidFill>
-                <a:latin typeface="Calibri"/>
-              </a:rPr>
-              <a:t>~5 sec</a:t>
-            </a:r>
-          </a:p>
-        </p:txBody>
-      </p:sp>
-      <p:sp>
-        <p:nvSpPr>
-          <p:cNvPr id="24" name="TextBox 23"/>
-          <p:cNvSpPr txBox="1"/>
-          <p:nvPr/>
-        </p:nvSpPr>
-        <p:spPr>
-          <a:xfrm>
-            <a:off x="685800" y="5614416"/>
-            <a:ext cx="2499283" cy="457200"/>
-          </a:xfrm>
-          <a:prstGeom prst="rect">
-            <a:avLst/>
-          </a:prstGeom>
-          <a:noFill/>
-        </p:spPr>
-        <p:txBody>
-          <a:bodyPr wrap="square" anchor="t" lIns="0" rIns="0" tIns="0" bIns="0">
-            <a:spAutoFit/>
-          </a:bodyPr>
-          <a:lstStyle/>
-          <a:p>
-            <a:pPr algn="ctr">
-              <a:lnSpc>
-                <a:spcPct val="106000"/>
-              </a:lnSpc>
-              <a:spcBef>
-                <a:spcPts val="0"/>
-              </a:spcBef>
-              <a:spcAft>
-                <a:spcPts val="0"/>
-              </a:spcAft>
-            </a:pPr>
-            <a:r>
-              <a:rPr sz="1250" b="1" i="0">
-                <a:solidFill>
-                  <a:srgbClr val="4C5359"/>
-                </a:solidFill>
-                <a:latin typeface="Calibri"/>
-              </a:rPr>
-              <a:t>answer per query, vs up to 493 min today</a:t>
-            </a:r>
-          </a:p>
-        </p:txBody>
-      </p:sp>
-      <p:sp>
-        <p:nvSpPr>
-          <p:cNvPr id="25" name="TextBox 24"/>
-          <p:cNvSpPr txBox="1"/>
-          <p:nvPr/>
-        </p:nvSpPr>
-        <p:spPr>
-          <a:xfrm>
-            <a:off x="3459403" y="5047488"/>
-            <a:ext cx="2499283" cy="640080"/>
-          </a:xfrm>
-          <a:prstGeom prst="rect">
-            <a:avLst/>
-          </a:prstGeom>
-          <a:noFill/>
-        </p:spPr>
-        <p:txBody>
-          <a:bodyPr wrap="square" anchor="t" lIns="0" rIns="0" tIns="0" bIns="0">
-            <a:spAutoFit/>
-          </a:bodyPr>
-          <a:lstStyle/>
-          <a:p>
-            <a:pPr algn="ctr">
-              <a:lnSpc>
-                <a:spcPct val="106000"/>
-              </a:lnSpc>
-              <a:spcBef>
-                <a:spcPts val="0"/>
-              </a:spcBef>
-              <a:spcAft>
-                <a:spcPts val="0"/>
-              </a:spcAft>
-            </a:pPr>
-            <a:r>
-              <a:rPr sz="3000" b="1" i="0">
-                <a:solidFill>
-                  <a:srgbClr val="E4002B"/>
-                </a:solidFill>
-                <a:latin typeface="Calibri"/>
-              </a:rPr>
-              <a:t>&lt; 3 mo</a:t>
-            </a:r>
-          </a:p>
-        </p:txBody>
-      </p:sp>
-      <p:sp>
-        <p:nvSpPr>
-          <p:cNvPr id="26" name="TextBox 25"/>
-          <p:cNvSpPr txBox="1"/>
-          <p:nvPr/>
-        </p:nvSpPr>
-        <p:spPr>
-          <a:xfrm>
-            <a:off x="3459403" y="5614416"/>
-            <a:ext cx="2499283" cy="457200"/>
-          </a:xfrm>
-          <a:prstGeom prst="rect">
-            <a:avLst/>
-          </a:prstGeom>
-          <a:noFill/>
-        </p:spPr>
-        <p:txBody>
-          <a:bodyPr wrap="square" anchor="t" lIns="0" rIns="0" tIns="0" bIns="0">
-            <a:spAutoFit/>
-          </a:bodyPr>
-          <a:lstStyle/>
-          <a:p>
-            <a:pPr algn="ctr">
-              <a:lnSpc>
-                <a:spcPct val="106000"/>
-              </a:lnSpc>
-              <a:spcBef>
-                <a:spcPts val="0"/>
-              </a:spcBef>
-              <a:spcAft>
-                <a:spcPts val="0"/>
-              </a:spcAft>
-            </a:pPr>
-            <a:r>
-              <a:rPr sz="1250" b="1" i="0">
-                <a:solidFill>
-                  <a:srgbClr val="4C5359"/>
-                </a:solidFill>
-                <a:latin typeface="Calibri"/>
-              </a:rPr>
-              <a:t>projected payback on ~Rp 206 Mio a year</a:t>
-            </a:r>
-          </a:p>
-        </p:txBody>
-      </p:sp>
-      <p:sp>
-        <p:nvSpPr>
-          <p:cNvPr id="27" name="TextBox 26"/>
-          <p:cNvSpPr txBox="1"/>
-          <p:nvPr/>
-        </p:nvSpPr>
-        <p:spPr>
-          <a:xfrm>
-            <a:off x="6233006" y="5047488"/>
-            <a:ext cx="2499283" cy="640080"/>
-          </a:xfrm>
-          <a:prstGeom prst="rect">
-            <a:avLst/>
-          </a:prstGeom>
-          <a:noFill/>
-        </p:spPr>
-        <p:txBody>
-          <a:bodyPr wrap="square" anchor="t" lIns="0" rIns="0" tIns="0" bIns="0">
-            <a:spAutoFit/>
-          </a:bodyPr>
-          <a:lstStyle/>
-          <a:p>
-            <a:pPr algn="ctr">
-              <a:lnSpc>
-                <a:spcPct val="106000"/>
-              </a:lnSpc>
-              <a:spcBef>
-                <a:spcPts val="0"/>
-              </a:spcBef>
-              <a:spcAft>
-                <a:spcPts val="0"/>
-              </a:spcAft>
-            </a:pPr>
-            <a:r>
-              <a:rPr sz="2600" b="1" i="0">
-                <a:solidFill>
-                  <a:srgbClr val="B0812C"/>
-                </a:solidFill>
-                <a:latin typeface="Calibri"/>
-              </a:rPr>
-              <a:t>~Rp 4.1 Bn</a:t>
-            </a:r>
-          </a:p>
-        </p:txBody>
-      </p:sp>
-      <p:sp>
-        <p:nvSpPr>
-          <p:cNvPr id="28" name="TextBox 27"/>
-          <p:cNvSpPr txBox="1"/>
-          <p:nvPr/>
-        </p:nvSpPr>
-        <p:spPr>
-          <a:xfrm>
-            <a:off x="6233006" y="5614416"/>
-            <a:ext cx="2499283" cy="457200"/>
-          </a:xfrm>
-          <a:prstGeom prst="rect">
-            <a:avLst/>
-          </a:prstGeom>
-          <a:noFill/>
-        </p:spPr>
-        <p:txBody>
-          <a:bodyPr wrap="square" anchor="t" lIns="0" rIns="0" tIns="0" bIns="0">
-            <a:spAutoFit/>
-          </a:bodyPr>
-          <a:lstStyle/>
-          <a:p>
-            <a:pPr algn="ctr">
-              <a:lnSpc>
-                <a:spcPct val="106000"/>
-              </a:lnSpc>
-              <a:spcBef>
-                <a:spcPts val="0"/>
-              </a:spcBef>
-              <a:spcAft>
-                <a:spcPts val="0"/>
-              </a:spcAft>
-            </a:pPr>
-            <a:r>
-              <a:rPr sz="1250" b="1" i="0">
-                <a:solidFill>
-                  <a:srgbClr val="4C5359"/>
-                </a:solidFill>
-                <a:latin typeface="Calibri"/>
-              </a:rPr>
-              <a:t>estimated Year-1 net benefit</a:t>
-            </a:r>
-          </a:p>
-        </p:txBody>
-      </p:sp>
-      <p:sp>
-        <p:nvSpPr>
-          <p:cNvPr id="29" name="TextBox 28"/>
-          <p:cNvSpPr txBox="1"/>
-          <p:nvPr/>
-        </p:nvSpPr>
-        <p:spPr>
-          <a:xfrm>
-            <a:off x="9006609" y="5047488"/>
-            <a:ext cx="2499283" cy="640080"/>
-          </a:xfrm>
-          <a:prstGeom prst="rect">
-            <a:avLst/>
-          </a:prstGeom>
-          <a:noFill/>
-        </p:spPr>
-        <p:txBody>
-          <a:bodyPr wrap="square" anchor="t" lIns="0" rIns="0" tIns="0" bIns="0">
-            <a:spAutoFit/>
-          </a:bodyPr>
-          <a:lstStyle/>
-          <a:p>
-            <a:pPr algn="ctr">
-              <a:lnSpc>
-                <a:spcPct val="106000"/>
-              </a:lnSpc>
-              <a:spcBef>
-                <a:spcPts val="0"/>
-              </a:spcBef>
-              <a:spcAft>
-                <a:spcPts val="0"/>
-              </a:spcAft>
-            </a:pPr>
-            <a:r>
-              <a:rPr sz="3000" b="1" i="0">
-                <a:solidFill>
-                  <a:srgbClr val="B0812C"/>
-                </a:solidFill>
-                <a:latin typeface="Calibri"/>
-              </a:rPr>
-              <a:t>326</a:t>
-            </a:r>
-          </a:p>
-        </p:txBody>
-      </p:sp>
-      <p:sp>
-        <p:nvSpPr>
-          <p:cNvPr id="30" name="TextBox 29"/>
-          <p:cNvSpPr txBox="1"/>
-          <p:nvPr/>
-        </p:nvSpPr>
-        <p:spPr>
-          <a:xfrm>
-            <a:off x="9006609" y="5614416"/>
-            <a:ext cx="2499283" cy="457200"/>
-          </a:xfrm>
-          <a:prstGeom prst="rect">
-            <a:avLst/>
-          </a:prstGeom>
-          <a:noFill/>
-        </p:spPr>
-        <p:txBody>
-          <a:bodyPr wrap="square" anchor="t" lIns="0" rIns="0" tIns="0" bIns="0">
-            <a:spAutoFit/>
-          </a:bodyPr>
-          <a:lstStyle/>
-          <a:p>
-            <a:pPr algn="ctr">
-              <a:lnSpc>
-                <a:spcPct val="106000"/>
-              </a:lnSpc>
-              <a:spcBef>
-                <a:spcPts val="0"/>
-              </a:spcBef>
-              <a:spcAft>
-                <a:spcPts val="0"/>
-              </a:spcAft>
-            </a:pPr>
-            <a:r>
-              <a:rPr sz="1250" b="1" i="0">
-                <a:solidFill>
-                  <a:srgbClr val="4C5359"/>
-                </a:solidFill>
-                <a:latin typeface="Calibri"/>
-              </a:rPr>
-              <a:t>products &amp; promos live · 51 categories</a:t>
+              <a:t>projected payback</a:t>
             </a:r>
           </a:p>
         </p:txBody>

</xml_diff>